<commit_message>
Updating Diagram to match
</commit_message>
<xml_diff>
--- a/Project and Tool Layout.pptx
+++ b/Project and Tool Layout.pptx
@@ -4164,11 +4164,6 @@
               <a:rPr lang="en-US" dirty="0"/>
               <a:t>DB Schemas</a:t>
             </a:r>
-            <a:r>
-              <a:rPr lang="en-US" sz="1100" dirty="0"/>
-              <a:t>*</a:t>
-            </a:r>
-            <a:endParaRPr lang="en-US" dirty="0"/>
           </a:p>
           <a:p>
             <a:pPr algn="ctr"/>
@@ -5456,62 +5451,6 @@
             <a:r>
               <a:rPr lang="en-US" sz="700" dirty="0"/>
               <a:t>DML = data manip. language</a:t>
-            </a:r>
-          </a:p>
-        </p:txBody>
-      </p:sp>
-      <p:sp>
-        <p:nvSpPr>
-          <p:cNvPr id="154" name="Rectangle 153">
-            <a:extLst>
-              <a:ext uri="{FF2B5EF4-FFF2-40B4-BE49-F238E27FC236}">
-                <a16:creationId xmlns:a16="http://schemas.microsoft.com/office/drawing/2014/main" id="{476FAA6E-532E-811B-061E-21BC7C89326A}"/>
-              </a:ext>
-            </a:extLst>
-          </p:cNvPr>
-          <p:cNvSpPr/>
-          <p:nvPr/>
-        </p:nvSpPr>
-        <p:spPr>
-          <a:xfrm>
-            <a:off x="241235" y="6465515"/>
-            <a:ext cx="5345841" cy="249337"/>
-          </a:xfrm>
-          <a:prstGeom prst="rect">
-            <a:avLst/>
-          </a:prstGeom>
-          <a:solidFill>
-            <a:schemeClr val="bg1"/>
-          </a:solidFill>
-          <a:ln w="6350" cap="rnd"/>
-        </p:spPr>
-        <p:style>
-          <a:lnRef idx="2">
-            <a:schemeClr val="accent1">
-              <a:shade val="15000"/>
-            </a:schemeClr>
-          </a:lnRef>
-          <a:fillRef idx="1">
-            <a:schemeClr val="accent1"/>
-          </a:fillRef>
-          <a:effectRef idx="0">
-            <a:schemeClr val="accent1"/>
-          </a:effectRef>
-          <a:fontRef idx="minor">
-            <a:schemeClr val="lt1"/>
-          </a:fontRef>
-        </p:style>
-        <p:txBody>
-          <a:bodyPr lIns="91440" tIns="0" rIns="0" bIns="0" rtlCol="0" anchor="ctr"/>
-          <a:lstStyle/>
-          <a:p>
-            <a:r>
-              <a:rPr lang="en-US" sz="800" dirty="0">
-                <a:solidFill>
-                  <a:schemeClr val="tx1"/>
-                </a:solidFill>
-              </a:rPr>
-              <a:t>* Schemas in common parlance refers actually to the DB Models created for SQLAlchemy, but Pydantic uses it to refer to these Data Transfer Objects which define the interface boundary for the underlying DB Models</a:t>
             </a:r>
           </a:p>
         </p:txBody>
@@ -5995,7 +5934,7 @@
         </p:nvSpPr>
         <p:spPr>
           <a:xfrm>
-            <a:off x="8594372" y="2371990"/>
+            <a:off x="8594372" y="1985364"/>
             <a:ext cx="993676" cy="740680"/>
           </a:xfrm>
           <a:prstGeom prst="rect">
@@ -6056,7 +5995,7 @@
         </p:nvGrpSpPr>
         <p:grpSpPr>
           <a:xfrm>
-            <a:off x="8757367" y="2624410"/>
+            <a:off x="8757367" y="2237784"/>
             <a:ext cx="680794" cy="433282"/>
             <a:chOff x="8227377" y="3019807"/>
             <a:chExt cx="680794" cy="785917"/>
@@ -6232,7 +6171,7 @@
         </p:nvCxnSpPr>
         <p:spPr>
           <a:xfrm>
-            <a:off x="8129643" y="2864143"/>
+            <a:off x="8129643" y="2477517"/>
             <a:ext cx="627724" cy="0"/>
           </a:xfrm>
           <a:prstGeom prst="straightConnector1">
@@ -6275,8 +6214,8 @@
         </p:nvSpPr>
         <p:spPr>
           <a:xfrm>
-            <a:off x="6874294" y="4154220"/>
-            <a:ext cx="1314542" cy="1755660"/>
+            <a:off x="6874294" y="4154219"/>
+            <a:ext cx="1314542" cy="1904457"/>
           </a:xfrm>
           <a:prstGeom prst="rect">
             <a:avLst/>
@@ -6338,7 +6277,7 @@
         <p:spPr>
           <a:xfrm>
             <a:off x="6933487" y="4604573"/>
-            <a:ext cx="1196156" cy="1112474"/>
+            <a:ext cx="1196156" cy="1391900"/>
           </a:xfrm>
           <a:prstGeom prst="rect">
             <a:avLst/>
@@ -6787,7 +6726,7 @@
         <p:spPr>
           <a:xfrm>
             <a:off x="7006259" y="5334429"/>
-            <a:ext cx="1050612" cy="304890"/>
+            <a:ext cx="1050612" cy="611196"/>
           </a:xfrm>
           <a:prstGeom prst="rect">
             <a:avLst/>
@@ -6821,8 +6760,15 @@
           <a:p>
             <a:pPr algn="ctr"/>
             <a:r>
-              <a:rPr lang="en-US" sz="900" b="1" i="1" dirty="0"/>
-              <a:t>Local LLM</a:t>
+              <a:rPr lang="en-US" sz="1200" b="1" i="1" dirty="0"/>
+              <a:t>SQL Emitter</a:t>
+            </a:r>
+          </a:p>
+          <a:p>
+            <a:pPr algn="ctr"/>
+            <a:r>
+              <a:rPr lang="en-US" sz="800" b="1" i="1" dirty="0"/>
+              <a:t>(Local LLM)</a:t>
             </a:r>
           </a:p>
           <a:p>
@@ -6852,8 +6798,8 @@
         </p:nvSpPr>
         <p:spPr>
           <a:xfrm>
-            <a:off x="8966865" y="3520030"/>
-            <a:ext cx="1947624" cy="509053"/>
+            <a:off x="9311341" y="3827859"/>
+            <a:ext cx="2215437" cy="509053"/>
           </a:xfrm>
           <a:prstGeom prst="rect">
             <a:avLst/>
@@ -6917,8 +6863,8 @@
         </p:nvSpPr>
         <p:spPr>
           <a:xfrm>
-            <a:off x="8966865" y="4547422"/>
-            <a:ext cx="1947624" cy="1106552"/>
+            <a:off x="9706330" y="573017"/>
+            <a:ext cx="1947624" cy="779483"/>
           </a:xfrm>
           <a:prstGeom prst="rect">
             <a:avLst/>
@@ -6955,21 +6901,6 @@
           </a:p>
           <a:p>
             <a:pPr algn="ctr"/>
-            <a:r>
-              <a:rPr lang="en-US" sz="1100" dirty="0"/>
-              <a:t>📚 </a:t>
-            </a:r>
-            <a:r>
-              <a:rPr lang="en-US" sz="1100" b="1" u="sng" dirty="0"/>
-              <a:t>Ollama</a:t>
-            </a:r>
-            <a:r>
-              <a:rPr lang="en-US" sz="1100" dirty="0"/>
-              <a:t>  📚 ???</a:t>
-            </a:r>
-          </a:p>
-          <a:p>
-            <a:pPr algn="ctr"/>
             <a:endParaRPr lang="en-US" sz="100" dirty="0"/>
           </a:p>
           <a:p>
@@ -6977,59 +6908,6 @@
             <a:r>
               <a:rPr lang="en-US" sz="800" dirty="0"/>
               <a:t>= Receives queries from user, determines relevant Concepts, then uses Local LLM to get the data from PostgreSQL (read-only guard)</a:t>
-            </a:r>
-          </a:p>
-        </p:txBody>
-      </p:sp>
-      <p:sp>
-        <p:nvSpPr>
-          <p:cNvPr id="93" name="Rectangle 92">
-            <a:extLst>
-              <a:ext uri="{FF2B5EF4-FFF2-40B4-BE49-F238E27FC236}">
-                <a16:creationId xmlns:a16="http://schemas.microsoft.com/office/drawing/2014/main" id="{C470D739-A7E4-B20F-87C7-38FAB125269A}"/>
-              </a:ext>
-            </a:extLst>
-          </p:cNvPr>
-          <p:cNvSpPr/>
-          <p:nvPr/>
-        </p:nvSpPr>
-        <p:spPr>
-          <a:xfrm>
-            <a:off x="8998217" y="4599603"/>
-            <a:ext cx="393792" cy="101326"/>
-          </a:xfrm>
-          <a:prstGeom prst="rect">
-            <a:avLst/>
-          </a:prstGeom>
-          <a:solidFill>
-            <a:srgbClr val="7030A0"/>
-          </a:solidFill>
-          <a:ln w="6350" cap="rnd"/>
-        </p:spPr>
-        <p:style>
-          <a:lnRef idx="2">
-            <a:schemeClr val="accent1">
-              <a:shade val="15000"/>
-            </a:schemeClr>
-          </a:lnRef>
-          <a:fillRef idx="1">
-            <a:schemeClr val="accent1"/>
-          </a:fillRef>
-          <a:effectRef idx="0">
-            <a:schemeClr val="accent1"/>
-          </a:effectRef>
-          <a:fontRef idx="minor">
-            <a:schemeClr val="lt1"/>
-          </a:fontRef>
-        </p:style>
-        <p:txBody>
-          <a:bodyPr lIns="0" tIns="0" rIns="0" bIns="0" rtlCol="0" anchor="ctr"/>
-          <a:lstStyle/>
-          <a:p>
-            <a:pPr algn="ctr"/>
-            <a:r>
-              <a:rPr lang="en-US" sz="700" dirty="0"/>
-              <a:t>.py script</a:t>
             </a:r>
           </a:p>
         </p:txBody>
@@ -7045,15 +6923,13 @@
           </p:cNvPr>
           <p:cNvCxnSpPr>
             <a:cxnSpLocks/>
-            <a:stCxn id="90" idx="2"/>
-            <a:endCxn id="92" idx="0"/>
           </p:cNvCxnSpPr>
           <p:nvPr/>
         </p:nvCxnSpPr>
         <p:spPr>
           <a:xfrm>
-            <a:off x="9940677" y="4029083"/>
-            <a:ext cx="0" cy="518339"/>
+            <a:off x="9756433" y="4336912"/>
+            <a:ext cx="0" cy="547973"/>
           </a:xfrm>
           <a:prstGeom prst="straightConnector1">
             <a:avLst/>
@@ -7091,7 +6967,6 @@
           </p:cNvPr>
           <p:cNvCxnSpPr>
             <a:cxnSpLocks/>
-            <a:stCxn id="92" idx="1"/>
             <a:endCxn id="52" idx="3"/>
           </p:cNvCxnSpPr>
           <p:nvPr/>
@@ -7099,7 +6974,7 @@
         <p:spPr>
           <a:xfrm flipH="1">
             <a:off x="8056871" y="5100698"/>
-            <a:ext cx="909994" cy="0"/>
+            <a:ext cx="1254471" cy="0"/>
           </a:xfrm>
           <a:prstGeom prst="straightConnector1">
             <a:avLst/>
@@ -7127,12 +7002,151 @@
           </a:fontRef>
         </p:style>
       </p:cxnSp>
+      <p:sp>
+        <p:nvSpPr>
+          <p:cNvPr id="131" name="Flowchart: Off-page Connector 130">
+            <a:extLst>
+              <a:ext uri="{FF2B5EF4-FFF2-40B4-BE49-F238E27FC236}">
+                <a16:creationId xmlns:a16="http://schemas.microsoft.com/office/drawing/2014/main" id="{8DB5FFE1-B20F-BC4A-F98A-1DB0CDA11B3B}"/>
+              </a:ext>
+            </a:extLst>
+          </p:cNvPr>
+          <p:cNvSpPr/>
+          <p:nvPr/>
+        </p:nvSpPr>
+        <p:spPr>
+          <a:xfrm rot="16200000">
+            <a:off x="2209722" y="4781767"/>
+            <a:ext cx="186884" cy="240280"/>
+          </a:xfrm>
+          <a:prstGeom prst="flowChartOffpageConnector">
+            <a:avLst/>
+          </a:prstGeom>
+          <a:solidFill>
+            <a:schemeClr val="accent6">
+              <a:lumMod val="75000"/>
+            </a:schemeClr>
+          </a:solidFill>
+        </p:spPr>
+        <p:style>
+          <a:lnRef idx="2">
+            <a:schemeClr val="accent1">
+              <a:shade val="15000"/>
+            </a:schemeClr>
+          </a:lnRef>
+          <a:fillRef idx="1">
+            <a:schemeClr val="accent1"/>
+          </a:fillRef>
+          <a:effectRef idx="0">
+            <a:schemeClr val="accent1"/>
+          </a:effectRef>
+          <a:fontRef idx="minor">
+            <a:schemeClr val="lt1"/>
+          </a:fontRef>
+        </p:style>
+        <p:txBody>
+          <a:bodyPr vert="vert" rtlCol="0" anchor="ctr"/>
+          <a:lstStyle/>
+          <a:p>
+            <a:pPr algn="ctr"/>
+            <a:r>
+              <a:rPr lang="en-US" sz="1400" b="1" dirty="0"/>
+              <a:t>8</a:t>
+            </a:r>
+          </a:p>
+        </p:txBody>
+      </p:sp>
+      <p:sp>
+        <p:nvSpPr>
+          <p:cNvPr id="137" name="Rectangle 136">
+            <a:extLst>
+              <a:ext uri="{FF2B5EF4-FFF2-40B4-BE49-F238E27FC236}">
+                <a16:creationId xmlns:a16="http://schemas.microsoft.com/office/drawing/2014/main" id="{C12A4E2B-6096-150E-DA86-68333E328721}"/>
+              </a:ext>
+            </a:extLst>
+          </p:cNvPr>
+          <p:cNvSpPr/>
+          <p:nvPr/>
+        </p:nvSpPr>
+        <p:spPr>
+          <a:xfrm>
+            <a:off x="9311342" y="4884884"/>
+            <a:ext cx="2215438" cy="1195545"/>
+          </a:xfrm>
+          <a:prstGeom prst="rect">
+            <a:avLst/>
+          </a:prstGeom>
+          <a:solidFill>
+            <a:srgbClr val="7030A0"/>
+          </a:solidFill>
+        </p:spPr>
+        <p:style>
+          <a:lnRef idx="2">
+            <a:schemeClr val="accent1">
+              <a:shade val="15000"/>
+            </a:schemeClr>
+          </a:lnRef>
+          <a:fillRef idx="1">
+            <a:schemeClr val="accent1"/>
+          </a:fillRef>
+          <a:effectRef idx="0">
+            <a:schemeClr val="accent1"/>
+          </a:effectRef>
+          <a:fontRef idx="minor">
+            <a:schemeClr val="lt1"/>
+          </a:fontRef>
+        </p:style>
+        <p:txBody>
+          <a:bodyPr lIns="0" tIns="0" rIns="0" bIns="0" rtlCol="0" anchor="ctr"/>
+          <a:lstStyle/>
+          <a:p>
+            <a:pPr algn="ctr"/>
+            <a:r>
+              <a:rPr lang="en-US" sz="1050" b="1" dirty="0"/>
+              <a:t>Query Mapper</a:t>
+            </a:r>
+          </a:p>
+          <a:p>
+            <a:pPr algn="ctr"/>
+            <a:endParaRPr lang="en-US" sz="300" dirty="0"/>
+          </a:p>
+          <a:p>
+            <a:pPr algn="ctr"/>
+            <a:r>
+              <a:rPr lang="en-US" sz="900" dirty="0"/>
+              <a:t>Uses arcane SEC-specific knowledge to determine Concepts being asked about </a:t>
+            </a:r>
+          </a:p>
+          <a:p>
+            <a:pPr algn="ctr"/>
+            <a:r>
+              <a:rPr lang="en-US" sz="900" dirty="0"/>
+              <a:t>(via alias lookups, cosine distances, etc…)</a:t>
+            </a:r>
+          </a:p>
+          <a:p>
+            <a:pPr algn="ctr"/>
+            <a:endParaRPr lang="en-US" sz="900" dirty="0"/>
+          </a:p>
+          <a:p>
+            <a:pPr algn="ctr"/>
+            <a:r>
+              <a:rPr lang="en-US" sz="900" dirty="0"/>
+              <a:t>Produces a Query Plan for the local LLM to write a matching SQL query.</a:t>
+            </a:r>
+          </a:p>
+          <a:p>
+            <a:pPr algn="ctr"/>
+            <a:endParaRPr lang="en-US" sz="500" dirty="0"/>
+          </a:p>
+        </p:txBody>
+      </p:sp>
       <p:cxnSp>
         <p:nvCxnSpPr>
-          <p:cNvPr id="111" name="Straight Arrow Connector 110">
-            <a:extLst>
-              <a:ext uri="{FF2B5EF4-FFF2-40B4-BE49-F238E27FC236}">
-                <a16:creationId xmlns:a16="http://schemas.microsoft.com/office/drawing/2014/main" id="{8822856E-54E9-6C62-EE17-9702CBA202C2}"/>
+          <p:cNvPr id="138" name="Straight Arrow Connector 137">
+            <a:extLst>
+              <a:ext uri="{FF2B5EF4-FFF2-40B4-BE49-F238E27FC236}">
+                <a16:creationId xmlns:a16="http://schemas.microsoft.com/office/drawing/2014/main" id="{218F14AF-9931-3060-84FB-55E3AD301B67}"/>
               </a:ext>
             </a:extLst>
           </p:cNvPr>
@@ -7142,9 +7156,9 @@
           <p:nvPr/>
         </p:nvCxnSpPr>
         <p:spPr>
-          <a:xfrm>
-            <a:off x="8129643" y="3112670"/>
-            <a:ext cx="837222" cy="1441161"/>
+          <a:xfrm flipH="1">
+            <a:off x="8056871" y="5492584"/>
+            <a:ext cx="1254471" cy="0"/>
           </a:xfrm>
           <a:prstGeom prst="straightConnector1">
             <a:avLst/>
@@ -7153,6 +7167,7 @@
             <a:solidFill>
               <a:schemeClr val="tx1"/>
             </a:solidFill>
+            <a:headEnd type="none"/>
             <a:tailEnd type="arrow"/>
           </a:ln>
         </p:spPr>
@@ -7173,10 +7188,10 @@
       </p:cxnSp>
       <p:sp>
         <p:nvSpPr>
-          <p:cNvPr id="131" name="Flowchart: Off-page Connector 130">
-            <a:extLst>
-              <a:ext uri="{FF2B5EF4-FFF2-40B4-BE49-F238E27FC236}">
-                <a16:creationId xmlns:a16="http://schemas.microsoft.com/office/drawing/2014/main" id="{8DB5FFE1-B20F-BC4A-F98A-1DB0CDA11B3B}"/>
+          <p:cNvPr id="140" name="Rectangle 139">
+            <a:extLst>
+              <a:ext uri="{FF2B5EF4-FFF2-40B4-BE49-F238E27FC236}">
+                <a16:creationId xmlns:a16="http://schemas.microsoft.com/office/drawing/2014/main" id="{EFB83094-B4D6-F6AB-F052-7F3270A99A6B}"/>
               </a:ext>
             </a:extLst>
           </p:cNvPr>
@@ -7184,17 +7199,15 @@
           <p:nvPr/>
         </p:nvSpPr>
         <p:spPr>
-          <a:xfrm rot="16200000">
-            <a:off x="2209722" y="4781767"/>
-            <a:ext cx="186884" cy="240280"/>
-          </a:xfrm>
-          <a:prstGeom prst="flowChartOffpageConnector">
+          <a:xfrm>
+            <a:off x="9391751" y="4411928"/>
+            <a:ext cx="719593" cy="304891"/>
+          </a:xfrm>
+          <a:prstGeom prst="rect">
             <a:avLst/>
           </a:prstGeom>
           <a:solidFill>
-            <a:schemeClr val="accent6">
-              <a:lumMod val="75000"/>
-            </a:schemeClr>
+            <a:srgbClr val="B17ED8"/>
           </a:solidFill>
         </p:spPr>
         <p:style>
@@ -7214,23 +7227,36 @@
           </a:fontRef>
         </p:style>
         <p:txBody>
-          <a:bodyPr vert="vert" rtlCol="0" anchor="ctr"/>
-          <a:lstStyle/>
-          <a:p>
-            <a:pPr algn="ctr"/>
-            <a:r>
-              <a:rPr lang="en-US" sz="1400" b="1" dirty="0"/>
-              <a:t>8</a:t>
-            </a:r>
-          </a:p>
-        </p:txBody>
-      </p:sp>
-      <p:sp>
-        <p:nvSpPr>
-          <p:cNvPr id="137" name="Rectangle 136">
-            <a:extLst>
-              <a:ext uri="{FF2B5EF4-FFF2-40B4-BE49-F238E27FC236}">
-                <a16:creationId xmlns:a16="http://schemas.microsoft.com/office/drawing/2014/main" id="{C12A4E2B-6096-150E-DA86-68333E328721}"/>
+          <a:bodyPr lIns="0" tIns="0" rIns="0" bIns="0" rtlCol="0" anchor="t"/>
+          <a:lstStyle/>
+          <a:p>
+            <a:pPr algn="ctr"/>
+            <a:r>
+              <a:rPr lang="en-US" sz="1000" b="1" dirty="0"/>
+              <a:t>Query Object</a:t>
+            </a:r>
+            <a:endParaRPr lang="en-US" sz="1200" b="1" dirty="0"/>
+          </a:p>
+          <a:p>
+            <a:pPr algn="ctr"/>
+            <a:r>
+              <a:rPr lang="en-US" sz="700" dirty="0"/>
+              <a:t>📚 </a:t>
+            </a:r>
+            <a:r>
+              <a:rPr lang="en-US" sz="700" b="1" u="sng" dirty="0"/>
+              <a:t>Pydantic</a:t>
+            </a:r>
+            <a:endParaRPr lang="en-US" sz="800" b="1" u="sng" dirty="0"/>
+          </a:p>
+        </p:txBody>
+      </p:sp>
+      <p:sp>
+        <p:nvSpPr>
+          <p:cNvPr id="141" name="Rectangle 140">
+            <a:extLst>
+              <a:ext uri="{FF2B5EF4-FFF2-40B4-BE49-F238E27FC236}">
+                <a16:creationId xmlns:a16="http://schemas.microsoft.com/office/drawing/2014/main" id="{57D42052-BB79-A072-46BE-B34C46D0157D}"/>
               </a:ext>
             </a:extLst>
           </p:cNvPr>
@@ -7239,8 +7265,73 @@
         </p:nvSpPr>
         <p:spPr>
           <a:xfrm>
-            <a:off x="8966865" y="5751982"/>
-            <a:ext cx="1947624" cy="829702"/>
+            <a:off x="8370160" y="5353118"/>
+            <a:ext cx="719593" cy="304890"/>
+          </a:xfrm>
+          <a:prstGeom prst="rect">
+            <a:avLst/>
+          </a:prstGeom>
+          <a:solidFill>
+            <a:srgbClr val="B17ED8"/>
+          </a:solidFill>
+        </p:spPr>
+        <p:style>
+          <a:lnRef idx="2">
+            <a:schemeClr val="accent1">
+              <a:shade val="15000"/>
+            </a:schemeClr>
+          </a:lnRef>
+          <a:fillRef idx="1">
+            <a:schemeClr val="accent1"/>
+          </a:fillRef>
+          <a:effectRef idx="0">
+            <a:schemeClr val="accent1"/>
+          </a:effectRef>
+          <a:fontRef idx="minor">
+            <a:schemeClr val="lt1"/>
+          </a:fontRef>
+        </p:style>
+        <p:txBody>
+          <a:bodyPr lIns="0" tIns="0" rIns="0" bIns="0" rtlCol="0" anchor="t"/>
+          <a:lstStyle/>
+          <a:p>
+            <a:pPr algn="ctr"/>
+            <a:r>
+              <a:rPr lang="en-US" sz="1000" b="1" dirty="0"/>
+              <a:t>Query Plan</a:t>
+            </a:r>
+            <a:endParaRPr lang="en-US" sz="1200" b="1" dirty="0"/>
+          </a:p>
+          <a:p>
+            <a:pPr algn="ctr"/>
+            <a:r>
+              <a:rPr lang="en-US" sz="700" dirty="0"/>
+              <a:t>📚 </a:t>
+            </a:r>
+            <a:r>
+              <a:rPr lang="en-US" sz="700" b="1" u="sng" dirty="0"/>
+              <a:t>Pydantic</a:t>
+            </a:r>
+            <a:endParaRPr lang="en-US" sz="800" b="1" u="sng" dirty="0"/>
+          </a:p>
+        </p:txBody>
+      </p:sp>
+      <p:sp>
+        <p:nvSpPr>
+          <p:cNvPr id="93" name="Rectangle 92">
+            <a:extLst>
+              <a:ext uri="{FF2B5EF4-FFF2-40B4-BE49-F238E27FC236}">
+                <a16:creationId xmlns:a16="http://schemas.microsoft.com/office/drawing/2014/main" id="{C470D739-A7E4-B20F-87C7-38FAB125269A}"/>
+              </a:ext>
+            </a:extLst>
+          </p:cNvPr>
+          <p:cNvSpPr/>
+          <p:nvPr/>
+        </p:nvSpPr>
+        <p:spPr>
+          <a:xfrm>
+            <a:off x="9362414" y="4933772"/>
+            <a:ext cx="393792" cy="101326"/>
           </a:xfrm>
           <a:prstGeom prst="rect">
             <a:avLst/>
@@ -7248,6 +7339,7 @@
           <a:solidFill>
             <a:srgbClr val="7030A0"/>
           </a:solidFill>
+          <a:ln w="6350" cap="rnd"/>
         </p:spPr>
         <p:style>
           <a:lnRef idx="2">
@@ -7271,33 +7363,18 @@
           <a:p>
             <a:pPr algn="ctr"/>
             <a:r>
-              <a:rPr lang="en-US" sz="1050" b="1" dirty="0"/>
-              <a:t>Concept Mapper</a:t>
-            </a:r>
-          </a:p>
-          <a:p>
-            <a:pPr algn="ctr"/>
-            <a:endParaRPr lang="en-US" sz="300" dirty="0"/>
-          </a:p>
-          <a:p>
-            <a:pPr algn="ctr"/>
-            <a:r>
-              <a:rPr lang="en-US" sz="900" dirty="0"/>
-              <a:t>Uses arcane SEC-specific knowledge of Concept usage to determine Concepts when the traditional match will be incorrect</a:t>
-            </a:r>
-          </a:p>
-          <a:p>
-            <a:pPr algn="ctr"/>
-            <a:endParaRPr lang="en-US" sz="500" dirty="0"/>
+              <a:rPr lang="en-US" sz="700" dirty="0"/>
+              <a:t>.py script</a:t>
+            </a:r>
           </a:p>
         </p:txBody>
       </p:sp>
       <p:cxnSp>
         <p:nvCxnSpPr>
-          <p:cNvPr id="138" name="Straight Arrow Connector 137">
-            <a:extLst>
-              <a:ext uri="{FF2B5EF4-FFF2-40B4-BE49-F238E27FC236}">
-                <a16:creationId xmlns:a16="http://schemas.microsoft.com/office/drawing/2014/main" id="{218F14AF-9931-3060-84FB-55E3AD301B67}"/>
+          <p:cNvPr id="160" name="Straight Arrow Connector 159">
+            <a:extLst>
+              <a:ext uri="{FF2B5EF4-FFF2-40B4-BE49-F238E27FC236}">
+                <a16:creationId xmlns:a16="http://schemas.microsoft.com/office/drawing/2014/main" id="{544E47D5-B3E9-03E4-F236-9378DC14B57C}"/>
               </a:ext>
             </a:extLst>
           </p:cNvPr>
@@ -7308,8 +7385,133 @@
         </p:nvCxnSpPr>
         <p:spPr>
           <a:xfrm flipH="1">
-            <a:off x="8056871" y="5492584"/>
-            <a:ext cx="909994" cy="0"/>
+            <a:off x="8056871" y="5846330"/>
+            <a:ext cx="1254471" cy="0"/>
+          </a:xfrm>
+          <a:prstGeom prst="straightConnector1">
+            <a:avLst/>
+          </a:prstGeom>
+          <a:ln w="12700">
+            <a:solidFill>
+              <a:schemeClr val="tx1"/>
+            </a:solidFill>
+            <a:headEnd type="arrow"/>
+            <a:tailEnd type="none"/>
+          </a:ln>
+        </p:spPr>
+        <p:style>
+          <a:lnRef idx="1">
+            <a:schemeClr val="accent1"/>
+          </a:lnRef>
+          <a:fillRef idx="0">
+            <a:schemeClr val="accent1"/>
+          </a:fillRef>
+          <a:effectRef idx="0">
+            <a:schemeClr val="accent1"/>
+          </a:effectRef>
+          <a:fontRef idx="minor">
+            <a:schemeClr val="tx1"/>
+          </a:fontRef>
+        </p:style>
+      </p:cxnSp>
+      <p:sp>
+        <p:nvSpPr>
+          <p:cNvPr id="161" name="TextBox 160">
+            <a:extLst>
+              <a:ext uri="{FF2B5EF4-FFF2-40B4-BE49-F238E27FC236}">
+                <a16:creationId xmlns:a16="http://schemas.microsoft.com/office/drawing/2014/main" id="{EEB8931C-BA61-0618-C084-D24D32A32097}"/>
+              </a:ext>
+            </a:extLst>
+          </p:cNvPr>
+          <p:cNvSpPr txBox="1"/>
+          <p:nvPr/>
+        </p:nvSpPr>
+        <p:spPr>
+          <a:xfrm>
+            <a:off x="10731674" y="4511651"/>
+            <a:ext cx="652423" cy="169277"/>
+          </a:xfrm>
+          <a:prstGeom prst="rect">
+            <a:avLst/>
+          </a:prstGeom>
+          <a:noFill/>
+        </p:spPr>
+        <p:txBody>
+          <a:bodyPr wrap="none" lIns="0" tIns="0" rIns="0" bIns="0" rtlCol="0">
+            <a:spAutoFit/>
+          </a:bodyPr>
+          <a:lstStyle/>
+          <a:p>
+            <a:r>
+              <a:rPr lang="en-US" sz="1100" i="1" dirty="0"/>
+              <a:t>Query data</a:t>
+            </a:r>
+          </a:p>
+        </p:txBody>
+      </p:sp>
+      <p:cxnSp>
+        <p:nvCxnSpPr>
+          <p:cNvPr id="164" name="Straight Arrow Connector 163">
+            <a:extLst>
+              <a:ext uri="{FF2B5EF4-FFF2-40B4-BE49-F238E27FC236}">
+                <a16:creationId xmlns:a16="http://schemas.microsoft.com/office/drawing/2014/main" id="{AD5A96E6-5B59-6B19-7697-43661A71E9CA}"/>
+              </a:ext>
+            </a:extLst>
+          </p:cNvPr>
+          <p:cNvCxnSpPr>
+            <a:cxnSpLocks/>
+          </p:cNvCxnSpPr>
+          <p:nvPr/>
+        </p:nvCxnSpPr>
+        <p:spPr>
+          <a:xfrm>
+            <a:off x="11092940" y="4336911"/>
+            <a:ext cx="0" cy="547973"/>
+          </a:xfrm>
+          <a:prstGeom prst="straightConnector1">
+            <a:avLst/>
+          </a:prstGeom>
+          <a:ln w="12700">
+            <a:solidFill>
+              <a:schemeClr val="tx1"/>
+            </a:solidFill>
+            <a:headEnd type="arrow"/>
+            <a:tailEnd type="none"/>
+          </a:ln>
+        </p:spPr>
+        <p:style>
+          <a:lnRef idx="1">
+            <a:schemeClr val="accent1"/>
+          </a:lnRef>
+          <a:fillRef idx="0">
+            <a:schemeClr val="accent1"/>
+          </a:fillRef>
+          <a:effectRef idx="0">
+            <a:schemeClr val="accent1"/>
+          </a:effectRef>
+          <a:fontRef idx="minor">
+            <a:schemeClr val="tx1"/>
+          </a:fontRef>
+        </p:style>
+      </p:cxnSp>
+      <p:cxnSp>
+        <p:nvCxnSpPr>
+          <p:cNvPr id="167" name="Straight Arrow Connector 166">
+            <a:extLst>
+              <a:ext uri="{FF2B5EF4-FFF2-40B4-BE49-F238E27FC236}">
+                <a16:creationId xmlns:a16="http://schemas.microsoft.com/office/drawing/2014/main" id="{188E0E9D-CD8C-2DF9-9DD6-2809E60C06D4}"/>
+              </a:ext>
+            </a:extLst>
+          </p:cNvPr>
+          <p:cNvCxnSpPr>
+            <a:cxnSpLocks/>
+          </p:cNvCxnSpPr>
+          <p:nvPr/>
+        </p:nvCxnSpPr>
+        <p:spPr>
+          <a:xfrm flipH="1" flipV="1">
+            <a:off x="8129643" y="3112670"/>
+            <a:ext cx="1181698" cy="1772213"/>
           </a:xfrm>
           <a:prstGeom prst="straightConnector1">
             <a:avLst/>
@@ -7337,6 +7539,473 @@
           </a:fontRef>
         </p:style>
       </p:cxnSp>
+      <p:sp>
+        <p:nvSpPr>
+          <p:cNvPr id="170" name="TextBox 169">
+            <a:extLst>
+              <a:ext uri="{FF2B5EF4-FFF2-40B4-BE49-F238E27FC236}">
+                <a16:creationId xmlns:a16="http://schemas.microsoft.com/office/drawing/2014/main" id="{B083C1EC-BE03-48D2-C3AE-FADE3D496F76}"/>
+              </a:ext>
+            </a:extLst>
+          </p:cNvPr>
+          <p:cNvSpPr txBox="1"/>
+          <p:nvPr/>
+        </p:nvSpPr>
+        <p:spPr>
+          <a:xfrm>
+            <a:off x="8410425" y="5846330"/>
+            <a:ext cx="591509" cy="169277"/>
+          </a:xfrm>
+          <a:prstGeom prst="rect">
+            <a:avLst/>
+          </a:prstGeom>
+          <a:noFill/>
+        </p:spPr>
+        <p:txBody>
+          <a:bodyPr wrap="none" lIns="0" tIns="0" rIns="0" bIns="0" rtlCol="0">
+            <a:spAutoFit/>
+          </a:bodyPr>
+          <a:lstStyle/>
+          <a:p>
+            <a:r>
+              <a:rPr lang="en-US" sz="1100" i="1" dirty="0"/>
+              <a:t>SQL Query</a:t>
+            </a:r>
+          </a:p>
+        </p:txBody>
+      </p:sp>
+      <p:sp>
+        <p:nvSpPr>
+          <p:cNvPr id="171" name="TextBox 170">
+            <a:extLst>
+              <a:ext uri="{FF2B5EF4-FFF2-40B4-BE49-F238E27FC236}">
+                <a16:creationId xmlns:a16="http://schemas.microsoft.com/office/drawing/2014/main" id="{C4E25829-8F49-7D62-A8DF-A418112E679F}"/>
+              </a:ext>
+            </a:extLst>
+          </p:cNvPr>
+          <p:cNvSpPr txBox="1"/>
+          <p:nvPr/>
+        </p:nvSpPr>
+        <p:spPr>
+          <a:xfrm rot="3305483">
+            <a:off x="8268959" y="3850359"/>
+            <a:ext cx="1131720" cy="169277"/>
+          </a:xfrm>
+          <a:prstGeom prst="rect">
+            <a:avLst/>
+          </a:prstGeom>
+          <a:noFill/>
+        </p:spPr>
+        <p:txBody>
+          <a:bodyPr wrap="none" lIns="0" tIns="0" rIns="0" bIns="0" rtlCol="0">
+            <a:spAutoFit/>
+          </a:bodyPr>
+          <a:lstStyle/>
+          <a:p>
+            <a:r>
+              <a:rPr lang="en-US" sz="1100" i="1" dirty="0"/>
+              <a:t>Query and response</a:t>
+            </a:r>
+          </a:p>
+        </p:txBody>
+      </p:sp>
+      <p:sp>
+        <p:nvSpPr>
+          <p:cNvPr id="172" name="Flowchart: Off-page Connector 171">
+            <a:extLst>
+              <a:ext uri="{FF2B5EF4-FFF2-40B4-BE49-F238E27FC236}">
+                <a16:creationId xmlns:a16="http://schemas.microsoft.com/office/drawing/2014/main" id="{0447B003-9275-D120-E27F-58CA5443AE1E}"/>
+              </a:ext>
+            </a:extLst>
+          </p:cNvPr>
+          <p:cNvSpPr/>
+          <p:nvPr/>
+        </p:nvSpPr>
+        <p:spPr>
+          <a:xfrm rot="16200000">
+            <a:off x="9054676" y="3687072"/>
+            <a:ext cx="186884" cy="240280"/>
+          </a:xfrm>
+          <a:prstGeom prst="flowChartOffpageConnector">
+            <a:avLst/>
+          </a:prstGeom>
+          <a:solidFill>
+            <a:schemeClr val="accent4">
+              <a:lumMod val="60000"/>
+              <a:lumOff val="40000"/>
+            </a:schemeClr>
+          </a:solidFill>
+        </p:spPr>
+        <p:style>
+          <a:lnRef idx="2">
+            <a:schemeClr val="accent1">
+              <a:shade val="15000"/>
+            </a:schemeClr>
+          </a:lnRef>
+          <a:fillRef idx="1">
+            <a:schemeClr val="accent1"/>
+          </a:fillRef>
+          <a:effectRef idx="0">
+            <a:schemeClr val="accent1"/>
+          </a:effectRef>
+          <a:fontRef idx="minor">
+            <a:schemeClr val="lt1"/>
+          </a:fontRef>
+        </p:style>
+        <p:txBody>
+          <a:bodyPr vert="vert" rtlCol="0" anchor="ctr"/>
+          <a:lstStyle/>
+          <a:p>
+            <a:pPr algn="ctr"/>
+            <a:r>
+              <a:rPr lang="en-US" sz="1400" b="1" dirty="0">
+                <a:solidFill>
+                  <a:schemeClr val="accent4">
+                    <a:lumMod val="75000"/>
+                  </a:schemeClr>
+                </a:solidFill>
+              </a:rPr>
+              <a:t>1</a:t>
+            </a:r>
+          </a:p>
+        </p:txBody>
+      </p:sp>
+      <p:sp>
+        <p:nvSpPr>
+          <p:cNvPr id="173" name="Flowchart: Off-page Connector 172">
+            <a:extLst>
+              <a:ext uri="{FF2B5EF4-FFF2-40B4-BE49-F238E27FC236}">
+                <a16:creationId xmlns:a16="http://schemas.microsoft.com/office/drawing/2014/main" id="{2C8AEE21-31C9-8EE4-5BE2-13A0E04ABDE4}"/>
+              </a:ext>
+            </a:extLst>
+          </p:cNvPr>
+          <p:cNvSpPr/>
+          <p:nvPr/>
+        </p:nvSpPr>
+        <p:spPr>
+          <a:xfrm rot="16200000">
+            <a:off x="9206075" y="5166555"/>
+            <a:ext cx="186884" cy="240280"/>
+          </a:xfrm>
+          <a:prstGeom prst="flowChartOffpageConnector">
+            <a:avLst/>
+          </a:prstGeom>
+          <a:solidFill>
+            <a:schemeClr val="accent4">
+              <a:lumMod val="60000"/>
+              <a:lumOff val="40000"/>
+            </a:schemeClr>
+          </a:solidFill>
+        </p:spPr>
+        <p:style>
+          <a:lnRef idx="2">
+            <a:schemeClr val="accent1">
+              <a:shade val="15000"/>
+            </a:schemeClr>
+          </a:lnRef>
+          <a:fillRef idx="1">
+            <a:schemeClr val="accent1"/>
+          </a:fillRef>
+          <a:effectRef idx="0">
+            <a:schemeClr val="accent1"/>
+          </a:effectRef>
+          <a:fontRef idx="minor">
+            <a:schemeClr val="lt1"/>
+          </a:fontRef>
+        </p:style>
+        <p:txBody>
+          <a:bodyPr vert="vert" rtlCol="0" anchor="ctr"/>
+          <a:lstStyle/>
+          <a:p>
+            <a:pPr algn="ctr"/>
+            <a:r>
+              <a:rPr lang="en-US" sz="1400" b="1" dirty="0">
+                <a:solidFill>
+                  <a:schemeClr val="accent4">
+                    <a:lumMod val="75000"/>
+                  </a:schemeClr>
+                </a:solidFill>
+              </a:rPr>
+              <a:t>2</a:t>
+            </a:r>
+          </a:p>
+        </p:txBody>
+      </p:sp>
+      <p:sp>
+        <p:nvSpPr>
+          <p:cNvPr id="174" name="Flowchart: Off-page Connector 173">
+            <a:extLst>
+              <a:ext uri="{FF2B5EF4-FFF2-40B4-BE49-F238E27FC236}">
+                <a16:creationId xmlns:a16="http://schemas.microsoft.com/office/drawing/2014/main" id="{DC49F929-8236-C80A-DF74-45C92AFAD358}"/>
+              </a:ext>
+            </a:extLst>
+          </p:cNvPr>
+          <p:cNvSpPr/>
+          <p:nvPr/>
+        </p:nvSpPr>
+        <p:spPr>
+          <a:xfrm rot="16200000">
+            <a:off x="6789154" y="5248565"/>
+            <a:ext cx="186884" cy="240280"/>
+          </a:xfrm>
+          <a:prstGeom prst="flowChartOffpageConnector">
+            <a:avLst/>
+          </a:prstGeom>
+          <a:solidFill>
+            <a:schemeClr val="accent4">
+              <a:lumMod val="60000"/>
+              <a:lumOff val="40000"/>
+            </a:schemeClr>
+          </a:solidFill>
+        </p:spPr>
+        <p:style>
+          <a:lnRef idx="2">
+            <a:schemeClr val="accent1">
+              <a:shade val="15000"/>
+            </a:schemeClr>
+          </a:lnRef>
+          <a:fillRef idx="1">
+            <a:schemeClr val="accent1"/>
+          </a:fillRef>
+          <a:effectRef idx="0">
+            <a:schemeClr val="accent1"/>
+          </a:effectRef>
+          <a:fontRef idx="minor">
+            <a:schemeClr val="lt1"/>
+          </a:fontRef>
+        </p:style>
+        <p:txBody>
+          <a:bodyPr vert="vert" rtlCol="0" anchor="ctr"/>
+          <a:lstStyle/>
+          <a:p>
+            <a:pPr algn="ctr"/>
+            <a:r>
+              <a:rPr lang="en-US" sz="1400" b="1" dirty="0">
+                <a:solidFill>
+                  <a:schemeClr val="accent4">
+                    <a:lumMod val="75000"/>
+                  </a:schemeClr>
+                </a:solidFill>
+              </a:rPr>
+              <a:t>3</a:t>
+            </a:r>
+          </a:p>
+        </p:txBody>
+      </p:sp>
+      <p:sp>
+        <p:nvSpPr>
+          <p:cNvPr id="175" name="Flowchart: Off-page Connector 174">
+            <a:extLst>
+              <a:ext uri="{FF2B5EF4-FFF2-40B4-BE49-F238E27FC236}">
+                <a16:creationId xmlns:a16="http://schemas.microsoft.com/office/drawing/2014/main" id="{EAA4BC7C-AB35-5672-4A04-11F3AED98435}"/>
+              </a:ext>
+            </a:extLst>
+          </p:cNvPr>
+          <p:cNvSpPr/>
+          <p:nvPr/>
+        </p:nvSpPr>
+        <p:spPr>
+          <a:xfrm rot="16200000">
+            <a:off x="8244296" y="3376702"/>
+            <a:ext cx="186884" cy="240280"/>
+          </a:xfrm>
+          <a:prstGeom prst="flowChartOffpageConnector">
+            <a:avLst/>
+          </a:prstGeom>
+          <a:solidFill>
+            <a:schemeClr val="accent4">
+              <a:lumMod val="60000"/>
+              <a:lumOff val="40000"/>
+            </a:schemeClr>
+          </a:solidFill>
+        </p:spPr>
+        <p:style>
+          <a:lnRef idx="2">
+            <a:schemeClr val="accent1">
+              <a:shade val="15000"/>
+            </a:schemeClr>
+          </a:lnRef>
+          <a:fillRef idx="1">
+            <a:schemeClr val="accent1"/>
+          </a:fillRef>
+          <a:effectRef idx="0">
+            <a:schemeClr val="accent1"/>
+          </a:effectRef>
+          <a:fontRef idx="minor">
+            <a:schemeClr val="lt1"/>
+          </a:fontRef>
+        </p:style>
+        <p:txBody>
+          <a:bodyPr vert="vert" rtlCol="0" anchor="ctr"/>
+          <a:lstStyle/>
+          <a:p>
+            <a:pPr algn="ctr"/>
+            <a:r>
+              <a:rPr lang="en-US" sz="1400" b="1" dirty="0">
+                <a:solidFill>
+                  <a:schemeClr val="accent4">
+                    <a:lumMod val="75000"/>
+                  </a:schemeClr>
+                </a:solidFill>
+              </a:rPr>
+              <a:t>4</a:t>
+            </a:r>
+          </a:p>
+        </p:txBody>
+      </p:sp>
+      <p:sp>
+        <p:nvSpPr>
+          <p:cNvPr id="176" name="Flowchart: Off-page Connector 175">
+            <a:extLst>
+              <a:ext uri="{FF2B5EF4-FFF2-40B4-BE49-F238E27FC236}">
+                <a16:creationId xmlns:a16="http://schemas.microsoft.com/office/drawing/2014/main" id="{AFCC506F-4117-8D5C-A52D-382D4EF3B926}"/>
+              </a:ext>
+            </a:extLst>
+          </p:cNvPr>
+          <p:cNvSpPr/>
+          <p:nvPr/>
+        </p:nvSpPr>
+        <p:spPr>
+          <a:xfrm rot="16200000">
+            <a:off x="10473248" y="4465418"/>
+            <a:ext cx="186884" cy="240280"/>
+          </a:xfrm>
+          <a:prstGeom prst="flowChartOffpageConnector">
+            <a:avLst/>
+          </a:prstGeom>
+          <a:solidFill>
+            <a:schemeClr val="accent4">
+              <a:lumMod val="60000"/>
+              <a:lumOff val="40000"/>
+            </a:schemeClr>
+          </a:solidFill>
+        </p:spPr>
+        <p:style>
+          <a:lnRef idx="2">
+            <a:schemeClr val="accent1">
+              <a:shade val="15000"/>
+            </a:schemeClr>
+          </a:lnRef>
+          <a:fillRef idx="1">
+            <a:schemeClr val="accent1"/>
+          </a:fillRef>
+          <a:effectRef idx="0">
+            <a:schemeClr val="accent1"/>
+          </a:effectRef>
+          <a:fontRef idx="minor">
+            <a:schemeClr val="lt1"/>
+          </a:fontRef>
+        </p:style>
+        <p:txBody>
+          <a:bodyPr vert="vert" rtlCol="0" anchor="ctr"/>
+          <a:lstStyle/>
+          <a:p>
+            <a:pPr algn="ctr"/>
+            <a:r>
+              <a:rPr lang="en-US" sz="1400" b="1" dirty="0">
+                <a:solidFill>
+                  <a:schemeClr val="accent4">
+                    <a:lumMod val="75000"/>
+                  </a:schemeClr>
+                </a:solidFill>
+              </a:rPr>
+              <a:t>5</a:t>
+            </a:r>
+          </a:p>
+        </p:txBody>
+      </p:sp>
+      <p:sp>
+        <p:nvSpPr>
+          <p:cNvPr id="178" name="Thought Bubble: Cloud 177">
+            <a:extLst>
+              <a:ext uri="{FF2B5EF4-FFF2-40B4-BE49-F238E27FC236}">
+                <a16:creationId xmlns:a16="http://schemas.microsoft.com/office/drawing/2014/main" id="{22BE8A4D-DA4E-6EFE-842E-C807DCC86649}"/>
+              </a:ext>
+            </a:extLst>
+          </p:cNvPr>
+          <p:cNvSpPr/>
+          <p:nvPr/>
+        </p:nvSpPr>
+        <p:spPr>
+          <a:xfrm>
+            <a:off x="9697423" y="2919947"/>
+            <a:ext cx="1320449" cy="509053"/>
+          </a:xfrm>
+          <a:prstGeom prst="cloudCallout">
+            <a:avLst>
+              <a:gd name="adj1" fmla="val 1435"/>
+              <a:gd name="adj2" fmla="val 46748"/>
+            </a:avLst>
+          </a:prstGeom>
+          <a:noFill/>
+        </p:spPr>
+        <p:style>
+          <a:lnRef idx="2">
+            <a:schemeClr val="accent1">
+              <a:shade val="15000"/>
+            </a:schemeClr>
+          </a:lnRef>
+          <a:fillRef idx="1">
+            <a:schemeClr val="accent1"/>
+          </a:fillRef>
+          <a:effectRef idx="0">
+            <a:schemeClr val="accent1"/>
+          </a:effectRef>
+          <a:fontRef idx="minor">
+            <a:schemeClr val="lt1"/>
+          </a:fontRef>
+        </p:style>
+        <p:txBody>
+          <a:bodyPr rtlCol="0" anchor="ctr"/>
+          <a:lstStyle/>
+          <a:p>
+            <a:pPr algn="ctr"/>
+            <a:r>
+              <a:rPr lang="en-US" sz="2800" b="1" dirty="0">
+                <a:solidFill>
+                  <a:schemeClr val="tx1"/>
+                </a:solidFill>
+              </a:rPr>
+              <a:t>User</a:t>
+            </a:r>
+          </a:p>
+        </p:txBody>
+      </p:sp>
+      <p:sp>
+        <p:nvSpPr>
+          <p:cNvPr id="179" name="TextBox 178">
+            <a:extLst>
+              <a:ext uri="{FF2B5EF4-FFF2-40B4-BE49-F238E27FC236}">
+                <a16:creationId xmlns:a16="http://schemas.microsoft.com/office/drawing/2014/main" id="{7EE5DE43-57A1-40FD-4F3A-9493D38626A3}"/>
+              </a:ext>
+            </a:extLst>
+          </p:cNvPr>
+          <p:cNvSpPr txBox="1"/>
+          <p:nvPr/>
+        </p:nvSpPr>
+        <p:spPr>
+          <a:xfrm>
+            <a:off x="9665887" y="3519100"/>
+            <a:ext cx="1561325" cy="169277"/>
+          </a:xfrm>
+          <a:prstGeom prst="rect">
+            <a:avLst/>
+          </a:prstGeom>
+          <a:noFill/>
+        </p:spPr>
+        <p:txBody>
+          <a:bodyPr wrap="none" lIns="0" tIns="0" rIns="0" bIns="0" rtlCol="0">
+            <a:spAutoFit/>
+          </a:bodyPr>
+          <a:lstStyle/>
+          <a:p>
+            <a:r>
+              <a:rPr lang="en-US" sz="1100" i="1" dirty="0"/>
+              <a:t>Ask question / Display data</a:t>
+            </a:r>
+          </a:p>
+        </p:txBody>
+      </p:sp>
     </p:spTree>
     <p:extLst>
       <p:ext uri="{BB962C8B-B14F-4D97-AF65-F5344CB8AC3E}">

</xml_diff>

<commit_message>
Updating diagram again for query phase
</commit_message>
<xml_diff>
--- a/Project and Tool Layout.pptx
+++ b/Project and Tool Layout.pptx
@@ -6,6 +6,7 @@
   </p:sldMasterIdLst>
   <p:sldIdLst>
     <p:sldId id="256" r:id="rId2"/>
+    <p:sldId id="258" r:id="rId3"/>
   </p:sldIdLst>
   <p:sldSz cx="12192000" cy="6858000"/>
   <p:notesSz cx="6858000" cy="9144000"/>
@@ -3340,7 +3341,7 @@
         </p:nvSpPr>
         <p:spPr>
           <a:xfrm>
-            <a:off x="2097659" y="149458"/>
+            <a:off x="3086994" y="770182"/>
             <a:ext cx="3492379" cy="1656606"/>
           </a:xfrm>
           <a:prstGeom prst="rect">
@@ -3398,7 +3399,7 @@
         </p:nvSpPr>
         <p:spPr>
           <a:xfrm>
-            <a:off x="6874294" y="1766629"/>
+            <a:off x="7863629" y="2387353"/>
             <a:ext cx="1314542" cy="1426968"/>
           </a:xfrm>
           <a:prstGeom prst="rect">
@@ -3460,7 +3461,7 @@
         </p:nvSpPr>
         <p:spPr>
           <a:xfrm>
-            <a:off x="6874294" y="549197"/>
+            <a:off x="7863629" y="1169921"/>
             <a:ext cx="1314542" cy="922951"/>
           </a:xfrm>
           <a:prstGeom prst="rect">
@@ -3522,7 +3523,7 @@
         </p:nvSpPr>
         <p:spPr>
           <a:xfrm>
-            <a:off x="6933487" y="2216982"/>
+            <a:off x="7922822" y="2837706"/>
             <a:ext cx="1196156" cy="895688"/>
           </a:xfrm>
           <a:prstGeom prst="rect">
@@ -3577,7 +3578,7 @@
         </p:nvSpPr>
         <p:spPr>
           <a:xfrm>
-            <a:off x="481515" y="184470"/>
+            <a:off x="1470850" y="805194"/>
             <a:ext cx="1177564" cy="660952"/>
           </a:xfrm>
           <a:prstGeom prst="cloudCallout">
@@ -3634,7 +3635,7 @@
         </p:nvSpPr>
         <p:spPr>
           <a:xfrm>
-            <a:off x="509643" y="1332477"/>
+            <a:off x="1498978" y="1953201"/>
             <a:ext cx="1121308" cy="1361588"/>
           </a:xfrm>
           <a:prstGeom prst="rect">
@@ -3709,7 +3710,7 @@
         </p:nvSpPr>
         <p:spPr>
           <a:xfrm>
-            <a:off x="509643" y="2927983"/>
+            <a:off x="1498978" y="3548707"/>
             <a:ext cx="1121308" cy="548974"/>
           </a:xfrm>
           <a:prstGeom prst="rect">
@@ -3771,7 +3772,7 @@
         </p:nvCxnSpPr>
         <p:spPr>
           <a:xfrm>
-            <a:off x="1070297" y="2694065"/>
+            <a:off x="2059632" y="3314789"/>
             <a:ext cx="0" cy="233918"/>
           </a:xfrm>
           <a:prstGeom prst="straightConnector1">
@@ -3813,7 +3814,7 @@
         </p:nvSpPr>
         <p:spPr>
           <a:xfrm>
-            <a:off x="509643" y="3665676"/>
+            <a:off x="1498978" y="4286400"/>
             <a:ext cx="1121308" cy="957830"/>
           </a:xfrm>
           <a:prstGeom prst="rect">
@@ -3891,7 +3892,7 @@
         </p:nvCxnSpPr>
         <p:spPr>
           <a:xfrm>
-            <a:off x="1070297" y="3476957"/>
+            <a:off x="2059632" y="4097681"/>
             <a:ext cx="0" cy="188719"/>
           </a:xfrm>
           <a:prstGeom prst="straightConnector1">
@@ -3933,7 +3934,7 @@
         </p:nvSpPr>
         <p:spPr>
           <a:xfrm>
-            <a:off x="536339" y="1352500"/>
+            <a:off x="1525674" y="1973224"/>
             <a:ext cx="393791" cy="106792"/>
           </a:xfrm>
           <a:prstGeom prst="rect">
@@ -3986,7 +3987,7 @@
         </p:nvSpPr>
         <p:spPr>
           <a:xfrm>
-            <a:off x="2485670" y="382618"/>
+            <a:off x="3475005" y="1003342"/>
             <a:ext cx="1256228" cy="1301519"/>
           </a:xfrm>
           <a:prstGeom prst="rect">
@@ -4072,7 +4073,7 @@
         </p:nvSpPr>
         <p:spPr>
           <a:xfrm>
-            <a:off x="2512366" y="402642"/>
+            <a:off x="3501701" y="1023366"/>
             <a:ext cx="468643" cy="106792"/>
           </a:xfrm>
           <a:prstGeom prst="rect">
@@ -4125,7 +4126,7 @@
         </p:nvSpPr>
         <p:spPr>
           <a:xfrm>
-            <a:off x="4115345" y="382617"/>
+            <a:off x="5104680" y="1003341"/>
             <a:ext cx="1256225" cy="1301519"/>
           </a:xfrm>
           <a:prstGeom prst="rect">
@@ -4223,7 +4224,7 @@
         </p:nvSpPr>
         <p:spPr>
           <a:xfrm>
-            <a:off x="4142042" y="411469"/>
+            <a:off x="5131377" y="1032193"/>
             <a:ext cx="468643" cy="106884"/>
           </a:xfrm>
           <a:prstGeom prst="rect">
@@ -4280,7 +4281,7 @@
         </p:nvCxnSpPr>
         <p:spPr>
           <a:xfrm flipV="1">
-            <a:off x="3741898" y="1033377"/>
+            <a:off x="4731233" y="1654101"/>
             <a:ext cx="373447" cy="1"/>
           </a:xfrm>
           <a:prstGeom prst="line">
@@ -4322,7 +4323,7 @@
         </p:nvSpPr>
         <p:spPr>
           <a:xfrm>
-            <a:off x="2467882" y="1967324"/>
+            <a:off x="3457217" y="2588048"/>
             <a:ext cx="1256227" cy="862212"/>
           </a:xfrm>
           <a:prstGeom prst="rect">
@@ -4403,7 +4404,7 @@
         </p:nvSpPr>
         <p:spPr>
           <a:xfrm>
-            <a:off x="2494578" y="1987348"/>
+            <a:off x="3483913" y="2608072"/>
             <a:ext cx="548737" cy="106790"/>
           </a:xfrm>
           <a:prstGeom prst="rect">
@@ -4456,7 +4457,7 @@
         </p:nvSpPr>
         <p:spPr>
           <a:xfrm>
-            <a:off x="4096597" y="1967324"/>
+            <a:off x="5085932" y="2588048"/>
             <a:ext cx="1257184" cy="862209"/>
           </a:xfrm>
           <a:prstGeom prst="rect">
@@ -4565,7 +4566,7 @@
         </p:nvCxnSpPr>
         <p:spPr>
           <a:xfrm flipV="1">
-            <a:off x="3724109" y="2398429"/>
+            <a:off x="4713444" y="3019153"/>
             <a:ext cx="372488" cy="1"/>
           </a:xfrm>
           <a:prstGeom prst="straightConnector1">
@@ -4609,7 +4610,7 @@
         </p:nvCxnSpPr>
         <p:spPr>
           <a:xfrm>
-            <a:off x="1630951" y="3891416"/>
+            <a:off x="2620286" y="4512140"/>
             <a:ext cx="836929" cy="0"/>
           </a:xfrm>
           <a:prstGeom prst="straightConnector1">
@@ -4651,7 +4652,7 @@
         </p:nvSpPr>
         <p:spPr>
           <a:xfrm>
-            <a:off x="2467880" y="3281155"/>
+            <a:off x="3457215" y="3901879"/>
             <a:ext cx="1483159" cy="1397845"/>
           </a:xfrm>
           <a:prstGeom prst="rect">
@@ -4744,7 +4745,7 @@
         </p:nvSpPr>
         <p:spPr>
           <a:xfrm>
-            <a:off x="2494577" y="3301178"/>
+            <a:off x="3483912" y="3921902"/>
             <a:ext cx="393791" cy="105966"/>
           </a:xfrm>
           <a:prstGeom prst="rect">
@@ -4797,7 +4798,7 @@
         </p:nvSpPr>
         <p:spPr>
           <a:xfrm>
-            <a:off x="3951039" y="3281155"/>
+            <a:off x="4940374" y="3901879"/>
             <a:ext cx="1454713" cy="1397845"/>
           </a:xfrm>
           <a:prstGeom prst="rect">
@@ -4893,7 +4894,7 @@
         </p:nvCxnSpPr>
         <p:spPr>
           <a:xfrm>
-            <a:off x="5353781" y="2398429"/>
+            <a:off x="6343116" y="3019153"/>
             <a:ext cx="1370627" cy="0"/>
           </a:xfrm>
           <a:prstGeom prst="straightConnector1">
@@ -4935,7 +4936,7 @@
         </p:nvSpPr>
         <p:spPr>
           <a:xfrm rot="16200000">
-            <a:off x="3858657" y="288588"/>
+            <a:off x="4847992" y="909312"/>
             <a:ext cx="186884" cy="240280"/>
           </a:xfrm>
           <a:prstGeom prst="flowChartOffpageConnector">
@@ -4989,7 +4990,7 @@
         </p:nvSpPr>
         <p:spPr>
           <a:xfrm rot="16200000">
-            <a:off x="2228981" y="269026"/>
+            <a:off x="3218316" y="889750"/>
             <a:ext cx="186884" cy="240280"/>
           </a:xfrm>
           <a:prstGeom prst="flowChartOffpageConnector">
@@ -5043,7 +5044,7 @@
         </p:nvSpPr>
         <p:spPr>
           <a:xfrm rot="16200000">
-            <a:off x="2234394" y="1853733"/>
+            <a:off x="3223729" y="2474457"/>
             <a:ext cx="186884" cy="240280"/>
           </a:xfrm>
           <a:prstGeom prst="flowChartOffpageConnector">
@@ -5097,7 +5098,7 @@
         </p:nvSpPr>
         <p:spPr>
           <a:xfrm>
-            <a:off x="5790609" y="1950899"/>
+            <a:off x="6779944" y="2571623"/>
             <a:ext cx="186884" cy="240280"/>
           </a:xfrm>
           <a:prstGeom prst="flowChartOffpageConnector">
@@ -5151,7 +5152,7 @@
         </p:nvSpPr>
         <p:spPr>
           <a:xfrm rot="16200000">
-            <a:off x="2209722" y="3166900"/>
+            <a:off x="3199057" y="3787624"/>
             <a:ext cx="186884" cy="240280"/>
           </a:xfrm>
           <a:prstGeom prst="flowChartOffpageConnector">
@@ -5205,7 +5206,7 @@
         </p:nvSpPr>
         <p:spPr>
           <a:xfrm rot="16200000">
-            <a:off x="267933" y="1218884"/>
+            <a:off x="1257268" y="1839608"/>
             <a:ext cx="186884" cy="240280"/>
           </a:xfrm>
           <a:prstGeom prst="flowChartOffpageConnector">
@@ -5259,7 +5260,7 @@
         </p:nvSpPr>
         <p:spPr>
           <a:xfrm>
-            <a:off x="5643612" y="2207796"/>
+            <a:off x="6632947" y="2828520"/>
             <a:ext cx="452047" cy="169277"/>
           </a:xfrm>
           <a:prstGeom prst="rect">
@@ -5294,7 +5295,7 @@
         </p:nvSpPr>
         <p:spPr>
           <a:xfrm>
-            <a:off x="6933487" y="143148"/>
+            <a:off x="7922822" y="763872"/>
             <a:ext cx="1196156" cy="321580"/>
           </a:xfrm>
           <a:prstGeom prst="rect">
@@ -5363,7 +5364,7 @@
         </p:nvSpPr>
         <p:spPr>
           <a:xfrm>
-            <a:off x="4096597" y="2829534"/>
+            <a:off x="5085932" y="3450258"/>
             <a:ext cx="1249962" cy="118721"/>
           </a:xfrm>
           <a:prstGeom prst="rect">
@@ -5416,7 +5417,7 @@
         </p:nvSpPr>
         <p:spPr>
           <a:xfrm>
-            <a:off x="3951039" y="4679000"/>
+            <a:off x="4940374" y="5299724"/>
             <a:ext cx="1454713" cy="135515"/>
           </a:xfrm>
           <a:prstGeom prst="rect">
@@ -5469,7 +5470,7 @@
         </p:nvSpPr>
         <p:spPr>
           <a:xfrm>
-            <a:off x="6934365" y="929641"/>
+            <a:off x="7923700" y="1550365"/>
             <a:ext cx="1196156" cy="500584"/>
           </a:xfrm>
           <a:prstGeom prst="rect">
@@ -5544,7 +5545,7 @@
         </p:nvCxnSpPr>
         <p:spPr>
           <a:xfrm>
-            <a:off x="7531565" y="1472148"/>
+            <a:off x="8520900" y="2092872"/>
             <a:ext cx="0" cy="294481"/>
           </a:xfrm>
           <a:prstGeom prst="straightConnector1">
@@ -5587,7 +5588,7 @@
         </p:nvSpPr>
         <p:spPr>
           <a:xfrm>
-            <a:off x="7065871" y="2776537"/>
+            <a:off x="8055206" y="3397261"/>
             <a:ext cx="931388" cy="206948"/>
           </a:xfrm>
           <a:prstGeom prst="rect">
@@ -5646,7 +5647,7 @@
         </p:nvSpPr>
         <p:spPr>
           <a:xfrm rot="16200000">
-            <a:off x="6632644" y="429057"/>
+            <a:off x="7621979" y="1049781"/>
             <a:ext cx="186884" cy="240280"/>
           </a:xfrm>
           <a:prstGeom prst="flowChartOffpageConnector">
@@ -5700,7 +5701,7 @@
         </p:nvSpPr>
         <p:spPr>
           <a:xfrm rot="16200000">
-            <a:off x="6632644" y="1976210"/>
+            <a:off x="7621979" y="2596934"/>
             <a:ext cx="186884" cy="240280"/>
           </a:xfrm>
           <a:prstGeom prst="flowChartOffpageConnector">
@@ -5754,7 +5755,7 @@
         </p:nvSpPr>
         <p:spPr>
           <a:xfrm>
-            <a:off x="6874294" y="3241987"/>
+            <a:off x="7863629" y="3862711"/>
             <a:ext cx="1314542" cy="740680"/>
           </a:xfrm>
           <a:prstGeom prst="rect">
@@ -5816,7 +5817,7 @@
         </p:nvSpPr>
         <p:spPr>
           <a:xfrm>
-            <a:off x="6933487" y="3578390"/>
+            <a:off x="7922822" y="4199114"/>
             <a:ext cx="1196156" cy="356069"/>
           </a:xfrm>
           <a:prstGeom prst="rect">
@@ -5875,7 +5876,7 @@
         </p:nvSpPr>
         <p:spPr>
           <a:xfrm>
-            <a:off x="7141181" y="3760923"/>
+            <a:off x="8130516" y="4381647"/>
             <a:ext cx="780768" cy="149563"/>
           </a:xfrm>
           <a:prstGeom prst="rect">
@@ -5934,7 +5935,7 @@
         </p:nvSpPr>
         <p:spPr>
           <a:xfrm>
-            <a:off x="8594372" y="1985364"/>
+            <a:off x="9583707" y="2606088"/>
             <a:ext cx="993676" cy="740680"/>
           </a:xfrm>
           <a:prstGeom prst="rect">
@@ -5995,7 +5996,7 @@
         </p:nvGrpSpPr>
         <p:grpSpPr>
           <a:xfrm>
-            <a:off x="8757367" y="2237784"/>
+            <a:off x="9746702" y="2858508"/>
             <a:ext cx="680794" cy="433282"/>
             <a:chOff x="8227377" y="3019807"/>
             <a:chExt cx="680794" cy="785917"/>
@@ -6171,7 +6172,7 @@
         </p:nvCxnSpPr>
         <p:spPr>
           <a:xfrm>
-            <a:off x="8129643" y="2477517"/>
+            <a:off x="9118978" y="3098241"/>
             <a:ext cx="627724" cy="0"/>
           </a:xfrm>
           <a:prstGeom prst="straightConnector1">
@@ -6214,7 +6215,7 @@
         </p:nvSpPr>
         <p:spPr>
           <a:xfrm>
-            <a:off x="6874294" y="4154219"/>
+            <a:off x="7863629" y="4774943"/>
             <a:ext cx="1314542" cy="1904457"/>
           </a:xfrm>
           <a:prstGeom prst="rect">
@@ -6276,7 +6277,7 @@
         </p:nvSpPr>
         <p:spPr>
           <a:xfrm>
-            <a:off x="6933487" y="4604573"/>
+            <a:off x="7922822" y="5225297"/>
             <a:ext cx="1196156" cy="1391900"/>
           </a:xfrm>
           <a:prstGeom prst="rect">
@@ -6331,7 +6332,7 @@
         </p:nvSpPr>
         <p:spPr>
           <a:xfrm>
-            <a:off x="7006259" y="4932631"/>
+            <a:off x="7995594" y="5553355"/>
             <a:ext cx="1050612" cy="336133"/>
           </a:xfrm>
           <a:prstGeom prst="rect">
@@ -6390,7 +6391,7 @@
         </p:nvSpPr>
         <p:spPr>
           <a:xfrm>
-            <a:off x="2467880" y="4911207"/>
+            <a:off x="3457215" y="5531931"/>
             <a:ext cx="2937872" cy="728112"/>
           </a:xfrm>
           <a:prstGeom prst="rect">
@@ -6484,7 +6485,7 @@
         </p:nvSpPr>
         <p:spPr>
           <a:xfrm>
-            <a:off x="2494576" y="4931230"/>
+            <a:off x="3483911" y="5551954"/>
             <a:ext cx="393792" cy="101326"/>
           </a:xfrm>
           <a:prstGeom prst="rect">
@@ -6537,7 +6538,7 @@
         </p:nvSpPr>
         <p:spPr>
           <a:xfrm>
-            <a:off x="6724408" y="2216984"/>
+            <a:off x="7713743" y="2837708"/>
             <a:ext cx="202062" cy="895686"/>
           </a:xfrm>
           <a:prstGeom prst="rect">
@@ -6591,7 +6592,7 @@
         </p:nvCxnSpPr>
         <p:spPr>
           <a:xfrm flipV="1">
-            <a:off x="5405752" y="2530534"/>
+            <a:off x="6395087" y="3151258"/>
             <a:ext cx="1318656" cy="1318793"/>
           </a:xfrm>
           <a:prstGeom prst="bentConnector3">
@@ -6635,7 +6636,7 @@
         </p:nvCxnSpPr>
         <p:spPr>
           <a:xfrm flipV="1">
-            <a:off x="5405752" y="2682744"/>
+            <a:off x="6395087" y="3303468"/>
             <a:ext cx="1318656" cy="2312605"/>
           </a:xfrm>
           <a:prstGeom prst="bentConnector3">
@@ -6682,7 +6683,7 @@
         </p:nvCxnSpPr>
         <p:spPr>
           <a:xfrm flipH="1">
-            <a:off x="5405752" y="5100698"/>
+            <a:off x="6395087" y="5721422"/>
             <a:ext cx="1600507" cy="0"/>
           </a:xfrm>
           <a:prstGeom prst="line">
@@ -6725,7 +6726,7 @@
         </p:nvSpPr>
         <p:spPr>
           <a:xfrm>
-            <a:off x="7006259" y="5334429"/>
+            <a:off x="7995594" y="5955153"/>
             <a:ext cx="1050612" cy="611196"/>
           </a:xfrm>
           <a:prstGeom prst="rect">
@@ -6786,10 +6787,10 @@
       </p:sp>
       <p:sp>
         <p:nvSpPr>
-          <p:cNvPr id="90" name="Rectangle 89">
-            <a:extLst>
-              <a:ext uri="{FF2B5EF4-FFF2-40B4-BE49-F238E27FC236}">
-                <a16:creationId xmlns:a16="http://schemas.microsoft.com/office/drawing/2014/main" id="{E9A11068-2F85-B8AC-D139-7A94970A6B6F}"/>
+          <p:cNvPr id="131" name="Flowchart: Off-page Connector 130">
+            <a:extLst>
+              <a:ext uri="{FF2B5EF4-FFF2-40B4-BE49-F238E27FC236}">
+                <a16:creationId xmlns:a16="http://schemas.microsoft.com/office/drawing/2014/main" id="{8DB5FFE1-B20F-BC4A-F98A-1DB0CDA11B3B}"/>
               </a:ext>
             </a:extLst>
           </p:cNvPr>
@@ -6797,16 +6798,16 @@
           <p:nvPr/>
         </p:nvSpPr>
         <p:spPr>
-          <a:xfrm>
-            <a:off x="9311341" y="3827859"/>
-            <a:ext cx="2215437" cy="509053"/>
-          </a:xfrm>
-          <a:prstGeom prst="rect">
+          <a:xfrm rot="16200000">
+            <a:off x="3199057" y="5402491"/>
+            <a:ext cx="186884" cy="240280"/>
+          </a:xfrm>
+          <a:prstGeom prst="flowChartOffpageConnector">
             <a:avLst/>
           </a:prstGeom>
           <a:solidFill>
-            <a:schemeClr val="bg1">
-              <a:lumMod val="85000"/>
+            <a:schemeClr val="accent6">
+              <a:lumMod val="75000"/>
             </a:schemeClr>
           </a:solidFill>
         </p:spPr>
@@ -6827,15 +6828,65 @@
           </a:fontRef>
         </p:style>
         <p:txBody>
-          <a:bodyPr lIns="0" tIns="45720" rIns="0" bIns="0" rtlCol="0" anchor="t"/>
-          <a:lstStyle/>
-          <a:p>
-            <a:pPr algn="ctr"/>
-            <a:r>
-              <a:rPr lang="en-US" sz="1100" b="1" dirty="0"/>
-              <a:t>User-facing LLM</a:t>
-            </a:r>
-          </a:p>
+          <a:bodyPr vert="vert" rtlCol="0" anchor="ctr"/>
+          <a:lstStyle/>
+          <a:p>
+            <a:pPr algn="ctr"/>
+            <a:r>
+              <a:rPr lang="en-US" sz="1400" b="1" dirty="0"/>
+              <a:t>8</a:t>
+            </a:r>
+          </a:p>
+        </p:txBody>
+      </p:sp>
+      <p:sp>
+        <p:nvSpPr>
+          <p:cNvPr id="183" name="Rectangle 182">
+            <a:extLst>
+              <a:ext uri="{FF2B5EF4-FFF2-40B4-BE49-F238E27FC236}">
+                <a16:creationId xmlns:a16="http://schemas.microsoft.com/office/drawing/2014/main" id="{9E492C8C-E2EB-4DCC-8FC4-C53AECC1962C}"/>
+              </a:ext>
+            </a:extLst>
+          </p:cNvPr>
+          <p:cNvSpPr/>
+          <p:nvPr/>
+        </p:nvSpPr>
+        <p:spPr>
+          <a:xfrm>
+            <a:off x="9583707" y="5769777"/>
+            <a:ext cx="993676" cy="796571"/>
+          </a:xfrm>
+          <a:prstGeom prst="rect">
+            <a:avLst/>
+          </a:prstGeom>
+          <a:solidFill>
+            <a:schemeClr val="bg1">
+              <a:lumMod val="95000"/>
+            </a:schemeClr>
+          </a:solidFill>
+          <a:ln>
+            <a:prstDash val="dash"/>
+          </a:ln>
+        </p:spPr>
+        <p:style>
+          <a:lnRef idx="2">
+            <a:schemeClr val="accent1">
+              <a:shade val="15000"/>
+            </a:schemeClr>
+          </a:lnRef>
+          <a:fillRef idx="1">
+            <a:schemeClr val="accent1"/>
+          </a:fillRef>
+          <a:effectRef idx="0">
+            <a:schemeClr val="accent1"/>
+          </a:effectRef>
+          <a:fontRef idx="minor">
+            <a:schemeClr val="lt1"/>
+          </a:fontRef>
+        </p:style>
+        <p:txBody>
+          <a:bodyPr rtlCol="0" anchor="t"/>
+          <a:lstStyle/>
           <a:p>
             <a:pPr algn="ctr"/>
             <a:r>
@@ -6844,17 +6895,180 @@
                   <a:schemeClr val="tx1"/>
                 </a:solidFill>
               </a:rPr>
-              <a:t>📚 …</a:t>
-            </a:r>
-          </a:p>
-        </p:txBody>
-      </p:sp>
-      <p:sp>
-        <p:nvSpPr>
-          <p:cNvPr id="92" name="Rectangle 91">
-            <a:extLst>
-              <a:ext uri="{FF2B5EF4-FFF2-40B4-BE49-F238E27FC236}">
-                <a16:creationId xmlns:a16="http://schemas.microsoft.com/office/drawing/2014/main" id="{D286EDA6-6361-ED43-DE75-245CF0C6A8BC}"/>
+              <a:t>Host GPU</a:t>
+            </a:r>
+          </a:p>
+        </p:txBody>
+      </p:sp>
+      <p:cxnSp>
+        <p:nvCxnSpPr>
+          <p:cNvPr id="188" name="Straight Arrow Connector 187">
+            <a:extLst>
+              <a:ext uri="{FF2B5EF4-FFF2-40B4-BE49-F238E27FC236}">
+                <a16:creationId xmlns:a16="http://schemas.microsoft.com/office/drawing/2014/main" id="{0F362DED-BF34-5AF8-243D-B31EC86503E7}"/>
+              </a:ext>
+            </a:extLst>
+          </p:cNvPr>
+          <p:cNvCxnSpPr>
+            <a:cxnSpLocks/>
+          </p:cNvCxnSpPr>
+          <p:nvPr/>
+        </p:nvCxnSpPr>
+        <p:spPr>
+          <a:xfrm>
+            <a:off x="9118978" y="6261931"/>
+            <a:ext cx="627724" cy="0"/>
+          </a:xfrm>
+          <a:prstGeom prst="straightConnector1">
+            <a:avLst/>
+          </a:prstGeom>
+          <a:ln w="12700">
+            <a:solidFill>
+              <a:schemeClr val="tx1"/>
+            </a:solidFill>
+            <a:headEnd type="arrow"/>
+            <a:tailEnd type="arrow"/>
+          </a:ln>
+        </p:spPr>
+        <p:style>
+          <a:lnRef idx="1">
+            <a:schemeClr val="accent1"/>
+          </a:lnRef>
+          <a:fillRef idx="0">
+            <a:schemeClr val="accent1"/>
+          </a:fillRef>
+          <a:effectRef idx="0">
+            <a:schemeClr val="accent1"/>
+          </a:effectRef>
+          <a:fontRef idx="minor">
+            <a:schemeClr val="tx1"/>
+          </a:fontRef>
+        </p:style>
+      </p:cxnSp>
+      <p:pic>
+        <p:nvPicPr>
+          <p:cNvPr id="1024" name="Picture 2" descr="Gpu - Free computer icons">
+            <a:extLst>
+              <a:ext uri="{FF2B5EF4-FFF2-40B4-BE49-F238E27FC236}">
+                <a16:creationId xmlns:a16="http://schemas.microsoft.com/office/drawing/2014/main" id="{720321CC-3759-1DB6-FCD7-CF1E417DC114}"/>
+              </a:ext>
+            </a:extLst>
+          </p:cNvPr>
+          <p:cNvPicPr>
+            <a:picLocks noChangeAspect="1" noChangeArrowheads="1"/>
+          </p:cNvPicPr>
+          <p:nvPr/>
+        </p:nvPicPr>
+        <p:blipFill>
+          <a:blip r:embed="rId2">
+            <a:extLst>
+              <a:ext uri="{28A0092B-C50C-407E-A947-70E740481C1C}">
+                <a14:useLocalDpi xmlns:a14="http://schemas.microsoft.com/office/drawing/2010/main" val="0"/>
+              </a:ext>
+            </a:extLst>
+          </a:blip>
+          <a:srcRect/>
+          <a:stretch>
+            <a:fillRect/>
+          </a:stretch>
+        </p:blipFill>
+        <p:spPr bwMode="auto">
+          <a:xfrm>
+            <a:off x="9791515" y="5955153"/>
+            <a:ext cx="591168" cy="591168"/>
+          </a:xfrm>
+          <a:prstGeom prst="rect">
+            <a:avLst/>
+          </a:prstGeom>
+          <a:noFill/>
+          <a:extLst>
+            <a:ext uri="{909E8E84-426E-40DD-AFC4-6F175D3DCCD1}">
+              <a14:hiddenFill xmlns:a14="http://schemas.microsoft.com/office/drawing/2010/main">
+                <a:solidFill>
+                  <a:srgbClr val="FFFFFF"/>
+                </a:solidFill>
+              </a14:hiddenFill>
+            </a:ext>
+          </a:extLst>
+        </p:spPr>
+      </p:pic>
+      <p:sp>
+        <p:nvSpPr>
+          <p:cNvPr id="1025" name="Title 1024">
+            <a:extLst>
+              <a:ext uri="{FF2B5EF4-FFF2-40B4-BE49-F238E27FC236}">
+                <a16:creationId xmlns:a16="http://schemas.microsoft.com/office/drawing/2014/main" id="{D6F6158F-D78B-7FB3-5885-9E394282A4F9}"/>
+              </a:ext>
+            </a:extLst>
+          </p:cNvPr>
+          <p:cNvSpPr>
+            <a:spLocks noGrp="1"/>
+          </p:cNvSpPr>
+          <p:nvPr>
+            <p:ph type="title"/>
+          </p:nvPr>
+        </p:nvSpPr>
+        <p:spPr>
+          <a:xfrm>
+            <a:off x="115735" y="64032"/>
+            <a:ext cx="4615498" cy="476956"/>
+          </a:xfrm>
+        </p:spPr>
+        <p:txBody>
+          <a:bodyPr anchor="t">
+            <a:noAutofit/>
+          </a:bodyPr>
+          <a:lstStyle/>
+          <a:p>
+            <a:r>
+              <a:rPr lang="en-US" sz="4000" dirty="0"/>
+              <a:t>Priming Phase</a:t>
+            </a:r>
+          </a:p>
+        </p:txBody>
+      </p:sp>
+    </p:spTree>
+    <p:extLst>
+      <p:ext uri="{BB962C8B-B14F-4D97-AF65-F5344CB8AC3E}">
+        <p14:creationId xmlns:p14="http://schemas.microsoft.com/office/powerpoint/2010/main" val="467536827"/>
+      </p:ext>
+    </p:extLst>
+  </p:cSld>
+  <p:clrMapOvr>
+    <a:masterClrMapping/>
+  </p:clrMapOvr>
+</p:sld>
+</file>
+
+<file path=ppt/slides/slide2.xml><?xml version="1.0" encoding="utf-8"?>
+<p:sld xmlns:a="http://schemas.openxmlformats.org/drawingml/2006/main" xmlns:r="http://schemas.openxmlformats.org/officeDocument/2006/relationships" xmlns:p="http://schemas.openxmlformats.org/presentationml/2006/main">
+  <p:cSld>
+    <p:spTree>
+      <p:nvGrpSpPr>
+        <p:cNvPr id="1" name="">
+          <a:extLst>
+            <a:ext uri="{FF2B5EF4-FFF2-40B4-BE49-F238E27FC236}">
+              <a16:creationId xmlns:a16="http://schemas.microsoft.com/office/drawing/2014/main" id="{232DE0EE-A8BD-8F30-7418-87BB25146CDB}"/>
+            </a:ext>
+          </a:extLst>
+        </p:cNvPr>
+        <p:cNvGrpSpPr/>
+        <p:nvPr/>
+      </p:nvGrpSpPr>
+      <p:grpSpPr>
+        <a:xfrm>
+          <a:off x="0" y="0"/>
+          <a:ext cx="0" cy="0"/>
+          <a:chOff x="0" y="0"/>
+          <a:chExt cx="0" cy="0"/>
+        </a:xfrm>
+      </p:grpSpPr>
+      <p:sp>
+        <p:nvSpPr>
+          <p:cNvPr id="50" name="Rectangle 49">
+            <a:extLst>
+              <a:ext uri="{FF2B5EF4-FFF2-40B4-BE49-F238E27FC236}">
+                <a16:creationId xmlns:a16="http://schemas.microsoft.com/office/drawing/2014/main" id="{D620D2BF-387D-D4BF-5090-B9D7F5E1A177}"/>
               </a:ext>
             </a:extLst>
           </p:cNvPr>
@@ -6863,14 +7077,17 @@
         </p:nvSpPr>
         <p:spPr>
           <a:xfrm>
-            <a:off x="9706330" y="573017"/>
-            <a:ext cx="1947624" cy="779483"/>
+            <a:off x="4211972" y="5000371"/>
+            <a:ext cx="4028187" cy="1650802"/>
           </a:xfrm>
           <a:prstGeom prst="rect">
             <a:avLst/>
           </a:prstGeom>
           <a:solidFill>
-            <a:srgbClr val="7030A0"/>
+            <a:schemeClr val="accent1">
+              <a:lumMod val="40000"/>
+              <a:lumOff val="60000"/>
+            </a:schemeClr>
           </a:solidFill>
         </p:spPr>
         <p:style>
@@ -6890,46 +7107,914 @@
           </a:fontRef>
         </p:style>
         <p:txBody>
+          <a:bodyPr lIns="0" tIns="45720" rIns="0" bIns="0" rtlCol="0" anchor="b"/>
+          <a:lstStyle/>
+          <a:p>
+            <a:pPr algn="ctr"/>
+            <a:r>
+              <a:rPr lang="en-US" sz="900" b="1" dirty="0"/>
+              <a:t>🐳 Docker Container</a:t>
+            </a:r>
+          </a:p>
+          <a:p>
+            <a:pPr algn="ctr"/>
+            <a:r>
+              <a:rPr lang="en-US" sz="900" i="1" dirty="0"/>
+              <a:t>“ollama/ollama:latest”</a:t>
+            </a:r>
+          </a:p>
+          <a:p>
+            <a:pPr algn="ctr"/>
+            <a:endParaRPr lang="en-US" sz="200" i="1" dirty="0"/>
+          </a:p>
+        </p:txBody>
+      </p:sp>
+      <p:sp>
+        <p:nvSpPr>
+          <p:cNvPr id="51" name="Rectangle 50">
+            <a:extLst>
+              <a:ext uri="{FF2B5EF4-FFF2-40B4-BE49-F238E27FC236}">
+                <a16:creationId xmlns:a16="http://schemas.microsoft.com/office/drawing/2014/main" id="{E3B161CA-3951-5003-8932-A211335401FC}"/>
+              </a:ext>
+            </a:extLst>
+          </p:cNvPr>
+          <p:cNvSpPr/>
+          <p:nvPr/>
+        </p:nvSpPr>
+        <p:spPr>
+          <a:xfrm>
+            <a:off x="4271165" y="5000370"/>
+            <a:ext cx="3714012" cy="1313663"/>
+          </a:xfrm>
+          <a:prstGeom prst="rect">
+            <a:avLst/>
+          </a:prstGeom>
+          <a:solidFill>
+            <a:schemeClr val="accent2">
+              <a:lumMod val="60000"/>
+              <a:lumOff val="40000"/>
+            </a:schemeClr>
+          </a:solidFill>
+        </p:spPr>
+        <p:style>
+          <a:lnRef idx="2">
+            <a:schemeClr val="accent1">
+              <a:shade val="15000"/>
+            </a:schemeClr>
+          </a:lnRef>
+          <a:fillRef idx="1">
+            <a:schemeClr val="accent1"/>
+          </a:fillRef>
+          <a:effectRef idx="0">
+            <a:schemeClr val="accent1"/>
+          </a:effectRef>
+          <a:fontRef idx="minor">
+            <a:schemeClr val="lt1"/>
+          </a:fontRef>
+        </p:style>
+        <p:txBody>
+          <a:bodyPr lIns="0" tIns="0" rIns="0" bIns="0" rtlCol="0" anchor="b"/>
+          <a:lstStyle/>
+          <a:p>
+            <a:pPr algn="ctr"/>
+            <a:r>
+              <a:rPr lang="en-US" sz="1600" dirty="0"/>
+              <a:t>Ollama</a:t>
+            </a:r>
+          </a:p>
+        </p:txBody>
+      </p:sp>
+      <p:sp>
+        <p:nvSpPr>
+          <p:cNvPr id="52" name="Rectangle 51">
+            <a:extLst>
+              <a:ext uri="{FF2B5EF4-FFF2-40B4-BE49-F238E27FC236}">
+                <a16:creationId xmlns:a16="http://schemas.microsoft.com/office/drawing/2014/main" id="{562CBA80-95B2-D658-D869-139D92552C8F}"/>
+              </a:ext>
+            </a:extLst>
+          </p:cNvPr>
+          <p:cNvSpPr/>
+          <p:nvPr/>
+        </p:nvSpPr>
+        <p:spPr>
+          <a:xfrm>
+            <a:off x="5591241" y="5000369"/>
+            <a:ext cx="1020305" cy="1100081"/>
+          </a:xfrm>
+          <a:prstGeom prst="rect">
+            <a:avLst/>
+          </a:prstGeom>
+          <a:solidFill>
+            <a:schemeClr val="accent2">
+              <a:lumMod val="75000"/>
+            </a:schemeClr>
+          </a:solidFill>
+        </p:spPr>
+        <p:style>
+          <a:lnRef idx="2">
+            <a:schemeClr val="accent1">
+              <a:shade val="15000"/>
+            </a:schemeClr>
+          </a:lnRef>
+          <a:fillRef idx="1">
+            <a:schemeClr val="accent1"/>
+          </a:fillRef>
+          <a:effectRef idx="0">
+            <a:schemeClr val="accent1"/>
+          </a:effectRef>
+          <a:fontRef idx="minor">
+            <a:schemeClr val="lt1"/>
+          </a:fontRef>
+        </p:style>
+        <p:txBody>
           <a:bodyPr lIns="0" tIns="0" rIns="0" bIns="0" rtlCol="0" anchor="ctr"/>
           <a:lstStyle/>
           <a:p>
             <a:pPr algn="ctr"/>
             <a:r>
+              <a:rPr lang="en-US" sz="1200" b="1" dirty="0"/>
+              <a:t>Embedding Model</a:t>
+            </a:r>
+            <a:endParaRPr lang="en-US" sz="900" b="1" dirty="0"/>
+          </a:p>
+          <a:p>
+            <a:pPr algn="ctr"/>
+            <a:r>
+              <a:rPr lang="en-US" sz="900" dirty="0"/>
+              <a:t>📚 </a:t>
+            </a:r>
+            <a:r>
+              <a:rPr lang="en-US" sz="900" b="1" u="sng" dirty="0"/>
+              <a:t>nomic-embed-</a:t>
+            </a:r>
+          </a:p>
+          <a:p>
+            <a:pPr algn="ctr"/>
+            <a:r>
+              <a:rPr lang="en-US" sz="900" b="1" u="sng" dirty="0"/>
+              <a:t>text-v1.5</a:t>
+            </a:r>
+          </a:p>
+        </p:txBody>
+      </p:sp>
+      <p:sp>
+        <p:nvSpPr>
+          <p:cNvPr id="89" name="Rectangle 88">
+            <a:extLst>
+              <a:ext uri="{FF2B5EF4-FFF2-40B4-BE49-F238E27FC236}">
+                <a16:creationId xmlns:a16="http://schemas.microsoft.com/office/drawing/2014/main" id="{609F7108-FF93-609D-A945-2510E83DD8FF}"/>
+              </a:ext>
+            </a:extLst>
+          </p:cNvPr>
+          <p:cNvSpPr/>
+          <p:nvPr/>
+        </p:nvSpPr>
+        <p:spPr>
+          <a:xfrm>
+            <a:off x="6693641" y="5000367"/>
+            <a:ext cx="1222081" cy="1100083"/>
+          </a:xfrm>
+          <a:prstGeom prst="rect">
+            <a:avLst/>
+          </a:prstGeom>
+          <a:solidFill>
+            <a:schemeClr val="accent2">
+              <a:lumMod val="75000"/>
+            </a:schemeClr>
+          </a:solidFill>
+        </p:spPr>
+        <p:style>
+          <a:lnRef idx="2">
+            <a:schemeClr val="accent1">
+              <a:shade val="15000"/>
+            </a:schemeClr>
+          </a:lnRef>
+          <a:fillRef idx="1">
+            <a:schemeClr val="accent1"/>
+          </a:fillRef>
+          <a:effectRef idx="0">
+            <a:schemeClr val="accent1"/>
+          </a:effectRef>
+          <a:fontRef idx="minor">
+            <a:schemeClr val="lt1"/>
+          </a:fontRef>
+        </p:style>
+        <p:txBody>
+          <a:bodyPr lIns="0" tIns="0" rIns="0" bIns="0" rtlCol="0" anchor="ctr"/>
+          <a:lstStyle/>
+          <a:p>
+            <a:pPr algn="ctr"/>
+            <a:r>
+              <a:rPr lang="en-US" sz="1600" b="1" i="1" dirty="0"/>
+              <a:t>SQL Emitter</a:t>
+            </a:r>
+          </a:p>
+          <a:p>
+            <a:pPr algn="ctr"/>
+            <a:r>
+              <a:rPr lang="en-US" sz="800" b="1" i="1" dirty="0"/>
+              <a:t>(Local LLM)</a:t>
+            </a:r>
+          </a:p>
+          <a:p>
+            <a:pPr algn="ctr"/>
+            <a:endParaRPr lang="en-US" sz="800" b="1" i="1" dirty="0"/>
+          </a:p>
+          <a:p>
+            <a:pPr algn="ctr"/>
+            <a:r>
+              <a:rPr lang="en-US" sz="900" dirty="0"/>
+              <a:t>📚 </a:t>
+            </a:r>
+            <a:r>
+              <a:rPr lang="en-US" sz="900" b="1" u="sng" dirty="0"/>
+              <a:t>Qwen2.5-Coder:7b</a:t>
+            </a:r>
+          </a:p>
+        </p:txBody>
+      </p:sp>
+      <p:sp>
+        <p:nvSpPr>
+          <p:cNvPr id="2" name="Rectangle 1">
+            <a:extLst>
+              <a:ext uri="{FF2B5EF4-FFF2-40B4-BE49-F238E27FC236}">
+                <a16:creationId xmlns:a16="http://schemas.microsoft.com/office/drawing/2014/main" id="{81D6A0B9-4705-2CEA-1EC6-D1806A8968BE}"/>
+              </a:ext>
+            </a:extLst>
+          </p:cNvPr>
+          <p:cNvSpPr/>
+          <p:nvPr/>
+        </p:nvSpPr>
+        <p:spPr>
+          <a:xfrm>
+            <a:off x="7985177" y="5000371"/>
+            <a:ext cx="202062" cy="1313662"/>
+          </a:xfrm>
+          <a:prstGeom prst="rect">
+            <a:avLst/>
+          </a:prstGeom>
+          <a:solidFill>
+            <a:srgbClr val="B17ED8"/>
+          </a:solidFill>
+        </p:spPr>
+        <p:style>
+          <a:lnRef idx="2">
+            <a:schemeClr val="accent1">
+              <a:shade val="15000"/>
+            </a:schemeClr>
+          </a:lnRef>
+          <a:fillRef idx="1">
+            <a:schemeClr val="accent1"/>
+          </a:fillRef>
+          <a:effectRef idx="0">
+            <a:schemeClr val="accent1"/>
+          </a:effectRef>
+          <a:fontRef idx="minor">
+            <a:schemeClr val="lt1"/>
+          </a:fontRef>
+        </p:style>
+        <p:txBody>
+          <a:bodyPr vert="vert270" lIns="0" tIns="0" rIns="0" bIns="0" rtlCol="0" anchor="ctr"/>
+          <a:lstStyle/>
+          <a:p>
+            <a:pPr algn="ctr"/>
+            <a:r>
+              <a:rPr lang="en-US" sz="900" dirty="0"/>
+              <a:t>📚 httpx</a:t>
+            </a:r>
+          </a:p>
+        </p:txBody>
+      </p:sp>
+      <p:sp>
+        <p:nvSpPr>
+          <p:cNvPr id="3" name="Rectangle 2">
+            <a:extLst>
+              <a:ext uri="{FF2B5EF4-FFF2-40B4-BE49-F238E27FC236}">
+                <a16:creationId xmlns:a16="http://schemas.microsoft.com/office/drawing/2014/main" id="{2624562D-A1F3-CEF9-451E-331CC6461D6E}"/>
+              </a:ext>
+            </a:extLst>
+          </p:cNvPr>
+          <p:cNvSpPr/>
+          <p:nvPr/>
+        </p:nvSpPr>
+        <p:spPr>
+          <a:xfrm>
+            <a:off x="3114580" y="733345"/>
+            <a:ext cx="398031" cy="401369"/>
+          </a:xfrm>
+          <a:prstGeom prst="rect">
+            <a:avLst/>
+          </a:prstGeom>
+          <a:solidFill>
+            <a:schemeClr val="bg1">
+              <a:lumMod val="85000"/>
+            </a:schemeClr>
+          </a:solidFill>
+        </p:spPr>
+        <p:style>
+          <a:lnRef idx="2">
+            <a:schemeClr val="accent1">
+              <a:shade val="15000"/>
+            </a:schemeClr>
+          </a:lnRef>
+          <a:fillRef idx="1">
+            <a:schemeClr val="accent1"/>
+          </a:fillRef>
+          <a:effectRef idx="0">
+            <a:schemeClr val="accent1"/>
+          </a:effectRef>
+          <a:fontRef idx="minor">
+            <a:schemeClr val="lt1"/>
+          </a:fontRef>
+        </p:style>
+        <p:txBody>
+          <a:bodyPr lIns="0" tIns="45720" rIns="0" bIns="0" rtlCol="0" anchor="t"/>
+          <a:lstStyle/>
+          <a:p>
+            <a:pPr algn="ctr"/>
+            <a:r>
+              <a:rPr lang="en-US" sz="1100" b="1" dirty="0"/>
+              <a:t>Text Box</a:t>
+            </a:r>
+            <a:endParaRPr lang="en-US" sz="1200" dirty="0">
+              <a:solidFill>
+                <a:schemeClr val="tx1"/>
+              </a:solidFill>
+            </a:endParaRPr>
+          </a:p>
+        </p:txBody>
+      </p:sp>
+      <p:sp>
+        <p:nvSpPr>
+          <p:cNvPr id="5" name="Rectangle 4">
+            <a:extLst>
+              <a:ext uri="{FF2B5EF4-FFF2-40B4-BE49-F238E27FC236}">
+                <a16:creationId xmlns:a16="http://schemas.microsoft.com/office/drawing/2014/main" id="{377B6516-346C-8990-ACB5-79355B120195}"/>
+              </a:ext>
+            </a:extLst>
+          </p:cNvPr>
+          <p:cNvSpPr/>
+          <p:nvPr/>
+        </p:nvSpPr>
+        <p:spPr>
+          <a:xfrm>
+            <a:off x="1791433" y="733345"/>
+            <a:ext cx="1116053" cy="401369"/>
+          </a:xfrm>
+          <a:prstGeom prst="rect">
+            <a:avLst/>
+          </a:prstGeom>
+          <a:solidFill>
+            <a:schemeClr val="bg1">
+              <a:lumMod val="85000"/>
+            </a:schemeClr>
+          </a:solidFill>
+        </p:spPr>
+        <p:style>
+          <a:lnRef idx="2">
+            <a:schemeClr val="accent1">
+              <a:shade val="15000"/>
+            </a:schemeClr>
+          </a:lnRef>
+          <a:fillRef idx="1">
+            <a:schemeClr val="accent1"/>
+          </a:fillRef>
+          <a:effectRef idx="0">
+            <a:schemeClr val="accent1"/>
+          </a:effectRef>
+          <a:fontRef idx="minor">
+            <a:schemeClr val="lt1"/>
+          </a:fontRef>
+        </p:style>
+        <p:txBody>
+          <a:bodyPr lIns="0" tIns="45720" rIns="0" bIns="0" rtlCol="0" anchor="t"/>
+          <a:lstStyle/>
+          <a:p>
+            <a:pPr algn="ctr"/>
+            <a:r>
+              <a:rPr lang="en-US" sz="1100" b="1" dirty="0">
+                <a:solidFill>
+                  <a:schemeClr val="tx1"/>
+                </a:solidFill>
+              </a:rPr>
+              <a:t>User Input </a:t>
+            </a:r>
+          </a:p>
+          <a:p>
+            <a:pPr algn="ctr"/>
+            <a:r>
+              <a:rPr lang="en-US" sz="800" b="1" dirty="0">
+                <a:solidFill>
+                  <a:schemeClr val="tx1"/>
+                </a:solidFill>
+              </a:rPr>
+              <a:t>(Browser)</a:t>
+            </a:r>
+          </a:p>
+        </p:txBody>
+      </p:sp>
+      <p:sp>
+        <p:nvSpPr>
+          <p:cNvPr id="6" name="Rectangle 5">
+            <a:extLst>
+              <a:ext uri="{FF2B5EF4-FFF2-40B4-BE49-F238E27FC236}">
+                <a16:creationId xmlns:a16="http://schemas.microsoft.com/office/drawing/2014/main" id="{FDB002BE-836F-8408-1F21-4AD91EC21A2B}"/>
+              </a:ext>
+            </a:extLst>
+          </p:cNvPr>
+          <p:cNvSpPr/>
+          <p:nvPr/>
+        </p:nvSpPr>
+        <p:spPr>
+          <a:xfrm>
+            <a:off x="1791433" y="1926795"/>
+            <a:ext cx="1116053" cy="401369"/>
+          </a:xfrm>
+          <a:prstGeom prst="rect">
+            <a:avLst/>
+          </a:prstGeom>
+          <a:solidFill>
+            <a:schemeClr val="bg1">
+              <a:lumMod val="85000"/>
+            </a:schemeClr>
+          </a:solidFill>
+        </p:spPr>
+        <p:style>
+          <a:lnRef idx="2">
+            <a:schemeClr val="accent1">
+              <a:shade val="15000"/>
+            </a:schemeClr>
+          </a:lnRef>
+          <a:fillRef idx="1">
+            <a:schemeClr val="accent1"/>
+          </a:fillRef>
+          <a:effectRef idx="0">
+            <a:schemeClr val="accent1"/>
+          </a:effectRef>
+          <a:fontRef idx="minor">
+            <a:schemeClr val="lt1"/>
+          </a:fontRef>
+        </p:style>
+        <p:txBody>
+          <a:bodyPr lIns="0" tIns="45720" rIns="0" bIns="0" rtlCol="0" anchor="t"/>
+          <a:lstStyle/>
+          <a:p>
+            <a:pPr algn="ctr"/>
+            <a:r>
+              <a:rPr lang="en-US" sz="1100" b="1" dirty="0">
+                <a:solidFill>
+                  <a:schemeClr val="tx1"/>
+                </a:solidFill>
+              </a:rPr>
+              <a:t>User Display </a:t>
+            </a:r>
+          </a:p>
+          <a:p>
+            <a:pPr algn="ctr"/>
+            <a:r>
+              <a:rPr lang="en-US" sz="800" b="1" dirty="0">
+                <a:solidFill>
+                  <a:schemeClr val="tx1"/>
+                </a:solidFill>
+              </a:rPr>
+              <a:t>(Browser)</a:t>
+            </a:r>
+          </a:p>
+        </p:txBody>
+      </p:sp>
+      <p:sp>
+        <p:nvSpPr>
+          <p:cNvPr id="7" name="Rectangle 6">
+            <a:extLst>
+              <a:ext uri="{FF2B5EF4-FFF2-40B4-BE49-F238E27FC236}">
+                <a16:creationId xmlns:a16="http://schemas.microsoft.com/office/drawing/2014/main" id="{20F24B60-2905-0E09-E718-C84C2BFDB1B3}"/>
+              </a:ext>
+            </a:extLst>
+          </p:cNvPr>
+          <p:cNvSpPr/>
+          <p:nvPr/>
+        </p:nvSpPr>
+        <p:spPr>
+          <a:xfrm>
+            <a:off x="3737717" y="385973"/>
+            <a:ext cx="122599" cy="2248872"/>
+          </a:xfrm>
+          <a:prstGeom prst="rect">
+            <a:avLst/>
+          </a:prstGeom>
+          <a:solidFill>
+            <a:srgbClr val="7030A0"/>
+          </a:solidFill>
+        </p:spPr>
+        <p:style>
+          <a:lnRef idx="2">
+            <a:schemeClr val="accent1">
+              <a:shade val="15000"/>
+            </a:schemeClr>
+          </a:lnRef>
+          <a:fillRef idx="1">
+            <a:schemeClr val="accent1"/>
+          </a:fillRef>
+          <a:effectRef idx="0">
+            <a:schemeClr val="accent1"/>
+          </a:effectRef>
+          <a:fontRef idx="minor">
+            <a:schemeClr val="lt1"/>
+          </a:fontRef>
+        </p:style>
+        <p:txBody>
+          <a:bodyPr lIns="0" tIns="0" rIns="0" bIns="0" rtlCol="0" anchor="ctr"/>
+          <a:lstStyle/>
+          <a:p>
+            <a:pPr algn="ctr"/>
+            <a:r>
+              <a:rPr lang="en-US" sz="1200" dirty="0"/>
+              <a:t>HTTP</a:t>
+            </a:r>
+            <a:endParaRPr lang="en-US" sz="500" dirty="0"/>
+          </a:p>
+        </p:txBody>
+      </p:sp>
+      <p:sp>
+        <p:nvSpPr>
+          <p:cNvPr id="8" name="Rectangle 7">
+            <a:extLst>
+              <a:ext uri="{FF2B5EF4-FFF2-40B4-BE49-F238E27FC236}">
+                <a16:creationId xmlns:a16="http://schemas.microsoft.com/office/drawing/2014/main" id="{5F6E5B91-C632-7638-5DE6-41D98F5FAD3D}"/>
+              </a:ext>
+            </a:extLst>
+          </p:cNvPr>
+          <p:cNvSpPr/>
+          <p:nvPr/>
+        </p:nvSpPr>
+        <p:spPr>
+          <a:xfrm>
+            <a:off x="4215226" y="709327"/>
+            <a:ext cx="1022504" cy="1650807"/>
+          </a:xfrm>
+          <a:prstGeom prst="rect">
+            <a:avLst/>
+          </a:prstGeom>
+          <a:solidFill>
+            <a:srgbClr val="7030A0"/>
+          </a:solidFill>
+        </p:spPr>
+        <p:style>
+          <a:lnRef idx="2">
+            <a:schemeClr val="accent1">
+              <a:shade val="15000"/>
+            </a:schemeClr>
+          </a:lnRef>
+          <a:fillRef idx="1">
+            <a:schemeClr val="accent1"/>
+          </a:fillRef>
+          <a:effectRef idx="0">
+            <a:schemeClr val="accent1"/>
+          </a:effectRef>
+          <a:fontRef idx="minor">
+            <a:schemeClr val="lt1"/>
+          </a:fontRef>
+        </p:style>
+        <p:txBody>
+          <a:bodyPr lIns="0" tIns="0" rIns="0" bIns="0" rtlCol="0" anchor="ctr"/>
+          <a:lstStyle/>
+          <a:p>
+            <a:pPr algn="ctr"/>
+            <a:r>
+              <a:rPr lang="en-US" sz="1600" dirty="0"/>
+              <a:t>Web Display</a:t>
+            </a:r>
+            <a:endParaRPr lang="en-US" sz="1400" dirty="0"/>
+          </a:p>
+          <a:p>
+            <a:pPr algn="ctr"/>
+            <a:r>
+              <a:rPr lang="en-US" sz="1100" u="sng" dirty="0"/>
+              <a:t>app/web</a:t>
+            </a:r>
+          </a:p>
+          <a:p>
+            <a:pPr algn="ctr"/>
+            <a:endParaRPr lang="en-US" sz="800" dirty="0"/>
+          </a:p>
+          <a:p>
+            <a:pPr algn="ctr"/>
+            <a:r>
+              <a:rPr lang="en-US" sz="800" dirty="0"/>
+              <a:t>Handles </a:t>
+            </a:r>
+          </a:p>
+          <a:p>
+            <a:pPr algn="ctr"/>
+            <a:r>
+              <a:rPr lang="en-US" sz="800" dirty="0"/>
+              <a:t>display for user interactions</a:t>
+            </a:r>
+          </a:p>
+        </p:txBody>
+      </p:sp>
+      <p:sp>
+        <p:nvSpPr>
+          <p:cNvPr id="9" name="Rectangle 8">
+            <a:extLst>
+              <a:ext uri="{FF2B5EF4-FFF2-40B4-BE49-F238E27FC236}">
+                <a16:creationId xmlns:a16="http://schemas.microsoft.com/office/drawing/2014/main" id="{6337990E-CA5C-5E9E-B92E-0D2BC0C31F0B}"/>
+              </a:ext>
+            </a:extLst>
+          </p:cNvPr>
+          <p:cNvSpPr/>
+          <p:nvPr/>
+        </p:nvSpPr>
+        <p:spPr>
+          <a:xfrm>
+            <a:off x="4211972" y="2662037"/>
+            <a:ext cx="1025758" cy="1650807"/>
+          </a:xfrm>
+          <a:prstGeom prst="rect">
+            <a:avLst/>
+          </a:prstGeom>
+          <a:solidFill>
+            <a:srgbClr val="7030A0"/>
+          </a:solidFill>
+        </p:spPr>
+        <p:style>
+          <a:lnRef idx="2">
+            <a:schemeClr val="accent1">
+              <a:shade val="15000"/>
+            </a:schemeClr>
+          </a:lnRef>
+          <a:fillRef idx="1">
+            <a:schemeClr val="accent1"/>
+          </a:fillRef>
+          <a:effectRef idx="0">
+            <a:schemeClr val="accent1"/>
+          </a:effectRef>
+          <a:fontRef idx="minor">
+            <a:schemeClr val="lt1"/>
+          </a:fontRef>
+        </p:style>
+        <p:txBody>
+          <a:bodyPr lIns="0" tIns="0" rIns="0" bIns="0" rtlCol="0" anchor="ctr"/>
+          <a:lstStyle/>
+          <a:p>
+            <a:pPr algn="ctr"/>
+            <a:r>
               <a:rPr lang="en-US" dirty="0"/>
-              <a:t>Query Handler</a:t>
-            </a:r>
-          </a:p>
-          <a:p>
-            <a:pPr algn="ctr"/>
-            <a:endParaRPr lang="en-US" sz="100" dirty="0"/>
+              <a:t>Query Parser</a:t>
+            </a:r>
+            <a:endParaRPr lang="en-US" sz="1100" dirty="0"/>
+          </a:p>
+          <a:p>
+            <a:pPr algn="ctr"/>
+            <a:r>
+              <a:rPr lang="en-US" sz="1100" u="sng" dirty="0"/>
+              <a:t>app/producer</a:t>
+            </a:r>
+          </a:p>
+          <a:p>
+            <a:pPr algn="ctr"/>
+            <a:endParaRPr lang="en-US" sz="800" dirty="0"/>
           </a:p>
           <a:p>
             <a:pPr algn="ctr"/>
             <a:r>
               <a:rPr lang="en-US" sz="800" dirty="0"/>
-              <a:t>= Receives queries from user, determines relevant Concepts, then uses Local LLM to get the data from PostgreSQL (read-only guard)</a:t>
+              <a:t>Converts user string to </a:t>
+            </a:r>
+            <a:r>
+              <a:rPr lang="en-US" sz="800" dirty="0">
+                <a:solidFill>
+                  <a:srgbClr val="B17ED8"/>
+                </a:solidFill>
+                <a:latin typeface="Adobe Gothic Std B" panose="020B0800000000000000" pitchFamily="34" charset="-128"/>
+                <a:ea typeface="Adobe Gothic Std B" panose="020B0800000000000000" pitchFamily="34" charset="-128"/>
+              </a:rPr>
+              <a:t>Query</a:t>
+            </a:r>
+            <a:r>
+              <a:rPr lang="en-US" sz="800" dirty="0"/>
+              <a:t> object </a:t>
+            </a:r>
+          </a:p>
+          <a:p>
+            <a:pPr algn="ctr"/>
+            <a:r>
+              <a:rPr lang="en-US" sz="800" dirty="0"/>
+              <a:t>(via Qwen)</a:t>
+            </a:r>
+          </a:p>
+        </p:txBody>
+      </p:sp>
+      <p:sp>
+        <p:nvSpPr>
+          <p:cNvPr id="11" name="Rectangle 10">
+            <a:extLst>
+              <a:ext uri="{FF2B5EF4-FFF2-40B4-BE49-F238E27FC236}">
+                <a16:creationId xmlns:a16="http://schemas.microsoft.com/office/drawing/2014/main" id="{FD350345-C206-49FB-1B55-4BFF02E6ED8D}"/>
+              </a:ext>
+            </a:extLst>
+          </p:cNvPr>
+          <p:cNvSpPr/>
+          <p:nvPr/>
+        </p:nvSpPr>
+        <p:spPr>
+          <a:xfrm>
+            <a:off x="5983906" y="2662037"/>
+            <a:ext cx="1025758" cy="1650807"/>
+          </a:xfrm>
+          <a:prstGeom prst="rect">
+            <a:avLst/>
+          </a:prstGeom>
+          <a:solidFill>
+            <a:srgbClr val="7030A0"/>
+          </a:solidFill>
+        </p:spPr>
+        <p:style>
+          <a:lnRef idx="2">
+            <a:schemeClr val="accent1">
+              <a:shade val="15000"/>
+            </a:schemeClr>
+          </a:lnRef>
+          <a:fillRef idx="1">
+            <a:schemeClr val="accent1"/>
+          </a:fillRef>
+          <a:effectRef idx="0">
+            <a:schemeClr val="accent1"/>
+          </a:effectRef>
+          <a:fontRef idx="minor">
+            <a:schemeClr val="lt1"/>
+          </a:fontRef>
+        </p:style>
+        <p:txBody>
+          <a:bodyPr lIns="0" tIns="0" rIns="0" bIns="0" rtlCol="0" anchor="ctr"/>
+          <a:lstStyle/>
+          <a:p>
+            <a:pPr algn="ctr"/>
+            <a:r>
+              <a:rPr lang="en-US" dirty="0"/>
+              <a:t>Query Mapper</a:t>
+            </a:r>
+            <a:endParaRPr lang="en-US" sz="1100" dirty="0"/>
+          </a:p>
+          <a:p>
+            <a:pPr algn="ctr"/>
+            <a:r>
+              <a:rPr lang="en-US" sz="1100" u="sng" dirty="0"/>
+              <a:t>app/semantic</a:t>
+            </a:r>
+          </a:p>
+          <a:p>
+            <a:pPr algn="ctr"/>
+            <a:endParaRPr lang="en-US" sz="800" dirty="0"/>
+          </a:p>
+          <a:p>
+            <a:pPr algn="ctr"/>
+            <a:r>
+              <a:rPr lang="en-US" sz="800" dirty="0"/>
+              <a:t>Does mapping from </a:t>
+            </a:r>
+            <a:r>
+              <a:rPr lang="en-US" sz="800" dirty="0">
+                <a:solidFill>
+                  <a:srgbClr val="B17ED8"/>
+                </a:solidFill>
+                <a:latin typeface="Adobe Gothic Std B" panose="020B0800000000000000" pitchFamily="34" charset="-128"/>
+                <a:ea typeface="Adobe Gothic Std B" panose="020B0800000000000000" pitchFamily="34" charset="-128"/>
+              </a:rPr>
+              <a:t>Query</a:t>
+            </a:r>
+            <a:r>
+              <a:rPr lang="en-US" sz="800" dirty="0"/>
+              <a:t> into a </a:t>
+            </a:r>
+          </a:p>
+          <a:p>
+            <a:pPr algn="ctr"/>
+            <a:r>
+              <a:rPr lang="en-US" sz="800" dirty="0">
+                <a:solidFill>
+                  <a:srgbClr val="B17ED8"/>
+                </a:solidFill>
+                <a:latin typeface="Adobe Gothic Std B" panose="020B0800000000000000" pitchFamily="34" charset="-128"/>
+                <a:ea typeface="Adobe Gothic Std B" panose="020B0800000000000000" pitchFamily="34" charset="-128"/>
+              </a:rPr>
+              <a:t>QueryPlan </a:t>
+            </a:r>
+          </a:p>
+          <a:p>
+            <a:pPr algn="ctr"/>
+            <a:r>
+              <a:rPr lang="en-US" sz="800" dirty="0"/>
+              <a:t>(normalizes request to what is retrievable in the database)</a:t>
+            </a:r>
+          </a:p>
+        </p:txBody>
+      </p:sp>
+      <p:sp>
+        <p:nvSpPr>
+          <p:cNvPr id="13" name="Rectangle 12">
+            <a:extLst>
+              <a:ext uri="{FF2B5EF4-FFF2-40B4-BE49-F238E27FC236}">
+                <a16:creationId xmlns:a16="http://schemas.microsoft.com/office/drawing/2014/main" id="{59DE70CD-39A9-A20F-7E9F-7837F6D26DB9}"/>
+              </a:ext>
+            </a:extLst>
+          </p:cNvPr>
+          <p:cNvSpPr/>
+          <p:nvPr/>
+        </p:nvSpPr>
+        <p:spPr>
+          <a:xfrm>
+            <a:off x="7310810" y="2662037"/>
+            <a:ext cx="929349" cy="1650807"/>
+          </a:xfrm>
+          <a:prstGeom prst="rect">
+            <a:avLst/>
+          </a:prstGeom>
+          <a:solidFill>
+            <a:srgbClr val="7030A0"/>
+          </a:solidFill>
+        </p:spPr>
+        <p:style>
+          <a:lnRef idx="2">
+            <a:schemeClr val="accent1">
+              <a:shade val="15000"/>
+            </a:schemeClr>
+          </a:lnRef>
+          <a:fillRef idx="1">
+            <a:schemeClr val="accent1"/>
+          </a:fillRef>
+          <a:effectRef idx="0">
+            <a:schemeClr val="accent1"/>
+          </a:effectRef>
+          <a:fontRef idx="minor">
+            <a:schemeClr val="lt1"/>
+          </a:fontRef>
+        </p:style>
+        <p:txBody>
+          <a:bodyPr lIns="0" tIns="0" rIns="0" bIns="0" rtlCol="0" anchor="ctr"/>
+          <a:lstStyle/>
+          <a:p>
+            <a:pPr algn="ctr"/>
+            <a:r>
+              <a:rPr lang="en-US" sz="1600" dirty="0"/>
+              <a:t>Executor</a:t>
+            </a:r>
+            <a:endParaRPr lang="en-US" sz="1400" dirty="0"/>
+          </a:p>
+          <a:p>
+            <a:pPr algn="ctr"/>
+            <a:r>
+              <a:rPr lang="en-US" sz="1100" u="sng" dirty="0"/>
+              <a:t>app/retrieval</a:t>
+            </a:r>
+          </a:p>
+          <a:p>
+            <a:pPr algn="ctr"/>
+            <a:endParaRPr lang="en-US" sz="800" dirty="0"/>
+          </a:p>
+          <a:p>
+            <a:pPr algn="ctr"/>
+            <a:r>
+              <a:rPr lang="en-US" sz="800" dirty="0"/>
+              <a:t>Generates SQL to execute </a:t>
+            </a:r>
+            <a:r>
+              <a:rPr lang="en-US" sz="800" dirty="0">
+                <a:solidFill>
+                  <a:srgbClr val="B17ED8"/>
+                </a:solidFill>
+                <a:latin typeface="Adobe Gothic Std B" panose="020B0800000000000000" pitchFamily="34" charset="-128"/>
+                <a:ea typeface="Adobe Gothic Std B" panose="020B0800000000000000" pitchFamily="34" charset="-128"/>
+              </a:rPr>
+              <a:t>QueryPlan</a:t>
+            </a:r>
+            <a:r>
+              <a:rPr lang="en-US" sz="800" dirty="0"/>
+              <a:t> (via Qwen), sanitizes then executes SQL</a:t>
             </a:r>
           </a:p>
         </p:txBody>
       </p:sp>
       <p:cxnSp>
         <p:nvCxnSpPr>
-          <p:cNvPr id="100" name="Straight Arrow Connector 99">
-            <a:extLst>
-              <a:ext uri="{FF2B5EF4-FFF2-40B4-BE49-F238E27FC236}">
-                <a16:creationId xmlns:a16="http://schemas.microsoft.com/office/drawing/2014/main" id="{048236B6-BEC2-3063-49AB-C4D8F7E5E371}"/>
+          <p:cNvPr id="14" name="Straight Arrow Connector 13">
+            <a:extLst>
+              <a:ext uri="{FF2B5EF4-FFF2-40B4-BE49-F238E27FC236}">
+                <a16:creationId xmlns:a16="http://schemas.microsoft.com/office/drawing/2014/main" id="{C823C645-2515-192B-C854-507A34F34D39}"/>
               </a:ext>
             </a:extLst>
           </p:cNvPr>
           <p:cNvCxnSpPr>
             <a:cxnSpLocks/>
+            <a:stCxn id="3" idx="1"/>
+            <a:endCxn id="5" idx="3"/>
           </p:cNvCxnSpPr>
           <p:nvPr/>
         </p:nvCxnSpPr>
         <p:spPr>
-          <a:xfrm>
-            <a:off x="9756433" y="4336912"/>
-            <a:ext cx="0" cy="547973"/>
+          <a:xfrm flipH="1">
+            <a:off x="2907486" y="934030"/>
+            <a:ext cx="207094" cy="0"/>
           </a:xfrm>
           <a:prstGeom prst="straightConnector1">
             <a:avLst/>
@@ -6938,7 +8023,8 @@
             <a:solidFill>
               <a:schemeClr val="tx1"/>
             </a:solidFill>
-            <a:tailEnd type="arrow"/>
+            <a:headEnd type="arrow"/>
+            <a:tailEnd type="none"/>
           </a:ln>
         </p:spPr>
         <p:style>
@@ -6958,515 +8044,23 @@
       </p:cxnSp>
       <p:cxnSp>
         <p:nvCxnSpPr>
-          <p:cNvPr id="103" name="Straight Arrow Connector 102">
-            <a:extLst>
-              <a:ext uri="{FF2B5EF4-FFF2-40B4-BE49-F238E27FC236}">
-                <a16:creationId xmlns:a16="http://schemas.microsoft.com/office/drawing/2014/main" id="{11A63202-9707-9FE3-CE76-F449C5D46B48}"/>
+          <p:cNvPr id="18" name="Straight Arrow Connector 17">
+            <a:extLst>
+              <a:ext uri="{FF2B5EF4-FFF2-40B4-BE49-F238E27FC236}">
+                <a16:creationId xmlns:a16="http://schemas.microsoft.com/office/drawing/2014/main" id="{289F1476-8289-F0DD-9B6E-4A04F3B111E0}"/>
               </a:ext>
             </a:extLst>
           </p:cNvPr>
           <p:cNvCxnSpPr>
             <a:cxnSpLocks/>
-            <a:endCxn id="52" idx="3"/>
+            <a:endCxn id="3" idx="3"/>
           </p:cNvCxnSpPr>
           <p:nvPr/>
         </p:nvCxnSpPr>
         <p:spPr>
           <a:xfrm flipH="1">
-            <a:off x="8056871" y="5100698"/>
-            <a:ext cx="1254471" cy="0"/>
-          </a:xfrm>
-          <a:prstGeom prst="straightConnector1">
-            <a:avLst/>
-          </a:prstGeom>
-          <a:ln w="12700">
-            <a:solidFill>
-              <a:schemeClr val="tx1"/>
-            </a:solidFill>
-            <a:headEnd type="arrow"/>
-            <a:tailEnd type="arrow"/>
-          </a:ln>
-        </p:spPr>
-        <p:style>
-          <a:lnRef idx="1">
-            <a:schemeClr val="accent1"/>
-          </a:lnRef>
-          <a:fillRef idx="0">
-            <a:schemeClr val="accent1"/>
-          </a:fillRef>
-          <a:effectRef idx="0">
-            <a:schemeClr val="accent1"/>
-          </a:effectRef>
-          <a:fontRef idx="minor">
-            <a:schemeClr val="tx1"/>
-          </a:fontRef>
-        </p:style>
-      </p:cxnSp>
-      <p:sp>
-        <p:nvSpPr>
-          <p:cNvPr id="131" name="Flowchart: Off-page Connector 130">
-            <a:extLst>
-              <a:ext uri="{FF2B5EF4-FFF2-40B4-BE49-F238E27FC236}">
-                <a16:creationId xmlns:a16="http://schemas.microsoft.com/office/drawing/2014/main" id="{8DB5FFE1-B20F-BC4A-F98A-1DB0CDA11B3B}"/>
-              </a:ext>
-            </a:extLst>
-          </p:cNvPr>
-          <p:cNvSpPr/>
-          <p:nvPr/>
-        </p:nvSpPr>
-        <p:spPr>
-          <a:xfrm rot="16200000">
-            <a:off x="2209722" y="4781767"/>
-            <a:ext cx="186884" cy="240280"/>
-          </a:xfrm>
-          <a:prstGeom prst="flowChartOffpageConnector">
-            <a:avLst/>
-          </a:prstGeom>
-          <a:solidFill>
-            <a:schemeClr val="accent6">
-              <a:lumMod val="75000"/>
-            </a:schemeClr>
-          </a:solidFill>
-        </p:spPr>
-        <p:style>
-          <a:lnRef idx="2">
-            <a:schemeClr val="accent1">
-              <a:shade val="15000"/>
-            </a:schemeClr>
-          </a:lnRef>
-          <a:fillRef idx="1">
-            <a:schemeClr val="accent1"/>
-          </a:fillRef>
-          <a:effectRef idx="0">
-            <a:schemeClr val="accent1"/>
-          </a:effectRef>
-          <a:fontRef idx="minor">
-            <a:schemeClr val="lt1"/>
-          </a:fontRef>
-        </p:style>
-        <p:txBody>
-          <a:bodyPr vert="vert" rtlCol="0" anchor="ctr"/>
-          <a:lstStyle/>
-          <a:p>
-            <a:pPr algn="ctr"/>
-            <a:r>
-              <a:rPr lang="en-US" sz="1400" b="1" dirty="0"/>
-              <a:t>8</a:t>
-            </a:r>
-          </a:p>
-        </p:txBody>
-      </p:sp>
-      <p:sp>
-        <p:nvSpPr>
-          <p:cNvPr id="137" name="Rectangle 136">
-            <a:extLst>
-              <a:ext uri="{FF2B5EF4-FFF2-40B4-BE49-F238E27FC236}">
-                <a16:creationId xmlns:a16="http://schemas.microsoft.com/office/drawing/2014/main" id="{C12A4E2B-6096-150E-DA86-68333E328721}"/>
-              </a:ext>
-            </a:extLst>
-          </p:cNvPr>
-          <p:cNvSpPr/>
-          <p:nvPr/>
-        </p:nvSpPr>
-        <p:spPr>
-          <a:xfrm>
-            <a:off x="9311342" y="4884884"/>
-            <a:ext cx="2215438" cy="1195545"/>
-          </a:xfrm>
-          <a:prstGeom prst="rect">
-            <a:avLst/>
-          </a:prstGeom>
-          <a:solidFill>
-            <a:srgbClr val="7030A0"/>
-          </a:solidFill>
-        </p:spPr>
-        <p:style>
-          <a:lnRef idx="2">
-            <a:schemeClr val="accent1">
-              <a:shade val="15000"/>
-            </a:schemeClr>
-          </a:lnRef>
-          <a:fillRef idx="1">
-            <a:schemeClr val="accent1"/>
-          </a:fillRef>
-          <a:effectRef idx="0">
-            <a:schemeClr val="accent1"/>
-          </a:effectRef>
-          <a:fontRef idx="minor">
-            <a:schemeClr val="lt1"/>
-          </a:fontRef>
-        </p:style>
-        <p:txBody>
-          <a:bodyPr lIns="0" tIns="0" rIns="0" bIns="0" rtlCol="0" anchor="ctr"/>
-          <a:lstStyle/>
-          <a:p>
-            <a:pPr algn="ctr"/>
-            <a:r>
-              <a:rPr lang="en-US" sz="1050" b="1" dirty="0"/>
-              <a:t>Query Mapper</a:t>
-            </a:r>
-          </a:p>
-          <a:p>
-            <a:pPr algn="ctr"/>
-            <a:endParaRPr lang="en-US" sz="300" dirty="0"/>
-          </a:p>
-          <a:p>
-            <a:pPr algn="ctr"/>
-            <a:r>
-              <a:rPr lang="en-US" sz="900" dirty="0"/>
-              <a:t>Uses arcane SEC-specific knowledge to determine Concepts being asked about </a:t>
-            </a:r>
-          </a:p>
-          <a:p>
-            <a:pPr algn="ctr"/>
-            <a:r>
-              <a:rPr lang="en-US" sz="900" dirty="0"/>
-              <a:t>(via alias lookups, cosine distances, etc…)</a:t>
-            </a:r>
-          </a:p>
-          <a:p>
-            <a:pPr algn="ctr"/>
-            <a:endParaRPr lang="en-US" sz="900" dirty="0"/>
-          </a:p>
-          <a:p>
-            <a:pPr algn="ctr"/>
-            <a:r>
-              <a:rPr lang="en-US" sz="900" dirty="0"/>
-              <a:t>Produces a Query Plan for the local LLM to write a matching SQL query.</a:t>
-            </a:r>
-          </a:p>
-          <a:p>
-            <a:pPr algn="ctr"/>
-            <a:endParaRPr lang="en-US" sz="500" dirty="0"/>
-          </a:p>
-        </p:txBody>
-      </p:sp>
-      <p:cxnSp>
-        <p:nvCxnSpPr>
-          <p:cNvPr id="138" name="Straight Arrow Connector 137">
-            <a:extLst>
-              <a:ext uri="{FF2B5EF4-FFF2-40B4-BE49-F238E27FC236}">
-                <a16:creationId xmlns:a16="http://schemas.microsoft.com/office/drawing/2014/main" id="{218F14AF-9931-3060-84FB-55E3AD301B67}"/>
-              </a:ext>
-            </a:extLst>
-          </p:cNvPr>
-          <p:cNvCxnSpPr>
-            <a:cxnSpLocks/>
-          </p:cNvCxnSpPr>
-          <p:nvPr/>
-        </p:nvCxnSpPr>
-        <p:spPr>
-          <a:xfrm flipH="1">
-            <a:off x="8056871" y="5492584"/>
-            <a:ext cx="1254471" cy="0"/>
-          </a:xfrm>
-          <a:prstGeom prst="straightConnector1">
-            <a:avLst/>
-          </a:prstGeom>
-          <a:ln w="12700">
-            <a:solidFill>
-              <a:schemeClr val="tx1"/>
-            </a:solidFill>
-            <a:headEnd type="none"/>
-            <a:tailEnd type="arrow"/>
-          </a:ln>
-        </p:spPr>
-        <p:style>
-          <a:lnRef idx="1">
-            <a:schemeClr val="accent1"/>
-          </a:lnRef>
-          <a:fillRef idx="0">
-            <a:schemeClr val="accent1"/>
-          </a:fillRef>
-          <a:effectRef idx="0">
-            <a:schemeClr val="accent1"/>
-          </a:effectRef>
-          <a:fontRef idx="minor">
-            <a:schemeClr val="tx1"/>
-          </a:fontRef>
-        </p:style>
-      </p:cxnSp>
-      <p:sp>
-        <p:nvSpPr>
-          <p:cNvPr id="140" name="Rectangle 139">
-            <a:extLst>
-              <a:ext uri="{FF2B5EF4-FFF2-40B4-BE49-F238E27FC236}">
-                <a16:creationId xmlns:a16="http://schemas.microsoft.com/office/drawing/2014/main" id="{EFB83094-B4D6-F6AB-F052-7F3270A99A6B}"/>
-              </a:ext>
-            </a:extLst>
-          </p:cNvPr>
-          <p:cNvSpPr/>
-          <p:nvPr/>
-        </p:nvSpPr>
-        <p:spPr>
-          <a:xfrm>
-            <a:off x="9391751" y="4411928"/>
-            <a:ext cx="719593" cy="304891"/>
-          </a:xfrm>
-          <a:prstGeom prst="rect">
-            <a:avLst/>
-          </a:prstGeom>
-          <a:solidFill>
-            <a:srgbClr val="B17ED8"/>
-          </a:solidFill>
-        </p:spPr>
-        <p:style>
-          <a:lnRef idx="2">
-            <a:schemeClr val="accent1">
-              <a:shade val="15000"/>
-            </a:schemeClr>
-          </a:lnRef>
-          <a:fillRef idx="1">
-            <a:schemeClr val="accent1"/>
-          </a:fillRef>
-          <a:effectRef idx="0">
-            <a:schemeClr val="accent1"/>
-          </a:effectRef>
-          <a:fontRef idx="minor">
-            <a:schemeClr val="lt1"/>
-          </a:fontRef>
-        </p:style>
-        <p:txBody>
-          <a:bodyPr lIns="0" tIns="0" rIns="0" bIns="0" rtlCol="0" anchor="t"/>
-          <a:lstStyle/>
-          <a:p>
-            <a:pPr algn="ctr"/>
-            <a:r>
-              <a:rPr lang="en-US" sz="1000" b="1" dirty="0"/>
-              <a:t>Query Object</a:t>
-            </a:r>
-            <a:endParaRPr lang="en-US" sz="1200" b="1" dirty="0"/>
-          </a:p>
-          <a:p>
-            <a:pPr algn="ctr"/>
-            <a:r>
-              <a:rPr lang="en-US" sz="700" dirty="0"/>
-              <a:t>📚 </a:t>
-            </a:r>
-            <a:r>
-              <a:rPr lang="en-US" sz="700" b="1" u="sng" dirty="0"/>
-              <a:t>Pydantic</a:t>
-            </a:r>
-            <a:endParaRPr lang="en-US" sz="800" b="1" u="sng" dirty="0"/>
-          </a:p>
-        </p:txBody>
-      </p:sp>
-      <p:sp>
-        <p:nvSpPr>
-          <p:cNvPr id="141" name="Rectangle 140">
-            <a:extLst>
-              <a:ext uri="{FF2B5EF4-FFF2-40B4-BE49-F238E27FC236}">
-                <a16:creationId xmlns:a16="http://schemas.microsoft.com/office/drawing/2014/main" id="{57D42052-BB79-A072-46BE-B34C46D0157D}"/>
-              </a:ext>
-            </a:extLst>
-          </p:cNvPr>
-          <p:cNvSpPr/>
-          <p:nvPr/>
-        </p:nvSpPr>
-        <p:spPr>
-          <a:xfrm>
-            <a:off x="8370160" y="5353118"/>
-            <a:ext cx="719593" cy="304890"/>
-          </a:xfrm>
-          <a:prstGeom prst="rect">
-            <a:avLst/>
-          </a:prstGeom>
-          <a:solidFill>
-            <a:srgbClr val="B17ED8"/>
-          </a:solidFill>
-        </p:spPr>
-        <p:style>
-          <a:lnRef idx="2">
-            <a:schemeClr val="accent1">
-              <a:shade val="15000"/>
-            </a:schemeClr>
-          </a:lnRef>
-          <a:fillRef idx="1">
-            <a:schemeClr val="accent1"/>
-          </a:fillRef>
-          <a:effectRef idx="0">
-            <a:schemeClr val="accent1"/>
-          </a:effectRef>
-          <a:fontRef idx="minor">
-            <a:schemeClr val="lt1"/>
-          </a:fontRef>
-        </p:style>
-        <p:txBody>
-          <a:bodyPr lIns="0" tIns="0" rIns="0" bIns="0" rtlCol="0" anchor="t"/>
-          <a:lstStyle/>
-          <a:p>
-            <a:pPr algn="ctr"/>
-            <a:r>
-              <a:rPr lang="en-US" sz="1000" b="1" dirty="0"/>
-              <a:t>Query Plan</a:t>
-            </a:r>
-            <a:endParaRPr lang="en-US" sz="1200" b="1" dirty="0"/>
-          </a:p>
-          <a:p>
-            <a:pPr algn="ctr"/>
-            <a:r>
-              <a:rPr lang="en-US" sz="700" dirty="0"/>
-              <a:t>📚 </a:t>
-            </a:r>
-            <a:r>
-              <a:rPr lang="en-US" sz="700" b="1" u="sng" dirty="0"/>
-              <a:t>Pydantic</a:t>
-            </a:r>
-            <a:endParaRPr lang="en-US" sz="800" b="1" u="sng" dirty="0"/>
-          </a:p>
-        </p:txBody>
-      </p:sp>
-      <p:sp>
-        <p:nvSpPr>
-          <p:cNvPr id="93" name="Rectangle 92">
-            <a:extLst>
-              <a:ext uri="{FF2B5EF4-FFF2-40B4-BE49-F238E27FC236}">
-                <a16:creationId xmlns:a16="http://schemas.microsoft.com/office/drawing/2014/main" id="{C470D739-A7E4-B20F-87C7-38FAB125269A}"/>
-              </a:ext>
-            </a:extLst>
-          </p:cNvPr>
-          <p:cNvSpPr/>
-          <p:nvPr/>
-        </p:nvSpPr>
-        <p:spPr>
-          <a:xfrm>
-            <a:off x="9362414" y="4933772"/>
-            <a:ext cx="393792" cy="101326"/>
-          </a:xfrm>
-          <a:prstGeom prst="rect">
-            <a:avLst/>
-          </a:prstGeom>
-          <a:solidFill>
-            <a:srgbClr val="7030A0"/>
-          </a:solidFill>
-          <a:ln w="6350" cap="rnd"/>
-        </p:spPr>
-        <p:style>
-          <a:lnRef idx="2">
-            <a:schemeClr val="accent1">
-              <a:shade val="15000"/>
-            </a:schemeClr>
-          </a:lnRef>
-          <a:fillRef idx="1">
-            <a:schemeClr val="accent1"/>
-          </a:fillRef>
-          <a:effectRef idx="0">
-            <a:schemeClr val="accent1"/>
-          </a:effectRef>
-          <a:fontRef idx="minor">
-            <a:schemeClr val="lt1"/>
-          </a:fontRef>
-        </p:style>
-        <p:txBody>
-          <a:bodyPr lIns="0" tIns="0" rIns="0" bIns="0" rtlCol="0" anchor="ctr"/>
-          <a:lstStyle/>
-          <a:p>
-            <a:pPr algn="ctr"/>
-            <a:r>
-              <a:rPr lang="en-US" sz="700" dirty="0"/>
-              <a:t>.py script</a:t>
-            </a:r>
-          </a:p>
-        </p:txBody>
-      </p:sp>
-      <p:cxnSp>
-        <p:nvCxnSpPr>
-          <p:cNvPr id="160" name="Straight Arrow Connector 159">
-            <a:extLst>
-              <a:ext uri="{FF2B5EF4-FFF2-40B4-BE49-F238E27FC236}">
-                <a16:creationId xmlns:a16="http://schemas.microsoft.com/office/drawing/2014/main" id="{544E47D5-B3E9-03E4-F236-9378DC14B57C}"/>
-              </a:ext>
-            </a:extLst>
-          </p:cNvPr>
-          <p:cNvCxnSpPr>
-            <a:cxnSpLocks/>
-          </p:cNvCxnSpPr>
-          <p:nvPr/>
-        </p:nvCxnSpPr>
-        <p:spPr>
-          <a:xfrm flipH="1">
-            <a:off x="8056871" y="5846330"/>
-            <a:ext cx="1254471" cy="0"/>
-          </a:xfrm>
-          <a:prstGeom prst="straightConnector1">
-            <a:avLst/>
-          </a:prstGeom>
-          <a:ln w="12700">
-            <a:solidFill>
-              <a:schemeClr val="tx1"/>
-            </a:solidFill>
-            <a:headEnd type="arrow"/>
-            <a:tailEnd type="none"/>
-          </a:ln>
-        </p:spPr>
-        <p:style>
-          <a:lnRef idx="1">
-            <a:schemeClr val="accent1"/>
-          </a:lnRef>
-          <a:fillRef idx="0">
-            <a:schemeClr val="accent1"/>
-          </a:fillRef>
-          <a:effectRef idx="0">
-            <a:schemeClr val="accent1"/>
-          </a:effectRef>
-          <a:fontRef idx="minor">
-            <a:schemeClr val="tx1"/>
-          </a:fontRef>
-        </p:style>
-      </p:cxnSp>
-      <p:sp>
-        <p:nvSpPr>
-          <p:cNvPr id="161" name="TextBox 160">
-            <a:extLst>
-              <a:ext uri="{FF2B5EF4-FFF2-40B4-BE49-F238E27FC236}">
-                <a16:creationId xmlns:a16="http://schemas.microsoft.com/office/drawing/2014/main" id="{EEB8931C-BA61-0618-C084-D24D32A32097}"/>
-              </a:ext>
-            </a:extLst>
-          </p:cNvPr>
-          <p:cNvSpPr txBox="1"/>
-          <p:nvPr/>
-        </p:nvSpPr>
-        <p:spPr>
-          <a:xfrm>
-            <a:off x="10731674" y="4511651"/>
-            <a:ext cx="652423" cy="169277"/>
-          </a:xfrm>
-          <a:prstGeom prst="rect">
-            <a:avLst/>
-          </a:prstGeom>
-          <a:noFill/>
-        </p:spPr>
-        <p:txBody>
-          <a:bodyPr wrap="none" lIns="0" tIns="0" rIns="0" bIns="0" rtlCol="0">
-            <a:spAutoFit/>
-          </a:bodyPr>
-          <a:lstStyle/>
-          <a:p>
-            <a:r>
-              <a:rPr lang="en-US" sz="1100" i="1" dirty="0"/>
-              <a:t>Query data</a:t>
-            </a:r>
-          </a:p>
-        </p:txBody>
-      </p:sp>
-      <p:cxnSp>
-        <p:nvCxnSpPr>
-          <p:cNvPr id="164" name="Straight Arrow Connector 163">
-            <a:extLst>
-              <a:ext uri="{FF2B5EF4-FFF2-40B4-BE49-F238E27FC236}">
-                <a16:creationId xmlns:a16="http://schemas.microsoft.com/office/drawing/2014/main" id="{AD5A96E6-5B59-6B19-7697-43661A71E9CA}"/>
-              </a:ext>
-            </a:extLst>
-          </p:cNvPr>
-          <p:cNvCxnSpPr>
-            <a:cxnSpLocks/>
-          </p:cNvCxnSpPr>
-          <p:nvPr/>
-        </p:nvCxnSpPr>
-        <p:spPr>
-          <a:xfrm>
-            <a:off x="11092940" y="4336911"/>
-            <a:ext cx="0" cy="547973"/>
+            <a:off x="3512611" y="934029"/>
+            <a:ext cx="702615" cy="1"/>
           </a:xfrm>
           <a:prstGeom prst="straightConnector1">
             <a:avLst/>
@@ -7496,22 +8090,70 @@
       </p:cxnSp>
       <p:cxnSp>
         <p:nvCxnSpPr>
-          <p:cNvPr id="167" name="Straight Arrow Connector 166">
-            <a:extLst>
-              <a:ext uri="{FF2B5EF4-FFF2-40B4-BE49-F238E27FC236}">
-                <a16:creationId xmlns:a16="http://schemas.microsoft.com/office/drawing/2014/main" id="{188E0E9D-CD8C-2DF9-9DD6-2809E60C06D4}"/>
+          <p:cNvPr id="21" name="Straight Arrow Connector 20">
+            <a:extLst>
+              <a:ext uri="{FF2B5EF4-FFF2-40B4-BE49-F238E27FC236}">
+                <a16:creationId xmlns:a16="http://schemas.microsoft.com/office/drawing/2014/main" id="{03AF897F-7D7C-FBC4-FE31-D98E8DB3A99D}"/>
               </a:ext>
             </a:extLst>
           </p:cNvPr>
           <p:cNvCxnSpPr>
             <a:cxnSpLocks/>
+            <a:stCxn id="9" idx="0"/>
+            <a:endCxn id="8" idx="2"/>
           </p:cNvCxnSpPr>
           <p:nvPr/>
         </p:nvCxnSpPr>
         <p:spPr>
-          <a:xfrm flipH="1" flipV="1">
-            <a:off x="8129643" y="3112670"/>
-            <a:ext cx="1181698" cy="1772213"/>
+          <a:xfrm flipV="1">
+            <a:off x="4724851" y="2360134"/>
+            <a:ext cx="1627" cy="301903"/>
+          </a:xfrm>
+          <a:prstGeom prst="straightConnector1">
+            <a:avLst/>
+          </a:prstGeom>
+          <a:ln w="12700">
+            <a:solidFill>
+              <a:schemeClr val="tx1"/>
+            </a:solidFill>
+            <a:headEnd type="arrow"/>
+            <a:tailEnd type="none"/>
+          </a:ln>
+        </p:spPr>
+        <p:style>
+          <a:lnRef idx="1">
+            <a:schemeClr val="accent1"/>
+          </a:lnRef>
+          <a:fillRef idx="0">
+            <a:schemeClr val="accent1"/>
+          </a:fillRef>
+          <a:effectRef idx="0">
+            <a:schemeClr val="accent1"/>
+          </a:effectRef>
+          <a:fontRef idx="minor">
+            <a:schemeClr val="tx1"/>
+          </a:fontRef>
+        </p:style>
+      </p:cxnSp>
+      <p:cxnSp>
+        <p:nvCxnSpPr>
+          <p:cNvPr id="25" name="Straight Arrow Connector 24">
+            <a:extLst>
+              <a:ext uri="{FF2B5EF4-FFF2-40B4-BE49-F238E27FC236}">
+                <a16:creationId xmlns:a16="http://schemas.microsoft.com/office/drawing/2014/main" id="{827F5B4B-693B-6867-1F64-A4FD871C749E}"/>
+              </a:ext>
+            </a:extLst>
+          </p:cNvPr>
+          <p:cNvCxnSpPr>
+            <a:cxnSpLocks/>
+            <a:endCxn id="9" idx="2"/>
+          </p:cNvCxnSpPr>
+          <p:nvPr/>
+        </p:nvCxnSpPr>
+        <p:spPr>
+          <a:xfrm flipV="1">
+            <a:off x="4724851" y="4312844"/>
+            <a:ext cx="0" cy="687522"/>
           </a:xfrm>
           <a:prstGeom prst="straightConnector1">
             <a:avLst/>
@@ -7539,12 +8181,517 @@
           </a:fontRef>
         </p:style>
       </p:cxnSp>
-      <p:sp>
-        <p:nvSpPr>
-          <p:cNvPr id="170" name="TextBox 169">
-            <a:extLst>
-              <a:ext uri="{FF2B5EF4-FFF2-40B4-BE49-F238E27FC236}">
-                <a16:creationId xmlns:a16="http://schemas.microsoft.com/office/drawing/2014/main" id="{B083C1EC-BE03-48D2-C3AE-FADE3D496F76}"/>
+      <p:cxnSp>
+        <p:nvCxnSpPr>
+          <p:cNvPr id="29" name="Straight Arrow Connector 28">
+            <a:extLst>
+              <a:ext uri="{FF2B5EF4-FFF2-40B4-BE49-F238E27FC236}">
+                <a16:creationId xmlns:a16="http://schemas.microsoft.com/office/drawing/2014/main" id="{60EFA422-E47F-91E3-42D0-2A8BC5CE310A}"/>
+              </a:ext>
+            </a:extLst>
+          </p:cNvPr>
+          <p:cNvCxnSpPr>
+            <a:cxnSpLocks/>
+            <a:stCxn id="13" idx="1"/>
+            <a:endCxn id="11" idx="3"/>
+          </p:cNvCxnSpPr>
+          <p:nvPr/>
+        </p:nvCxnSpPr>
+        <p:spPr>
+          <a:xfrm flipH="1">
+            <a:off x="7009664" y="3487441"/>
+            <a:ext cx="301146" cy="0"/>
+          </a:xfrm>
+          <a:prstGeom prst="straightConnector1">
+            <a:avLst/>
+          </a:prstGeom>
+          <a:ln w="12700">
+            <a:solidFill>
+              <a:schemeClr val="tx1"/>
+            </a:solidFill>
+            <a:headEnd type="arrow"/>
+            <a:tailEnd type="none"/>
+          </a:ln>
+        </p:spPr>
+        <p:style>
+          <a:lnRef idx="1">
+            <a:schemeClr val="accent1"/>
+          </a:lnRef>
+          <a:fillRef idx="0">
+            <a:schemeClr val="accent1"/>
+          </a:fillRef>
+          <a:effectRef idx="0">
+            <a:schemeClr val="accent1"/>
+          </a:effectRef>
+          <a:fontRef idx="minor">
+            <a:schemeClr val="tx1"/>
+          </a:fontRef>
+        </p:style>
+      </p:cxnSp>
+      <p:cxnSp>
+        <p:nvCxnSpPr>
+          <p:cNvPr id="35" name="Straight Arrow Connector 34">
+            <a:extLst>
+              <a:ext uri="{FF2B5EF4-FFF2-40B4-BE49-F238E27FC236}">
+                <a16:creationId xmlns:a16="http://schemas.microsoft.com/office/drawing/2014/main" id="{A91024CF-1BBB-6447-AC43-8CCFBE29F66A}"/>
+              </a:ext>
+            </a:extLst>
+          </p:cNvPr>
+          <p:cNvCxnSpPr>
+            <a:cxnSpLocks/>
+          </p:cNvCxnSpPr>
+          <p:nvPr/>
+        </p:nvCxnSpPr>
+        <p:spPr>
+          <a:xfrm flipV="1">
+            <a:off x="6144512" y="4312844"/>
+            <a:ext cx="0" cy="687522"/>
+          </a:xfrm>
+          <a:prstGeom prst="straightConnector1">
+            <a:avLst/>
+          </a:prstGeom>
+          <a:ln w="12700">
+            <a:solidFill>
+              <a:schemeClr val="tx1"/>
+            </a:solidFill>
+            <a:headEnd type="arrow"/>
+            <a:tailEnd type="arrow"/>
+          </a:ln>
+        </p:spPr>
+        <p:style>
+          <a:lnRef idx="1">
+            <a:schemeClr val="accent1"/>
+          </a:lnRef>
+          <a:fillRef idx="0">
+            <a:schemeClr val="accent1"/>
+          </a:fillRef>
+          <a:effectRef idx="0">
+            <a:schemeClr val="accent1"/>
+          </a:effectRef>
+          <a:fontRef idx="minor">
+            <a:schemeClr val="tx1"/>
+          </a:fontRef>
+        </p:style>
+      </p:cxnSp>
+      <p:cxnSp>
+        <p:nvCxnSpPr>
+          <p:cNvPr id="37" name="Straight Arrow Connector 36">
+            <a:extLst>
+              <a:ext uri="{FF2B5EF4-FFF2-40B4-BE49-F238E27FC236}">
+                <a16:creationId xmlns:a16="http://schemas.microsoft.com/office/drawing/2014/main" id="{837E65A8-E98B-A3F1-EC69-60F3FB12BFCB}"/>
+              </a:ext>
+            </a:extLst>
+          </p:cNvPr>
+          <p:cNvCxnSpPr>
+            <a:cxnSpLocks/>
+            <a:endCxn id="73" idx="0"/>
+          </p:cNvCxnSpPr>
+          <p:nvPr/>
+        </p:nvCxnSpPr>
+        <p:spPr>
+          <a:xfrm flipH="1">
+            <a:off x="7140831" y="4312844"/>
+            <a:ext cx="231288" cy="208593"/>
+          </a:xfrm>
+          <a:prstGeom prst="straightConnector1">
+            <a:avLst/>
+          </a:prstGeom>
+          <a:ln w="12700">
+            <a:solidFill>
+              <a:schemeClr val="tx1"/>
+            </a:solidFill>
+            <a:headEnd type="arrow"/>
+            <a:tailEnd type="arrow"/>
+          </a:ln>
+        </p:spPr>
+        <p:style>
+          <a:lnRef idx="1">
+            <a:schemeClr val="accent1"/>
+          </a:lnRef>
+          <a:fillRef idx="0">
+            <a:schemeClr val="accent1"/>
+          </a:fillRef>
+          <a:effectRef idx="0">
+            <a:schemeClr val="accent1"/>
+          </a:effectRef>
+          <a:fontRef idx="minor">
+            <a:schemeClr val="tx1"/>
+          </a:fontRef>
+        </p:style>
+      </p:cxnSp>
+      <p:cxnSp>
+        <p:nvCxnSpPr>
+          <p:cNvPr id="42" name="Straight Arrow Connector 41">
+            <a:extLst>
+              <a:ext uri="{FF2B5EF4-FFF2-40B4-BE49-F238E27FC236}">
+                <a16:creationId xmlns:a16="http://schemas.microsoft.com/office/drawing/2014/main" id="{59FA540F-0D32-6ABF-F082-1F95536F248C}"/>
+              </a:ext>
+            </a:extLst>
+          </p:cNvPr>
+          <p:cNvCxnSpPr>
+            <a:cxnSpLocks/>
+            <a:endCxn id="73" idx="0"/>
+          </p:cNvCxnSpPr>
+          <p:nvPr/>
+        </p:nvCxnSpPr>
+        <p:spPr>
+          <a:xfrm>
+            <a:off x="6936102" y="4312844"/>
+            <a:ext cx="204729" cy="208593"/>
+          </a:xfrm>
+          <a:prstGeom prst="straightConnector1">
+            <a:avLst/>
+          </a:prstGeom>
+          <a:ln w="12700">
+            <a:solidFill>
+              <a:schemeClr val="tx1"/>
+            </a:solidFill>
+            <a:headEnd type="arrow"/>
+            <a:tailEnd type="arrow"/>
+          </a:ln>
+        </p:spPr>
+        <p:style>
+          <a:lnRef idx="1">
+            <a:schemeClr val="accent1"/>
+          </a:lnRef>
+          <a:fillRef idx="0">
+            <a:schemeClr val="accent1"/>
+          </a:fillRef>
+          <a:effectRef idx="0">
+            <a:schemeClr val="accent1"/>
+          </a:effectRef>
+          <a:fontRef idx="minor">
+            <a:schemeClr val="tx1"/>
+          </a:fontRef>
+        </p:style>
+      </p:cxnSp>
+      <p:cxnSp>
+        <p:nvCxnSpPr>
+          <p:cNvPr id="43" name="Straight Arrow Connector 42">
+            <a:extLst>
+              <a:ext uri="{FF2B5EF4-FFF2-40B4-BE49-F238E27FC236}">
+                <a16:creationId xmlns:a16="http://schemas.microsoft.com/office/drawing/2014/main" id="{6DD88032-5E17-4F47-AA9F-FBDAC2D2C59F}"/>
+              </a:ext>
+            </a:extLst>
+          </p:cNvPr>
+          <p:cNvCxnSpPr>
+            <a:cxnSpLocks/>
+            <a:stCxn id="11" idx="1"/>
+            <a:endCxn id="9" idx="3"/>
+          </p:cNvCxnSpPr>
+          <p:nvPr/>
+        </p:nvCxnSpPr>
+        <p:spPr>
+          <a:xfrm flipH="1">
+            <a:off x="5237730" y="3487441"/>
+            <a:ext cx="746176" cy="0"/>
+          </a:xfrm>
+          <a:prstGeom prst="straightConnector1">
+            <a:avLst/>
+          </a:prstGeom>
+          <a:ln w="12700">
+            <a:solidFill>
+              <a:schemeClr val="tx1"/>
+            </a:solidFill>
+            <a:headEnd type="arrow"/>
+            <a:tailEnd type="none"/>
+          </a:ln>
+        </p:spPr>
+        <p:style>
+          <a:lnRef idx="1">
+            <a:schemeClr val="accent1"/>
+          </a:lnRef>
+          <a:fillRef idx="0">
+            <a:schemeClr val="accent1"/>
+          </a:fillRef>
+          <a:effectRef idx="0">
+            <a:schemeClr val="accent1"/>
+          </a:effectRef>
+          <a:fontRef idx="minor">
+            <a:schemeClr val="tx1"/>
+          </a:fontRef>
+        </p:style>
+      </p:cxnSp>
+      <p:cxnSp>
+        <p:nvCxnSpPr>
+          <p:cNvPr id="47" name="Straight Arrow Connector 46">
+            <a:extLst>
+              <a:ext uri="{FF2B5EF4-FFF2-40B4-BE49-F238E27FC236}">
+                <a16:creationId xmlns:a16="http://schemas.microsoft.com/office/drawing/2014/main" id="{8365C1E3-C6AD-0E59-D654-7A64454F99F0}"/>
+              </a:ext>
+            </a:extLst>
+          </p:cNvPr>
+          <p:cNvCxnSpPr>
+            <a:cxnSpLocks/>
+          </p:cNvCxnSpPr>
+          <p:nvPr/>
+        </p:nvCxnSpPr>
+        <p:spPr>
+          <a:xfrm flipV="1">
+            <a:off x="7842885" y="4312844"/>
+            <a:ext cx="0" cy="687522"/>
+          </a:xfrm>
+          <a:prstGeom prst="straightConnector1">
+            <a:avLst/>
+          </a:prstGeom>
+          <a:ln w="12700">
+            <a:solidFill>
+              <a:schemeClr val="tx1"/>
+            </a:solidFill>
+            <a:headEnd type="arrow"/>
+            <a:tailEnd type="arrow"/>
+          </a:ln>
+        </p:spPr>
+        <p:style>
+          <a:lnRef idx="1">
+            <a:schemeClr val="accent1"/>
+          </a:lnRef>
+          <a:fillRef idx="0">
+            <a:schemeClr val="accent1"/>
+          </a:fillRef>
+          <a:effectRef idx="0">
+            <a:schemeClr val="accent1"/>
+          </a:effectRef>
+          <a:fontRef idx="minor">
+            <a:schemeClr val="tx1"/>
+          </a:fontRef>
+        </p:style>
+      </p:cxnSp>
+      <p:sp>
+        <p:nvSpPr>
+          <p:cNvPr id="48" name="Rectangle 47">
+            <a:extLst>
+              <a:ext uri="{FF2B5EF4-FFF2-40B4-BE49-F238E27FC236}">
+                <a16:creationId xmlns:a16="http://schemas.microsoft.com/office/drawing/2014/main" id="{A1207485-D60E-FB2A-3919-B3EDA31AD605}"/>
+              </a:ext>
+            </a:extLst>
+          </p:cNvPr>
+          <p:cNvSpPr/>
+          <p:nvPr/>
+        </p:nvSpPr>
+        <p:spPr>
+          <a:xfrm>
+            <a:off x="4341573" y="5000368"/>
+            <a:ext cx="1167573" cy="1100082"/>
+          </a:xfrm>
+          <a:prstGeom prst="rect">
+            <a:avLst/>
+          </a:prstGeom>
+          <a:solidFill>
+            <a:schemeClr val="accent2">
+              <a:lumMod val="75000"/>
+            </a:schemeClr>
+          </a:solidFill>
+        </p:spPr>
+        <p:style>
+          <a:lnRef idx="2">
+            <a:schemeClr val="accent1">
+              <a:shade val="15000"/>
+            </a:schemeClr>
+          </a:lnRef>
+          <a:fillRef idx="1">
+            <a:schemeClr val="accent1"/>
+          </a:fillRef>
+          <a:effectRef idx="0">
+            <a:schemeClr val="accent1"/>
+          </a:effectRef>
+          <a:fontRef idx="minor">
+            <a:schemeClr val="lt1"/>
+          </a:fontRef>
+        </p:style>
+        <p:txBody>
+          <a:bodyPr lIns="0" tIns="0" rIns="0" bIns="0" rtlCol="0" anchor="ctr"/>
+          <a:lstStyle/>
+          <a:p>
+            <a:pPr algn="ctr"/>
+            <a:r>
+              <a:rPr lang="en-US" sz="1600" b="1" i="1" dirty="0"/>
+              <a:t>Parser LLM</a:t>
+            </a:r>
+          </a:p>
+          <a:p>
+            <a:pPr algn="ctr"/>
+            <a:r>
+              <a:rPr lang="en-US" sz="800" b="1" i="1" dirty="0"/>
+              <a:t>(Local LLM)</a:t>
+            </a:r>
+          </a:p>
+          <a:p>
+            <a:pPr algn="ctr"/>
+            <a:endParaRPr lang="en-US" sz="800" b="1" i="1" dirty="0"/>
+          </a:p>
+          <a:p>
+            <a:pPr algn="ctr"/>
+            <a:r>
+              <a:rPr lang="en-US" sz="900" dirty="0"/>
+              <a:t>📚 </a:t>
+            </a:r>
+            <a:r>
+              <a:rPr lang="en-US" sz="900" b="1" u="sng" dirty="0"/>
+              <a:t>Qwen2.5-Coder:7b</a:t>
+            </a:r>
+          </a:p>
+        </p:txBody>
+      </p:sp>
+      <p:cxnSp>
+        <p:nvCxnSpPr>
+          <p:cNvPr id="64" name="Straight Arrow Connector 63">
+            <a:extLst>
+              <a:ext uri="{FF2B5EF4-FFF2-40B4-BE49-F238E27FC236}">
+                <a16:creationId xmlns:a16="http://schemas.microsoft.com/office/drawing/2014/main" id="{876C400E-DE7F-DE8B-23CD-DE4F9C59641B}"/>
+              </a:ext>
+            </a:extLst>
+          </p:cNvPr>
+          <p:cNvCxnSpPr>
+            <a:cxnSpLocks/>
+            <a:stCxn id="6" idx="3"/>
+          </p:cNvCxnSpPr>
+          <p:nvPr/>
+        </p:nvCxnSpPr>
+        <p:spPr>
+          <a:xfrm flipV="1">
+            <a:off x="2907486" y="2127479"/>
+            <a:ext cx="1307740" cy="1"/>
+          </a:xfrm>
+          <a:prstGeom prst="straightConnector1">
+            <a:avLst/>
+          </a:prstGeom>
+          <a:ln w="12700">
+            <a:solidFill>
+              <a:schemeClr val="tx1"/>
+            </a:solidFill>
+            <a:headEnd type="arrow"/>
+            <a:tailEnd type="none"/>
+          </a:ln>
+        </p:spPr>
+        <p:style>
+          <a:lnRef idx="1">
+            <a:schemeClr val="accent1"/>
+          </a:lnRef>
+          <a:fillRef idx="0">
+            <a:schemeClr val="accent1"/>
+          </a:fillRef>
+          <a:effectRef idx="0">
+            <a:schemeClr val="accent1"/>
+          </a:effectRef>
+          <a:fontRef idx="minor">
+            <a:schemeClr val="tx1"/>
+          </a:fontRef>
+        </p:style>
+      </p:cxnSp>
+      <p:sp>
+        <p:nvSpPr>
+          <p:cNvPr id="73" name="Rectangle 72">
+            <a:extLst>
+              <a:ext uri="{FF2B5EF4-FFF2-40B4-BE49-F238E27FC236}">
+                <a16:creationId xmlns:a16="http://schemas.microsoft.com/office/drawing/2014/main" id="{3A768D3E-E65E-59D0-A9DE-9B81B3F86D94}"/>
+              </a:ext>
+            </a:extLst>
+          </p:cNvPr>
+          <p:cNvSpPr/>
+          <p:nvPr/>
+        </p:nvSpPr>
+        <p:spPr>
+          <a:xfrm>
+            <a:off x="6779879" y="4521437"/>
+            <a:ext cx="721904" cy="270336"/>
+          </a:xfrm>
+          <a:prstGeom prst="rect">
+            <a:avLst/>
+          </a:prstGeom>
+          <a:solidFill>
+            <a:srgbClr val="F7A5A5"/>
+          </a:solidFill>
+        </p:spPr>
+        <p:style>
+          <a:lnRef idx="2">
+            <a:schemeClr val="accent1">
+              <a:shade val="15000"/>
+            </a:schemeClr>
+          </a:lnRef>
+          <a:fillRef idx="1">
+            <a:schemeClr val="accent1"/>
+          </a:fillRef>
+          <a:effectRef idx="0">
+            <a:schemeClr val="accent1"/>
+          </a:effectRef>
+          <a:fontRef idx="minor">
+            <a:schemeClr val="lt1"/>
+          </a:fontRef>
+        </p:style>
+        <p:txBody>
+          <a:bodyPr lIns="0" tIns="45720" rIns="0" bIns="0" rtlCol="0" anchor="t"/>
+          <a:lstStyle/>
+          <a:p>
+            <a:pPr algn="ctr"/>
+            <a:r>
+              <a:rPr lang="en-US" sz="1100" dirty="0"/>
+              <a:t>🛢️</a:t>
+            </a:r>
+            <a:r>
+              <a:rPr lang="en-US" sz="900" b="1" dirty="0"/>
+              <a:t> </a:t>
+            </a:r>
+            <a:r>
+              <a:rPr lang="en-US" sz="1200" b="1" dirty="0"/>
+              <a:t>DB</a:t>
+            </a:r>
+            <a:endParaRPr lang="en-US" sz="900" i="1" dirty="0"/>
+          </a:p>
+        </p:txBody>
+      </p:sp>
+      <p:cxnSp>
+        <p:nvCxnSpPr>
+          <p:cNvPr id="109" name="Connector: Elbow 108">
+            <a:extLst>
+              <a:ext uri="{FF2B5EF4-FFF2-40B4-BE49-F238E27FC236}">
+                <a16:creationId xmlns:a16="http://schemas.microsoft.com/office/drawing/2014/main" id="{68CCE979-38C1-892C-888A-C361A055421E}"/>
+              </a:ext>
+            </a:extLst>
+          </p:cNvPr>
+          <p:cNvCxnSpPr>
+            <a:stCxn id="11" idx="0"/>
+            <a:endCxn id="8" idx="3"/>
+          </p:cNvCxnSpPr>
+          <p:nvPr/>
+        </p:nvCxnSpPr>
+        <p:spPr>
+          <a:xfrm rot="16200000" flipV="1">
+            <a:off x="5303605" y="1468856"/>
+            <a:ext cx="1127306" cy="1259055"/>
+          </a:xfrm>
+          <a:prstGeom prst="curvedConnector2">
+            <a:avLst/>
+          </a:prstGeom>
+          <a:ln w="12700">
+            <a:solidFill>
+              <a:schemeClr val="tx1"/>
+            </a:solidFill>
+            <a:headEnd type="none"/>
+            <a:tailEnd type="arrow"/>
+          </a:ln>
+        </p:spPr>
+        <p:style>
+          <a:lnRef idx="1">
+            <a:schemeClr val="accent1"/>
+          </a:lnRef>
+          <a:fillRef idx="0">
+            <a:schemeClr val="accent1"/>
+          </a:fillRef>
+          <a:effectRef idx="0">
+            <a:schemeClr val="accent1"/>
+          </a:effectRef>
+          <a:fontRef idx="minor">
+            <a:schemeClr val="tx1"/>
+          </a:fontRef>
+        </p:style>
+      </p:cxnSp>
+      <p:sp>
+        <p:nvSpPr>
+          <p:cNvPr id="112" name="TextBox 111">
+            <a:extLst>
+              <a:ext uri="{FF2B5EF4-FFF2-40B4-BE49-F238E27FC236}">
+                <a16:creationId xmlns:a16="http://schemas.microsoft.com/office/drawing/2014/main" id="{9FFA8364-6776-D3D2-5096-EBE29B8BFD78}"/>
               </a:ext>
             </a:extLst>
           </p:cNvPr>
@@ -7553,8 +8700,8 @@
         </p:nvSpPr>
         <p:spPr>
           <a:xfrm>
-            <a:off x="8410425" y="5846330"/>
-            <a:ext cx="591509" cy="169277"/>
+            <a:off x="5598996" y="1903523"/>
+            <a:ext cx="687689" cy="338554"/>
           </a:xfrm>
           <a:prstGeom prst="rect">
             <a:avLst/>
@@ -7569,17 +8716,77 @@
           <a:p>
             <a:r>
               <a:rPr lang="en-US" sz="1100" i="1" dirty="0"/>
-              <a:t>SQL Query</a:t>
-            </a:r>
-          </a:p>
-        </p:txBody>
-      </p:sp>
-      <p:sp>
-        <p:nvSpPr>
-          <p:cNvPr id="171" name="TextBox 170">
-            <a:extLst>
-              <a:ext uri="{FF2B5EF4-FFF2-40B4-BE49-F238E27FC236}">
-                <a16:creationId xmlns:a16="http://schemas.microsoft.com/office/drawing/2014/main" id="{C4E25829-8F49-7D62-A8DF-A418112E679F}"/>
+              <a:t>Refusal </a:t>
+            </a:r>
+            <a:r>
+              <a:rPr lang="en-US" sz="1100" dirty="0"/>
+              <a:t>|</a:t>
+            </a:r>
+            <a:r>
+              <a:rPr lang="en-US" sz="1100" i="1" dirty="0"/>
+              <a:t> </a:t>
+            </a:r>
+          </a:p>
+          <a:p>
+            <a:r>
+              <a:rPr lang="en-US" sz="1100" i="1" dirty="0"/>
+              <a:t>Clarification</a:t>
+            </a:r>
+          </a:p>
+        </p:txBody>
+      </p:sp>
+      <p:cxnSp>
+        <p:nvCxnSpPr>
+          <p:cNvPr id="113" name="Connector: Elbow 108">
+            <a:extLst>
+              <a:ext uri="{FF2B5EF4-FFF2-40B4-BE49-F238E27FC236}">
+                <a16:creationId xmlns:a16="http://schemas.microsoft.com/office/drawing/2014/main" id="{AE26BF72-4C1B-E05E-E217-85426BF0C49D}"/>
+              </a:ext>
+            </a:extLst>
+          </p:cNvPr>
+          <p:cNvCxnSpPr>
+            <a:cxnSpLocks/>
+            <a:stCxn id="13" idx="0"/>
+          </p:cNvCxnSpPr>
+          <p:nvPr/>
+        </p:nvCxnSpPr>
+        <p:spPr>
+          <a:xfrm rot="16200000" flipV="1">
+            <a:off x="5825639" y="712191"/>
+            <a:ext cx="1367591" cy="2532102"/>
+          </a:xfrm>
+          <a:prstGeom prst="curvedConnector2">
+            <a:avLst/>
+          </a:prstGeom>
+          <a:ln w="12700">
+            <a:solidFill>
+              <a:schemeClr val="tx1"/>
+            </a:solidFill>
+            <a:headEnd type="none"/>
+            <a:tailEnd type="arrow"/>
+          </a:ln>
+        </p:spPr>
+        <p:style>
+          <a:lnRef idx="1">
+            <a:schemeClr val="accent1"/>
+          </a:lnRef>
+          <a:fillRef idx="0">
+            <a:schemeClr val="accent1"/>
+          </a:fillRef>
+          <a:effectRef idx="0">
+            <a:schemeClr val="accent1"/>
+          </a:effectRef>
+          <a:fontRef idx="minor">
+            <a:schemeClr val="tx1"/>
+          </a:fontRef>
+        </p:style>
+      </p:cxnSp>
+      <p:sp>
+        <p:nvSpPr>
+          <p:cNvPr id="114" name="TextBox 113">
+            <a:extLst>
+              <a:ext uri="{FF2B5EF4-FFF2-40B4-BE49-F238E27FC236}">
+                <a16:creationId xmlns:a16="http://schemas.microsoft.com/office/drawing/2014/main" id="{49CA53C4-D49B-F86E-D5A4-FD5CADAE70DC}"/>
               </a:ext>
             </a:extLst>
           </p:cNvPr>
@@ -7587,9 +8794,9 @@
           <p:nvPr/>
         </p:nvSpPr>
         <p:spPr>
-          <a:xfrm rot="3305483">
-            <a:off x="8268959" y="3850359"/>
-            <a:ext cx="1131720" cy="169277"/>
+          <a:xfrm>
+            <a:off x="6886049" y="1471316"/>
+            <a:ext cx="615163" cy="161583"/>
           </a:xfrm>
           <a:prstGeom prst="rect">
             <a:avLst/>
@@ -7597,24 +8804,30 @@
           <a:noFill/>
         </p:spPr>
         <p:txBody>
-          <a:bodyPr wrap="none" lIns="0" tIns="0" rIns="0" bIns="0" rtlCol="0">
+          <a:bodyPr wrap="square" lIns="0" tIns="0" rIns="0" bIns="0" rtlCol="0">
             <a:spAutoFit/>
           </a:bodyPr>
           <a:lstStyle/>
           <a:p>
             <a:r>
-              <a:rPr lang="en-US" sz="1100" i="1" dirty="0"/>
-              <a:t>Query and response</a:t>
-            </a:r>
-          </a:p>
-        </p:txBody>
-      </p:sp>
-      <p:sp>
-        <p:nvSpPr>
-          <p:cNvPr id="172" name="Flowchart: Off-page Connector 171">
-            <a:extLst>
-              <a:ext uri="{FF2B5EF4-FFF2-40B4-BE49-F238E27FC236}">
-                <a16:creationId xmlns:a16="http://schemas.microsoft.com/office/drawing/2014/main" id="{0447B003-9275-D120-E27F-58CA5443AE1E}"/>
+              <a:rPr lang="en-US" sz="1050" dirty="0">
+                <a:solidFill>
+                  <a:srgbClr val="B17ED8"/>
+                </a:solidFill>
+                <a:latin typeface="Adobe Gothic Std B" panose="020B0800000000000000" pitchFamily="34" charset="-128"/>
+                <a:ea typeface="Adobe Gothic Std B" panose="020B0800000000000000" pitchFamily="34" charset="-128"/>
+              </a:rPr>
+              <a:t>ResultSet</a:t>
+            </a:r>
+          </a:p>
+        </p:txBody>
+      </p:sp>
+      <p:sp>
+        <p:nvSpPr>
+          <p:cNvPr id="117" name="Flowchart: Off-page Connector 116">
+            <a:extLst>
+              <a:ext uri="{FF2B5EF4-FFF2-40B4-BE49-F238E27FC236}">
+                <a16:creationId xmlns:a16="http://schemas.microsoft.com/office/drawing/2014/main" id="{D7C4B127-ED58-CB38-3043-477F8C136243}"/>
               </a:ext>
             </a:extLst>
           </p:cNvPr>
@@ -7623,7 +8836,7 @@
         </p:nvSpPr>
         <p:spPr>
           <a:xfrm rot="16200000">
-            <a:off x="9054676" y="3687072"/>
+            <a:off x="1572198" y="813889"/>
             <a:ext cx="186884" cy="240280"/>
           </a:xfrm>
           <a:prstGeom prst="flowChartOffpageConnector">
@@ -7672,10 +8885,10 @@
       </p:sp>
       <p:sp>
         <p:nvSpPr>
-          <p:cNvPr id="173" name="Flowchart: Off-page Connector 172">
-            <a:extLst>
-              <a:ext uri="{FF2B5EF4-FFF2-40B4-BE49-F238E27FC236}">
-                <a16:creationId xmlns:a16="http://schemas.microsoft.com/office/drawing/2014/main" id="{2C8AEE21-31C9-8EE4-5BE2-13A0E04ABDE4}"/>
+          <p:cNvPr id="118" name="Flowchart: Off-page Connector 117">
+            <a:extLst>
+              <a:ext uri="{FF2B5EF4-FFF2-40B4-BE49-F238E27FC236}">
+                <a16:creationId xmlns:a16="http://schemas.microsoft.com/office/drawing/2014/main" id="{CC198E2C-579D-69D7-7BE8-AD75D8EE4092}"/>
               </a:ext>
             </a:extLst>
           </p:cNvPr>
@@ -7684,7 +8897,7 @@
         </p:nvSpPr>
         <p:spPr>
           <a:xfrm rot="16200000">
-            <a:off x="9206075" y="5166555"/>
+            <a:off x="3995991" y="589186"/>
             <a:ext cx="186884" cy="240280"/>
           </a:xfrm>
           <a:prstGeom prst="flowChartOffpageConnector">
@@ -7733,10 +8946,10 @@
       </p:sp>
       <p:sp>
         <p:nvSpPr>
-          <p:cNvPr id="174" name="Flowchart: Off-page Connector 173">
-            <a:extLst>
-              <a:ext uri="{FF2B5EF4-FFF2-40B4-BE49-F238E27FC236}">
-                <a16:creationId xmlns:a16="http://schemas.microsoft.com/office/drawing/2014/main" id="{DC49F929-8236-C80A-DF74-45C92AFAD358}"/>
+          <p:cNvPr id="119" name="Flowchart: Off-page Connector 118">
+            <a:extLst>
+              <a:ext uri="{FF2B5EF4-FFF2-40B4-BE49-F238E27FC236}">
+                <a16:creationId xmlns:a16="http://schemas.microsoft.com/office/drawing/2014/main" id="{94CB7192-7274-F3D6-30B4-7233CC08C58F}"/>
               </a:ext>
             </a:extLst>
           </p:cNvPr>
@@ -7745,7 +8958,7 @@
         </p:nvSpPr>
         <p:spPr>
           <a:xfrm rot="16200000">
-            <a:off x="6789154" y="5248565"/>
+            <a:off x="3983792" y="2541897"/>
             <a:ext cx="186884" cy="240280"/>
           </a:xfrm>
           <a:prstGeom prst="flowChartOffpageConnector">
@@ -7794,10 +9007,10 @@
       </p:sp>
       <p:sp>
         <p:nvSpPr>
-          <p:cNvPr id="175" name="Flowchart: Off-page Connector 174">
-            <a:extLst>
-              <a:ext uri="{FF2B5EF4-FFF2-40B4-BE49-F238E27FC236}">
-                <a16:creationId xmlns:a16="http://schemas.microsoft.com/office/drawing/2014/main" id="{EAA4BC7C-AB35-5672-4A04-11F3AED98435}"/>
+          <p:cNvPr id="120" name="Flowchart: Off-page Connector 119">
+            <a:extLst>
+              <a:ext uri="{FF2B5EF4-FFF2-40B4-BE49-F238E27FC236}">
+                <a16:creationId xmlns:a16="http://schemas.microsoft.com/office/drawing/2014/main" id="{01DB02D4-794E-6EA2-5C1C-E49399D79D95}"/>
               </a:ext>
             </a:extLst>
           </p:cNvPr>
@@ -7806,7 +9019,7 @@
         </p:nvSpPr>
         <p:spPr>
           <a:xfrm rot="16200000">
-            <a:off x="8244296" y="3376702"/>
+            <a:off x="5759297" y="2541896"/>
             <a:ext cx="186884" cy="240280"/>
           </a:xfrm>
           <a:prstGeom prst="flowChartOffpageConnector">
@@ -7855,10 +9068,10 @@
       </p:sp>
       <p:sp>
         <p:nvSpPr>
-          <p:cNvPr id="176" name="Flowchart: Off-page Connector 175">
-            <a:extLst>
-              <a:ext uri="{FF2B5EF4-FFF2-40B4-BE49-F238E27FC236}">
-                <a16:creationId xmlns:a16="http://schemas.microsoft.com/office/drawing/2014/main" id="{AFCC506F-4117-8D5C-A52D-382D4EF3B926}"/>
+          <p:cNvPr id="121" name="Flowchart: Off-page Connector 120">
+            <a:extLst>
+              <a:ext uri="{FF2B5EF4-FFF2-40B4-BE49-F238E27FC236}">
+                <a16:creationId xmlns:a16="http://schemas.microsoft.com/office/drawing/2014/main" id="{4E3134F4-88B8-F4FE-19CF-EE627B72415C}"/>
               </a:ext>
             </a:extLst>
           </p:cNvPr>
@@ -7867,7 +9080,7 @@
         </p:nvSpPr>
         <p:spPr>
           <a:xfrm rot="16200000">
-            <a:off x="10473248" y="4465418"/>
+            <a:off x="7081963" y="2541895"/>
             <a:ext cx="186884" cy="240280"/>
           </a:xfrm>
           <a:prstGeom prst="flowChartOffpageConnector">
@@ -7916,10 +9129,10 @@
       </p:sp>
       <p:sp>
         <p:nvSpPr>
-          <p:cNvPr id="178" name="Thought Bubble: Cloud 177">
-            <a:extLst>
-              <a:ext uri="{FF2B5EF4-FFF2-40B4-BE49-F238E27FC236}">
-                <a16:creationId xmlns:a16="http://schemas.microsoft.com/office/drawing/2014/main" id="{22BE8A4D-DA4E-6EFE-842E-C807DCC86649}"/>
+          <p:cNvPr id="122" name="Flowchart: Off-page Connector 121">
+            <a:extLst>
+              <a:ext uri="{FF2B5EF4-FFF2-40B4-BE49-F238E27FC236}">
+                <a16:creationId xmlns:a16="http://schemas.microsoft.com/office/drawing/2014/main" id="{473F88A9-2CB3-E503-D874-718B48B13C8E}"/>
               </a:ext>
             </a:extLst>
           </p:cNvPr>
@@ -7927,17 +9140,19 @@
           <p:nvPr/>
         </p:nvSpPr>
         <p:spPr>
-          <a:xfrm>
-            <a:off x="9697423" y="2919947"/>
-            <a:ext cx="1320449" cy="509053"/>
-          </a:xfrm>
-          <a:prstGeom prst="cloudCallout">
-            <a:avLst>
-              <a:gd name="adj1" fmla="val 1435"/>
-              <a:gd name="adj2" fmla="val 46748"/>
-            </a:avLst>
-          </a:prstGeom>
-          <a:noFill/>
+          <a:xfrm rot="16200000">
+            <a:off x="6638932" y="1366235"/>
+            <a:ext cx="186884" cy="210161"/>
+          </a:xfrm>
+          <a:prstGeom prst="flowChartOffpageConnector">
+            <a:avLst/>
+          </a:prstGeom>
+          <a:solidFill>
+            <a:schemeClr val="accent4">
+              <a:lumMod val="60000"/>
+              <a:lumOff val="40000"/>
+            </a:schemeClr>
+          </a:solidFill>
         </p:spPr>
         <p:style>
           <a:lnRef idx="2">
@@ -7956,52 +9171,135 @@
           </a:fontRef>
         </p:style>
         <p:txBody>
-          <a:bodyPr rtlCol="0" anchor="ctr"/>
-          <a:lstStyle/>
-          <a:p>
-            <a:pPr algn="ctr"/>
-            <a:r>
-              <a:rPr lang="en-US" sz="2800" b="1" dirty="0">
+          <a:bodyPr vert="vert" rtlCol="0" anchor="ctr"/>
+          <a:lstStyle/>
+          <a:p>
+            <a:pPr algn="ctr"/>
+            <a:r>
+              <a:rPr lang="en-US" sz="1400" b="1" dirty="0">
+                <a:solidFill>
+                  <a:schemeClr val="accent4">
+                    <a:lumMod val="75000"/>
+                  </a:schemeClr>
+                </a:solidFill>
+              </a:rPr>
+              <a:t>6</a:t>
+            </a:r>
+          </a:p>
+        </p:txBody>
+      </p:sp>
+      <p:sp>
+        <p:nvSpPr>
+          <p:cNvPr id="123" name="Flowchart: Off-page Connector 122">
+            <a:extLst>
+              <a:ext uri="{FF2B5EF4-FFF2-40B4-BE49-F238E27FC236}">
+                <a16:creationId xmlns:a16="http://schemas.microsoft.com/office/drawing/2014/main" id="{9BEDBC72-BA05-EBD9-A868-CF9DCC0AD9A0}"/>
+              </a:ext>
+            </a:extLst>
+          </p:cNvPr>
+          <p:cNvSpPr/>
+          <p:nvPr/>
+        </p:nvSpPr>
+        <p:spPr>
+          <a:xfrm rot="16200000">
+            <a:off x="1557137" y="2022398"/>
+            <a:ext cx="186884" cy="210161"/>
+          </a:xfrm>
+          <a:prstGeom prst="flowChartOffpageConnector">
+            <a:avLst/>
+          </a:prstGeom>
+          <a:solidFill>
+            <a:schemeClr val="accent4">
+              <a:lumMod val="60000"/>
+              <a:lumOff val="40000"/>
+            </a:schemeClr>
+          </a:solidFill>
+        </p:spPr>
+        <p:style>
+          <a:lnRef idx="2">
+            <a:schemeClr val="accent1">
+              <a:shade val="15000"/>
+            </a:schemeClr>
+          </a:lnRef>
+          <a:fillRef idx="1">
+            <a:schemeClr val="accent1"/>
+          </a:fillRef>
+          <a:effectRef idx="0">
+            <a:schemeClr val="accent1"/>
+          </a:effectRef>
+          <a:fontRef idx="minor">
+            <a:schemeClr val="lt1"/>
+          </a:fontRef>
+        </p:style>
+        <p:txBody>
+          <a:bodyPr vert="vert" rtlCol="0" anchor="ctr"/>
+          <a:lstStyle/>
+          <a:p>
+            <a:pPr algn="ctr"/>
+            <a:r>
+              <a:rPr lang="en-US" sz="1400" b="1" dirty="0">
+                <a:solidFill>
+                  <a:schemeClr val="accent4">
+                    <a:lumMod val="75000"/>
+                  </a:schemeClr>
+                </a:solidFill>
+              </a:rPr>
+              <a:t>7</a:t>
+            </a:r>
+          </a:p>
+        </p:txBody>
+      </p:sp>
+      <p:sp>
+        <p:nvSpPr>
+          <p:cNvPr id="125" name="Title 1024">
+            <a:extLst>
+              <a:ext uri="{FF2B5EF4-FFF2-40B4-BE49-F238E27FC236}">
+                <a16:creationId xmlns:a16="http://schemas.microsoft.com/office/drawing/2014/main" id="{068CC61E-01B3-DEF8-1A06-BC2F944CE8A4}"/>
+              </a:ext>
+            </a:extLst>
+          </p:cNvPr>
+          <p:cNvSpPr txBox="1">
+            <a:spLocks/>
+          </p:cNvSpPr>
+          <p:nvPr/>
+        </p:nvSpPr>
+        <p:spPr>
+          <a:xfrm>
+            <a:off x="115735" y="64032"/>
+            <a:ext cx="4615498" cy="476956"/>
+          </a:xfrm>
+          <a:prstGeom prst="rect">
+            <a:avLst/>
+          </a:prstGeom>
+        </p:spPr>
+        <p:txBody>
+          <a:bodyPr vert="horz" lIns="91440" tIns="45720" rIns="91440" bIns="45720" rtlCol="0" anchor="t">
+            <a:noAutofit/>
+          </a:bodyPr>
+          <a:lstStyle>
+            <a:lvl1pPr algn="ctr" defTabSz="914400" rtl="0" eaLnBrk="1" latinLnBrk="0" hangingPunct="1">
+              <a:lnSpc>
+                <a:spcPct val="90000"/>
+              </a:lnSpc>
+              <a:spcBef>
+                <a:spcPct val="0"/>
+              </a:spcBef>
+              <a:buNone/>
+              <a:defRPr sz="6000" kern="1200">
                 <a:solidFill>
                   <a:schemeClr val="tx1"/>
                 </a:solidFill>
-              </a:rPr>
-              <a:t>User</a:t>
-            </a:r>
-          </a:p>
-        </p:txBody>
-      </p:sp>
-      <p:sp>
-        <p:nvSpPr>
-          <p:cNvPr id="179" name="TextBox 178">
-            <a:extLst>
-              <a:ext uri="{FF2B5EF4-FFF2-40B4-BE49-F238E27FC236}">
-                <a16:creationId xmlns:a16="http://schemas.microsoft.com/office/drawing/2014/main" id="{7EE5DE43-57A1-40FD-4F3A-9493D38626A3}"/>
-              </a:ext>
-            </a:extLst>
-          </p:cNvPr>
-          <p:cNvSpPr txBox="1"/>
-          <p:nvPr/>
-        </p:nvSpPr>
-        <p:spPr>
-          <a:xfrm>
-            <a:off x="9665887" y="3519100"/>
-            <a:ext cx="1561325" cy="169277"/>
-          </a:xfrm>
-          <a:prstGeom prst="rect">
-            <a:avLst/>
-          </a:prstGeom>
-          <a:noFill/>
-        </p:spPr>
-        <p:txBody>
-          <a:bodyPr wrap="none" lIns="0" tIns="0" rIns="0" bIns="0" rtlCol="0">
-            <a:spAutoFit/>
-          </a:bodyPr>
-          <a:lstStyle/>
-          <a:p>
-            <a:r>
-              <a:rPr lang="en-US" sz="1100" i="1" dirty="0"/>
-              <a:t>Ask question / Display data</a:t>
+                <a:latin typeface="+mj-lt"/>
+                <a:ea typeface="+mj-ea"/>
+                <a:cs typeface="+mj-cs"/>
+              </a:defRPr>
+            </a:lvl1pPr>
+          </a:lstStyle>
+          <a:p>
+            <a:pPr algn="l"/>
+            <a:r>
+              <a:rPr lang="en-US" sz="4000" dirty="0"/>
+              <a:t>Query Phase</a:t>
             </a:r>
           </a:p>
         </p:txBody>
@@ -8009,7 +9307,7 @@
     </p:spTree>
     <p:extLst>
       <p:ext uri="{BB962C8B-B14F-4D97-AF65-F5344CB8AC3E}">
-        <p14:creationId xmlns:p14="http://schemas.microsoft.com/office/powerpoint/2010/main" val="467536827"/>
+        <p14:creationId xmlns:p14="http://schemas.microsoft.com/office/powerpoint/2010/main" val="3238737500"/>
       </p:ext>
     </p:extLst>
   </p:cSld>

</xml_diff>

<commit_message>
Reorganise the docs: a system DESIGN plus GAPS, FUTURE, TESTING, TOOLS and STARTUP in docs/, the reference docs moved beside them, HANDOFF cut to work in progress, and step/slice history removed from docs and comments.
Co-Authored-By: Claude Opus 5.5 <noreply@anthropic.com>
</commit_message>
<xml_diff>
--- a/Project and Tool Layout.pptx
+++ b/Project and Tool Layout.pptx
@@ -9116,7 +9116,7 @@
                   </a:schemeClr>
                 </a:solidFill>
               </a:rPr>
-              <a:t>9</a:t>
+              <a:t>8</a:t>
             </a:r>
           </a:p>
         </p:txBody>
@@ -9390,7 +9390,7 @@
                   </a:schemeClr>
                 </a:solidFill>
               </a:rPr>
-              <a:t>8</a:t>
+              <a:t>7</a:t>
             </a:r>
           </a:p>
         </p:txBody>
@@ -9671,7 +9671,7 @@
                   </a:schemeClr>
                 </a:solidFill>
               </a:rPr>
-              <a:t>7</a:t>
+              <a:t>6</a:t>
             </a:r>
           </a:p>
         </p:txBody>

</xml_diff>

<commit_message>
Major diagram update, focusing on web server layout
</commit_message>
<xml_diff>
--- a/Project and Tool Layout.pptx
+++ b/Project and Tool Layout.pptx
@@ -6,8 +6,10 @@
   </p:sldMasterIdLst>
   <p:sldIdLst>
     <p:sldId id="256" r:id="rId2"/>
-    <p:sldId id="258" r:id="rId3"/>
+    <p:sldId id="262" r:id="rId3"/>
     <p:sldId id="259" r:id="rId4"/>
+    <p:sldId id="261" r:id="rId5"/>
+    <p:sldId id="263" r:id="rId6"/>
   </p:sldIdLst>
   <p:sldSz cx="12192000" cy="6858000"/>
   <p:notesSz cx="6858000" cy="9144000"/>
@@ -7049,7 +7051,7 @@
         <p:cNvPr id="1" name="">
           <a:extLst>
             <a:ext uri="{FF2B5EF4-FFF2-40B4-BE49-F238E27FC236}">
-              <a16:creationId xmlns:a16="http://schemas.microsoft.com/office/drawing/2014/main" id="{232DE0EE-A8BD-8F30-7418-87BB25146CDB}"/>
+              <a16:creationId xmlns:a16="http://schemas.microsoft.com/office/drawing/2014/main" id="{368AEC65-3B98-6345-4C16-ED19647360A8}"/>
             </a:ext>
           </a:extLst>
         </p:cNvPr>
@@ -7066,10 +7068,10 @@
       </p:grpSpPr>
       <p:sp>
         <p:nvSpPr>
-          <p:cNvPr id="16" name="Rectangle 15">
-            <a:extLst>
-              <a:ext uri="{FF2B5EF4-FFF2-40B4-BE49-F238E27FC236}">
-                <a16:creationId xmlns:a16="http://schemas.microsoft.com/office/drawing/2014/main" id="{1AEE394A-9CF7-8092-C774-EE074321C810}"/>
+          <p:cNvPr id="26" name="Rectangle 25">
+            <a:extLst>
+              <a:ext uri="{FF2B5EF4-FFF2-40B4-BE49-F238E27FC236}">
+                <a16:creationId xmlns:a16="http://schemas.microsoft.com/office/drawing/2014/main" id="{0182A2C5-7A73-3DB2-4DD1-197E91DF6C5B}"/>
               </a:ext>
             </a:extLst>
           </p:cNvPr>
@@ -7078,8 +7080,8 @@
         </p:nvSpPr>
         <p:spPr>
           <a:xfrm>
-            <a:off x="4363385" y="4022191"/>
-            <a:ext cx="1054194" cy="1650802"/>
+            <a:off x="4190128" y="3952550"/>
+            <a:ext cx="1361961" cy="1950232"/>
           </a:xfrm>
           <a:prstGeom prst="rect">
             <a:avLst/>
@@ -7114,7 +7116,14 @@
             <a:pPr algn="ctr"/>
             <a:r>
               <a:rPr lang="en-US" sz="900" b="1" dirty="0"/>
-              <a:t>🐳</a:t>
+              <a:t>🐳 Docker Container</a:t>
+            </a:r>
+          </a:p>
+          <a:p>
+            <a:pPr algn="ctr"/>
+            <a:r>
+              <a:rPr lang="en-US" sz="900" i="1" dirty="0"/>
+              <a:t>“caddy:alpine”</a:t>
             </a:r>
           </a:p>
           <a:p>
@@ -7125,10 +7134,10 @@
       </p:sp>
       <p:sp>
         <p:nvSpPr>
-          <p:cNvPr id="70" name="Rectangle 69">
-            <a:extLst>
-              <a:ext uri="{FF2B5EF4-FFF2-40B4-BE49-F238E27FC236}">
-                <a16:creationId xmlns:a16="http://schemas.microsoft.com/office/drawing/2014/main" id="{BFB9CE4D-708B-E48E-981B-EFC68A40D09E}"/>
+          <p:cNvPr id="16" name="Rectangle 15">
+            <a:extLst>
+              <a:ext uri="{FF2B5EF4-FFF2-40B4-BE49-F238E27FC236}">
+                <a16:creationId xmlns:a16="http://schemas.microsoft.com/office/drawing/2014/main" id="{6D5D0154-9275-7858-6C49-C800DB167249}"/>
               </a:ext>
             </a:extLst>
           </p:cNvPr>
@@ -7137,8 +7146,8 @@
         </p:nvSpPr>
         <p:spPr>
           <a:xfrm>
-            <a:off x="3991324" y="1019045"/>
-            <a:ext cx="3582830" cy="2525089"/>
+            <a:off x="7999996" y="1319396"/>
+            <a:ext cx="1204074" cy="1313244"/>
           </a:xfrm>
           <a:prstGeom prst="rect">
             <a:avLst/>
@@ -7167,34 +7176,25 @@
           </a:fontRef>
         </p:style>
         <p:txBody>
-          <a:bodyPr lIns="0" tIns="45720" rIns="0" bIns="0" rtlCol="0" anchor="t"/>
-          <a:lstStyle/>
-          <a:p>
-            <a:pPr algn="ctr"/>
+          <a:bodyPr lIns="0" tIns="45720" rIns="0" bIns="0" rtlCol="0" anchor="ctr"/>
+          <a:lstStyle/>
+          <a:p>
             <a:r>
               <a:rPr lang="en-US" sz="900" b="1" dirty="0"/>
-              <a:t>🐳 Docker Container</a:t>
-            </a:r>
-          </a:p>
-          <a:p>
-            <a:pPr algn="ctr"/>
-            <a:r>
-              <a:rPr lang="en-US" sz="900" i="1" dirty="0"/>
-              <a:t>“python:3.13-slim”</a:t>
-            </a:r>
-          </a:p>
-          <a:p>
-            <a:pPr algn="ctr"/>
+              <a:t>🐳</a:t>
+            </a:r>
+          </a:p>
+          <a:p>
             <a:endParaRPr lang="en-US" sz="200" i="1" dirty="0"/>
           </a:p>
         </p:txBody>
       </p:sp>
       <p:sp>
         <p:nvSpPr>
-          <p:cNvPr id="50" name="Rectangle 49">
-            <a:extLst>
-              <a:ext uri="{FF2B5EF4-FFF2-40B4-BE49-F238E27FC236}">
-                <a16:creationId xmlns:a16="http://schemas.microsoft.com/office/drawing/2014/main" id="{D620D2BF-387D-D4BF-5090-B9D7F5E1A177}"/>
+          <p:cNvPr id="70" name="Rectangle 69">
+            <a:extLst>
+              <a:ext uri="{FF2B5EF4-FFF2-40B4-BE49-F238E27FC236}">
+                <a16:creationId xmlns:a16="http://schemas.microsoft.com/office/drawing/2014/main" id="{774AE4ED-1C08-76BE-F2E4-4F2624145F75}"/>
               </a:ext>
             </a:extLst>
           </p:cNvPr>
@@ -7203,8 +7203,8 @@
         </p:nvSpPr>
         <p:spPr>
           <a:xfrm>
-            <a:off x="6393311" y="4022195"/>
-            <a:ext cx="4028187" cy="1650802"/>
+            <a:off x="3991324" y="1319396"/>
+            <a:ext cx="3582830" cy="2188475"/>
           </a:xfrm>
           <a:prstGeom prst="rect">
             <a:avLst/>
@@ -7233,7 +7233,7 @@
           </a:fontRef>
         </p:style>
         <p:txBody>
-          <a:bodyPr lIns="0" tIns="45720" rIns="0" bIns="0" rtlCol="0" anchor="b"/>
+          <a:bodyPr lIns="0" tIns="45720" rIns="0" bIns="0" rtlCol="0" anchor="t"/>
           <a:lstStyle/>
           <a:p>
             <a:pPr algn="ctr"/>
@@ -7246,7 +7246,7 @@
             <a:pPr algn="ctr"/>
             <a:r>
               <a:rPr lang="en-US" sz="900" i="1" dirty="0"/>
-              <a:t>“ollama/ollama:latest”</a:t>
+              <a:t>“python:3.13-slim”</a:t>
             </a:r>
           </a:p>
           <a:p>
@@ -7257,10 +7257,10 @@
       </p:sp>
       <p:sp>
         <p:nvSpPr>
-          <p:cNvPr id="51" name="Rectangle 50">
-            <a:extLst>
-              <a:ext uri="{FF2B5EF4-FFF2-40B4-BE49-F238E27FC236}">
-                <a16:creationId xmlns:a16="http://schemas.microsoft.com/office/drawing/2014/main" id="{E3B161CA-3951-5003-8932-A211335401FC}"/>
+          <p:cNvPr id="50" name="Rectangle 49">
+            <a:extLst>
+              <a:ext uri="{FF2B5EF4-FFF2-40B4-BE49-F238E27FC236}">
+                <a16:creationId xmlns:a16="http://schemas.microsoft.com/office/drawing/2014/main" id="{9BAEFE4A-8D34-CA13-BD6E-205310D6356D}"/>
               </a:ext>
             </a:extLst>
           </p:cNvPr>
@@ -7269,16 +7269,16 @@
         </p:nvSpPr>
         <p:spPr>
           <a:xfrm>
-            <a:off x="6452504" y="4070264"/>
-            <a:ext cx="3714012" cy="1249275"/>
+            <a:off x="7999996" y="3507872"/>
+            <a:ext cx="4028187" cy="1650802"/>
           </a:xfrm>
           <a:prstGeom prst="rect">
             <a:avLst/>
           </a:prstGeom>
           <a:solidFill>
-            <a:schemeClr val="accent2">
-              <a:lumMod val="60000"/>
-              <a:lumOff val="40000"/>
+            <a:schemeClr val="accent1">
+              <a:lumMod val="40000"/>
+              <a:lumOff val="60000"/>
             </a:schemeClr>
           </a:solidFill>
         </p:spPr>
@@ -7299,23 +7299,34 @@
           </a:fontRef>
         </p:style>
         <p:txBody>
-          <a:bodyPr lIns="0" tIns="0" rIns="0" bIns="0" rtlCol="0" anchor="b"/>
-          <a:lstStyle/>
-          <a:p>
-            <a:pPr algn="ctr"/>
-            <a:r>
-              <a:rPr lang="en-US" sz="1600" dirty="0"/>
-              <a:t>Ollama</a:t>
-            </a:r>
-          </a:p>
-        </p:txBody>
-      </p:sp>
-      <p:sp>
-        <p:nvSpPr>
-          <p:cNvPr id="52" name="Rectangle 51">
-            <a:extLst>
-              <a:ext uri="{FF2B5EF4-FFF2-40B4-BE49-F238E27FC236}">
-                <a16:creationId xmlns:a16="http://schemas.microsoft.com/office/drawing/2014/main" id="{562CBA80-95B2-D658-D869-139D92552C8F}"/>
+          <a:bodyPr lIns="0" tIns="45720" rIns="0" bIns="0" rtlCol="0" anchor="b"/>
+          <a:lstStyle/>
+          <a:p>
+            <a:pPr algn="ctr"/>
+            <a:r>
+              <a:rPr lang="en-US" sz="900" b="1" dirty="0"/>
+              <a:t>🐳 Docker Container</a:t>
+            </a:r>
+          </a:p>
+          <a:p>
+            <a:pPr algn="ctr"/>
+            <a:r>
+              <a:rPr lang="en-US" sz="900" i="1" dirty="0"/>
+              <a:t>“ollama/ollama:latest”</a:t>
+            </a:r>
+          </a:p>
+          <a:p>
+            <a:pPr algn="ctr"/>
+            <a:endParaRPr lang="en-US" sz="200" i="1" dirty="0"/>
+          </a:p>
+        </p:txBody>
+      </p:sp>
+      <p:sp>
+        <p:nvSpPr>
+          <p:cNvPr id="51" name="Rectangle 50">
+            <a:extLst>
+              <a:ext uri="{FF2B5EF4-FFF2-40B4-BE49-F238E27FC236}">
+                <a16:creationId xmlns:a16="http://schemas.microsoft.com/office/drawing/2014/main" id="{9E6B355C-7982-97C9-2B35-93572DD5AC98}"/>
               </a:ext>
             </a:extLst>
           </p:cNvPr>
@@ -7324,15 +7335,16 @@
         </p:nvSpPr>
         <p:spPr>
           <a:xfrm>
-            <a:off x="7772580" y="4070263"/>
-            <a:ext cx="1020305" cy="1020069"/>
+            <a:off x="8059189" y="3555941"/>
+            <a:ext cx="3714012" cy="1249275"/>
           </a:xfrm>
           <a:prstGeom prst="rect">
             <a:avLst/>
           </a:prstGeom>
           <a:solidFill>
             <a:schemeClr val="accent2">
-              <a:lumMod val="75000"/>
+              <a:lumMod val="60000"/>
+              <a:lumOff val="40000"/>
             </a:schemeClr>
           </a:solidFill>
         </p:spPr>
@@ -7353,42 +7365,23 @@
           </a:fontRef>
         </p:style>
         <p:txBody>
-          <a:bodyPr lIns="0" tIns="0" rIns="0" bIns="0" rtlCol="0" anchor="ctr"/>
-          <a:lstStyle/>
-          <a:p>
-            <a:pPr algn="ctr"/>
-            <a:r>
-              <a:rPr lang="en-US" sz="1200" b="1" dirty="0"/>
-              <a:t>Embedding Model</a:t>
-            </a:r>
-            <a:endParaRPr lang="en-US" sz="900" b="1" dirty="0"/>
-          </a:p>
-          <a:p>
-            <a:pPr algn="ctr"/>
-            <a:r>
-              <a:rPr lang="en-US" sz="900" dirty="0"/>
-              <a:t>📚 </a:t>
-            </a:r>
-            <a:r>
-              <a:rPr lang="en-US" sz="900" b="1" u="sng" dirty="0"/>
-              <a:t>nomic-embed-</a:t>
-            </a:r>
-          </a:p>
-          <a:p>
-            <a:pPr algn="ctr"/>
-            <a:r>
-              <a:rPr lang="en-US" sz="900" b="1" u="sng" dirty="0"/>
-              <a:t>text-v1.5</a:t>
-            </a:r>
-          </a:p>
-        </p:txBody>
-      </p:sp>
-      <p:sp>
-        <p:nvSpPr>
-          <p:cNvPr id="89" name="Rectangle 88">
-            <a:extLst>
-              <a:ext uri="{FF2B5EF4-FFF2-40B4-BE49-F238E27FC236}">
-                <a16:creationId xmlns:a16="http://schemas.microsoft.com/office/drawing/2014/main" id="{609F7108-FF93-609D-A945-2510E83DD8FF}"/>
+          <a:bodyPr lIns="0" tIns="0" rIns="0" bIns="0" rtlCol="0" anchor="b"/>
+          <a:lstStyle/>
+          <a:p>
+            <a:pPr algn="ctr"/>
+            <a:r>
+              <a:rPr lang="en-US" sz="1600" dirty="0"/>
+              <a:t>Ollama</a:t>
+            </a:r>
+          </a:p>
+        </p:txBody>
+      </p:sp>
+      <p:sp>
+        <p:nvSpPr>
+          <p:cNvPr id="52" name="Rectangle 51">
+            <a:extLst>
+              <a:ext uri="{FF2B5EF4-FFF2-40B4-BE49-F238E27FC236}">
+                <a16:creationId xmlns:a16="http://schemas.microsoft.com/office/drawing/2014/main" id="{E9918C49-6A57-37AE-A20E-CF1DC8DC3ADD}"/>
               </a:ext>
             </a:extLst>
           </p:cNvPr>
@@ -7397,8 +7390,8 @@
         </p:nvSpPr>
         <p:spPr>
           <a:xfrm>
-            <a:off x="8874980" y="4070261"/>
-            <a:ext cx="1222081" cy="1020069"/>
+            <a:off x="9379265" y="3555940"/>
+            <a:ext cx="1020305" cy="1020069"/>
           </a:xfrm>
           <a:prstGeom prst="rect">
             <a:avLst/>
@@ -7431,20 +7424,10 @@
           <a:p>
             <a:pPr algn="ctr"/>
             <a:r>
-              <a:rPr lang="en-US" sz="1600" b="1" i="1" dirty="0"/>
-              <a:t>SQL Emitter</a:t>
-            </a:r>
-          </a:p>
-          <a:p>
-            <a:pPr algn="ctr"/>
-            <a:r>
-              <a:rPr lang="en-US" sz="800" b="1" i="1" dirty="0"/>
-              <a:t>(Local LLM)</a:t>
-            </a:r>
-          </a:p>
-          <a:p>
-            <a:pPr algn="ctr"/>
-            <a:endParaRPr lang="en-US" sz="800" b="1" i="1" dirty="0"/>
+              <a:rPr lang="en-US" sz="1200" b="1" dirty="0"/>
+              <a:t>Embedding Model</a:t>
+            </a:r>
+            <a:endParaRPr lang="en-US" sz="900" b="1" dirty="0"/>
           </a:p>
           <a:p>
             <a:pPr algn="ctr"/>
@@ -7454,17 +7437,24 @@
             </a:r>
             <a:r>
               <a:rPr lang="en-US" sz="900" b="1" u="sng" dirty="0"/>
-              <a:t>Qwen2.5-Coder:7b</a:t>
-            </a:r>
-          </a:p>
-        </p:txBody>
-      </p:sp>
-      <p:sp>
-        <p:nvSpPr>
-          <p:cNvPr id="2" name="Rectangle 1">
-            <a:extLst>
-              <a:ext uri="{FF2B5EF4-FFF2-40B4-BE49-F238E27FC236}">
-                <a16:creationId xmlns:a16="http://schemas.microsoft.com/office/drawing/2014/main" id="{81D6A0B9-4705-2CEA-1EC6-D1806A8968BE}"/>
+              <a:t>nomic-embed-</a:t>
+            </a:r>
+          </a:p>
+          <a:p>
+            <a:pPr algn="ctr"/>
+            <a:r>
+              <a:rPr lang="en-US" sz="900" b="1" u="sng" dirty="0"/>
+              <a:t>text-v1.5</a:t>
+            </a:r>
+          </a:p>
+        </p:txBody>
+      </p:sp>
+      <p:sp>
+        <p:nvSpPr>
+          <p:cNvPr id="89" name="Rectangle 88">
+            <a:extLst>
+              <a:ext uri="{FF2B5EF4-FFF2-40B4-BE49-F238E27FC236}">
+                <a16:creationId xmlns:a16="http://schemas.microsoft.com/office/drawing/2014/main" id="{2740222D-2A35-EE1C-DA2F-C9D254AC42E4}"/>
               </a:ext>
             </a:extLst>
           </p:cNvPr>
@@ -7473,14 +7463,16 @@
         </p:nvSpPr>
         <p:spPr>
           <a:xfrm>
-            <a:off x="10166516" y="4070265"/>
-            <a:ext cx="202062" cy="1249274"/>
+            <a:off x="10481665" y="3555938"/>
+            <a:ext cx="1222081" cy="1020069"/>
           </a:xfrm>
           <a:prstGeom prst="rect">
             <a:avLst/>
           </a:prstGeom>
           <a:solidFill>
-            <a:srgbClr val="B17ED8"/>
+            <a:schemeClr val="accent2">
+              <a:lumMod val="75000"/>
+            </a:schemeClr>
           </a:solidFill>
         </p:spPr>
         <p:style>
@@ -7500,6 +7492,80 @@
           </a:fontRef>
         </p:style>
         <p:txBody>
+          <a:bodyPr lIns="0" tIns="0" rIns="0" bIns="0" rtlCol="0" anchor="ctr"/>
+          <a:lstStyle/>
+          <a:p>
+            <a:pPr algn="ctr"/>
+            <a:r>
+              <a:rPr lang="en-US" sz="1600" b="1" i="1" dirty="0"/>
+              <a:t>SQL Emitter</a:t>
+            </a:r>
+          </a:p>
+          <a:p>
+            <a:pPr algn="ctr"/>
+            <a:r>
+              <a:rPr lang="en-US" sz="800" b="1" i="1" dirty="0"/>
+              <a:t>(Local LLM)</a:t>
+            </a:r>
+          </a:p>
+          <a:p>
+            <a:pPr algn="ctr"/>
+            <a:endParaRPr lang="en-US" sz="800" b="1" i="1" dirty="0"/>
+          </a:p>
+          <a:p>
+            <a:pPr algn="ctr"/>
+            <a:r>
+              <a:rPr lang="en-US" sz="900" dirty="0"/>
+              <a:t>📚 </a:t>
+            </a:r>
+            <a:r>
+              <a:rPr lang="en-US" sz="900" b="1" u="sng" dirty="0"/>
+              <a:t>Qwen2.5-Coder:7b</a:t>
+            </a:r>
+          </a:p>
+        </p:txBody>
+      </p:sp>
+      <p:sp>
+        <p:nvSpPr>
+          <p:cNvPr id="2" name="Rectangle 1">
+            <a:extLst>
+              <a:ext uri="{FF2B5EF4-FFF2-40B4-BE49-F238E27FC236}">
+                <a16:creationId xmlns:a16="http://schemas.microsoft.com/office/drawing/2014/main" id="{14169A20-3607-4878-9868-AC7D3106E5B6}"/>
+              </a:ext>
+            </a:extLst>
+          </p:cNvPr>
+          <p:cNvSpPr/>
+          <p:nvPr/>
+        </p:nvSpPr>
+        <p:spPr>
+          <a:xfrm>
+            <a:off x="11773201" y="3555942"/>
+            <a:ext cx="202062" cy="1249274"/>
+          </a:xfrm>
+          <a:prstGeom prst="rect">
+            <a:avLst/>
+          </a:prstGeom>
+          <a:solidFill>
+            <a:srgbClr val="B17ED8"/>
+          </a:solidFill>
+        </p:spPr>
+        <p:style>
+          <a:lnRef idx="2">
+            <a:schemeClr val="accent1">
+              <a:shade val="15000"/>
+            </a:schemeClr>
+          </a:lnRef>
+          <a:fillRef idx="1">
+            <a:schemeClr val="accent1"/>
+          </a:fillRef>
+          <a:effectRef idx="0">
+            <a:schemeClr val="accent1"/>
+          </a:effectRef>
+          <a:fontRef idx="minor">
+            <a:schemeClr val="lt1"/>
+          </a:fontRef>
+        </p:style>
+        <p:txBody>
           <a:bodyPr vert="vert270" lIns="0" tIns="0" rIns="0" bIns="0" rtlCol="0" anchor="ctr"/>
           <a:lstStyle/>
           <a:p>
@@ -7516,7 +7582,7 @@
           <p:cNvPr id="5" name="Rectangle 4">
             <a:extLst>
               <a:ext uri="{FF2B5EF4-FFF2-40B4-BE49-F238E27FC236}">
-                <a16:creationId xmlns:a16="http://schemas.microsoft.com/office/drawing/2014/main" id="{377B6516-346C-8990-ACB5-79355B120195}"/>
+                <a16:creationId xmlns:a16="http://schemas.microsoft.com/office/drawing/2014/main" id="{F6C400ED-A1D1-98B2-554D-0095EC19BCE1}"/>
               </a:ext>
             </a:extLst>
           </p:cNvPr>
@@ -7525,7 +7591,7 @@
         </p:nvSpPr>
         <p:spPr>
           <a:xfrm>
-            <a:off x="562127" y="2634336"/>
+            <a:off x="289131" y="2934686"/>
             <a:ext cx="1116053" cy="401369"/>
           </a:xfrm>
           <a:prstGeom prst="rect">
@@ -7585,7 +7651,7 @@
           <p:cNvPr id="6" name="Rectangle 5">
             <a:extLst>
               <a:ext uri="{FF2B5EF4-FFF2-40B4-BE49-F238E27FC236}">
-                <a16:creationId xmlns:a16="http://schemas.microsoft.com/office/drawing/2014/main" id="{FDB002BE-836F-8408-1F21-4AD91EC21A2B}"/>
+                <a16:creationId xmlns:a16="http://schemas.microsoft.com/office/drawing/2014/main" id="{D34EC8A3-F27D-267B-C2D7-3D2E75E31A82}"/>
               </a:ext>
             </a:extLst>
           </p:cNvPr>
@@ -7594,7 +7660,7 @@
         </p:nvSpPr>
         <p:spPr>
           <a:xfrm>
-            <a:off x="562127" y="1493262"/>
+            <a:off x="289131" y="1793612"/>
             <a:ext cx="1116053" cy="401369"/>
           </a:xfrm>
           <a:prstGeom prst="rect">
@@ -7654,7 +7720,7 @@
           <p:cNvPr id="14" name="Straight Arrow Connector 13">
             <a:extLst>
               <a:ext uri="{FF2B5EF4-FFF2-40B4-BE49-F238E27FC236}">
-                <a16:creationId xmlns:a16="http://schemas.microsoft.com/office/drawing/2014/main" id="{C823C645-2515-192B-C854-507A34F34D39}"/>
+                <a16:creationId xmlns:a16="http://schemas.microsoft.com/office/drawing/2014/main" id="{41BAB05B-B55F-384A-6961-7BB5EF013628}"/>
               </a:ext>
             </a:extLst>
           </p:cNvPr>
@@ -7666,7 +7732,7 @@
         </p:nvCxnSpPr>
         <p:spPr>
           <a:xfrm flipH="1">
-            <a:off x="1678180" y="2835021"/>
+            <a:off x="1405184" y="3135371"/>
             <a:ext cx="552826" cy="0"/>
           </a:xfrm>
           <a:prstGeom prst="straightConnector1">
@@ -7695,59 +7761,12 @@
           </a:fontRef>
         </p:style>
       </p:cxnSp>
-      <p:cxnSp>
-        <p:nvCxnSpPr>
-          <p:cNvPr id="25" name="Straight Arrow Connector 24">
-            <a:extLst>
-              <a:ext uri="{FF2B5EF4-FFF2-40B4-BE49-F238E27FC236}">
-                <a16:creationId xmlns:a16="http://schemas.microsoft.com/office/drawing/2014/main" id="{827F5B4B-693B-6867-1F64-A4FD871C749E}"/>
-              </a:ext>
-            </a:extLst>
-          </p:cNvPr>
-          <p:cNvCxnSpPr>
-            <a:cxnSpLocks/>
-            <a:endCxn id="143" idx="2"/>
-          </p:cNvCxnSpPr>
-          <p:nvPr/>
-        </p:nvCxnSpPr>
-        <p:spPr>
-          <a:xfrm flipH="1" flipV="1">
-            <a:off x="6948754" y="3473508"/>
-            <a:ext cx="7718" cy="545074"/>
-          </a:xfrm>
-          <a:prstGeom prst="straightConnector1">
-            <a:avLst/>
-          </a:prstGeom>
-          <a:ln w="12700">
-            <a:solidFill>
-              <a:schemeClr val="tx1"/>
-            </a:solidFill>
-            <a:prstDash val="dash"/>
-            <a:headEnd type="arrow"/>
-            <a:tailEnd type="arrow"/>
-          </a:ln>
-        </p:spPr>
-        <p:style>
-          <a:lnRef idx="1">
-            <a:schemeClr val="accent1"/>
-          </a:lnRef>
-          <a:fillRef idx="0">
-            <a:schemeClr val="accent1"/>
-          </a:fillRef>
-          <a:effectRef idx="0">
-            <a:schemeClr val="accent1"/>
-          </a:effectRef>
-          <a:fontRef idx="minor">
-            <a:schemeClr val="tx1"/>
-          </a:fontRef>
-        </p:style>
-      </p:cxnSp>
       <p:sp>
         <p:nvSpPr>
           <p:cNvPr id="48" name="Rectangle 47">
             <a:extLst>
               <a:ext uri="{FF2B5EF4-FFF2-40B4-BE49-F238E27FC236}">
-                <a16:creationId xmlns:a16="http://schemas.microsoft.com/office/drawing/2014/main" id="{A1207485-D60E-FB2A-3919-B3EDA31AD605}"/>
+                <a16:creationId xmlns:a16="http://schemas.microsoft.com/office/drawing/2014/main" id="{B58C6C6F-EE91-089F-EA14-A17A90605B49}"/>
               </a:ext>
             </a:extLst>
           </p:cNvPr>
@@ -7756,7 +7775,7 @@
         </p:nvSpPr>
         <p:spPr>
           <a:xfrm>
-            <a:off x="6522912" y="4070262"/>
+            <a:off x="8129597" y="3555939"/>
             <a:ext cx="1167573" cy="1020070"/>
           </a:xfrm>
           <a:prstGeom prst="rect">
@@ -7823,7 +7842,7 @@
           <p:cNvPr id="117" name="Flowchart: Off-page Connector 116">
             <a:extLst>
               <a:ext uri="{FF2B5EF4-FFF2-40B4-BE49-F238E27FC236}">
-                <a16:creationId xmlns:a16="http://schemas.microsoft.com/office/drawing/2014/main" id="{D7C4B127-ED58-CB38-3043-477F8C136243}"/>
+                <a16:creationId xmlns:a16="http://schemas.microsoft.com/office/drawing/2014/main" id="{B27948CA-E4CF-2729-211D-66E1797C976A}"/>
               </a:ext>
             </a:extLst>
           </p:cNvPr>
@@ -7832,7 +7851,7 @@
         </p:nvSpPr>
         <p:spPr>
           <a:xfrm rot="16200000">
-            <a:off x="1998780" y="2541246"/>
+            <a:off x="1725784" y="2841596"/>
             <a:ext cx="186884" cy="240280"/>
           </a:xfrm>
           <a:prstGeom prst="flowChartOffpageConnector">
@@ -7881,10 +7900,10 @@
       </p:sp>
       <p:sp>
         <p:nvSpPr>
-          <p:cNvPr id="118" name="Flowchart: Off-page Connector 117">
-            <a:extLst>
-              <a:ext uri="{FF2B5EF4-FFF2-40B4-BE49-F238E27FC236}">
-                <a16:creationId xmlns:a16="http://schemas.microsoft.com/office/drawing/2014/main" id="{CC198E2C-579D-69D7-7BE8-AD75D8EE4092}"/>
+          <p:cNvPr id="123" name="Flowchart: Off-page Connector 122">
+            <a:extLst>
+              <a:ext uri="{FF2B5EF4-FFF2-40B4-BE49-F238E27FC236}">
+                <a16:creationId xmlns:a16="http://schemas.microsoft.com/office/drawing/2014/main" id="{C1CE6106-0B66-3171-6219-313F2DB3FD76}"/>
               </a:ext>
             </a:extLst>
           </p:cNvPr>
@@ -7893,8 +7912,8 @@
         </p:nvSpPr>
         <p:spPr>
           <a:xfrm rot="16200000">
-            <a:off x="4062433" y="2490177"/>
-            <a:ext cx="186884" cy="240280"/>
+            <a:off x="1710723" y="1715581"/>
+            <a:ext cx="186884" cy="210161"/>
           </a:xfrm>
           <a:prstGeom prst="flowChartOffpageConnector">
             <a:avLst/>
@@ -7935,68 +7954,7 @@
                   </a:schemeClr>
                 </a:solidFill>
               </a:rPr>
-              <a:t>2</a:t>
-            </a:r>
-          </a:p>
-        </p:txBody>
-      </p:sp>
-      <p:sp>
-        <p:nvSpPr>
-          <p:cNvPr id="123" name="Flowchart: Off-page Connector 122">
-            <a:extLst>
-              <a:ext uri="{FF2B5EF4-FFF2-40B4-BE49-F238E27FC236}">
-                <a16:creationId xmlns:a16="http://schemas.microsoft.com/office/drawing/2014/main" id="{9BEDBC72-BA05-EBD9-A868-CF9DCC0AD9A0}"/>
-              </a:ext>
-            </a:extLst>
-          </p:cNvPr>
-          <p:cNvSpPr/>
-          <p:nvPr/>
-        </p:nvSpPr>
-        <p:spPr>
-          <a:xfrm rot="16200000">
-            <a:off x="1983719" y="1415231"/>
-            <a:ext cx="186884" cy="210161"/>
-          </a:xfrm>
-          <a:prstGeom prst="flowChartOffpageConnector">
-            <a:avLst/>
-          </a:prstGeom>
-          <a:solidFill>
-            <a:schemeClr val="accent4">
-              <a:lumMod val="60000"/>
-              <a:lumOff val="40000"/>
-            </a:schemeClr>
-          </a:solidFill>
-        </p:spPr>
-        <p:style>
-          <a:lnRef idx="2">
-            <a:schemeClr val="accent1">
-              <a:shade val="15000"/>
-            </a:schemeClr>
-          </a:lnRef>
-          <a:fillRef idx="1">
-            <a:schemeClr val="accent1"/>
-          </a:fillRef>
-          <a:effectRef idx="0">
-            <a:schemeClr val="accent1"/>
-          </a:effectRef>
-          <a:fontRef idx="minor">
-            <a:schemeClr val="lt1"/>
-          </a:fontRef>
-        </p:style>
-        <p:txBody>
-          <a:bodyPr vert="vert" rtlCol="0" anchor="ctr"/>
-          <a:lstStyle/>
-          <a:p>
-            <a:pPr algn="ctr"/>
-            <a:r>
-              <a:rPr lang="en-US" sz="1400" b="1" dirty="0">
-                <a:solidFill>
-                  <a:schemeClr val="accent4">
-                    <a:lumMod val="75000"/>
-                  </a:schemeClr>
-                </a:solidFill>
-              </a:rPr>
-              <a:t>5</a:t>
+              <a:t>6</a:t>
             </a:r>
           </a:p>
         </p:txBody>
@@ -8006,7 +7964,7 @@
           <p:cNvPr id="125" name="Title 1024">
             <a:extLst>
               <a:ext uri="{FF2B5EF4-FFF2-40B4-BE49-F238E27FC236}">
-                <a16:creationId xmlns:a16="http://schemas.microsoft.com/office/drawing/2014/main" id="{068CC61E-01B3-DEF8-1A06-BC2F944CE8A4}"/>
+                <a16:creationId xmlns:a16="http://schemas.microsoft.com/office/drawing/2014/main" id="{5EE825B2-9BE9-CBC2-F2EB-AE70D921BE6A}"/>
               </a:ext>
             </a:extLst>
           </p:cNvPr>
@@ -8061,7 +8019,7 @@
           <p:cNvPr id="128" name="Rectangle 127">
             <a:extLst>
               <a:ext uri="{FF2B5EF4-FFF2-40B4-BE49-F238E27FC236}">
-                <a16:creationId xmlns:a16="http://schemas.microsoft.com/office/drawing/2014/main" id="{A153D90E-A2E5-4404-AD68-B92944BEAE64}"/>
+                <a16:creationId xmlns:a16="http://schemas.microsoft.com/office/drawing/2014/main" id="{55ABFD7C-8047-1744-6E35-0FE92F8A9237}"/>
               </a:ext>
             </a:extLst>
           </p:cNvPr>
@@ -8070,8 +8028,8 @@
         </p:nvSpPr>
         <p:spPr>
           <a:xfrm>
-            <a:off x="2236659" y="1376765"/>
-            <a:ext cx="1022504" cy="2096746"/>
+            <a:off x="1963663" y="1677115"/>
+            <a:ext cx="1022504" cy="3413662"/>
           </a:xfrm>
           <a:prstGeom prst="rect">
             <a:avLst/>
@@ -8105,54 +8063,16 @@
             <a:pPr algn="ctr"/>
             <a:r>
               <a:rPr lang="en-US" sz="1600" dirty="0"/>
-              <a:t>Web Client</a:t>
+              <a:t>Client</a:t>
             </a:r>
             <a:endParaRPr lang="en-US" sz="1400" dirty="0"/>
           </a:p>
           <a:p>
             <a:pPr algn="ctr"/>
-            <a:r>
-              <a:rPr lang="en-US" sz="800" u="sng" dirty="0"/>
-              <a:t>web/</a:t>
-            </a:r>
-          </a:p>
-          <a:p>
-            <a:pPr algn="ctr"/>
             <a:endParaRPr lang="en-US" sz="800" dirty="0"/>
           </a:p>
           <a:p>
             <a:pPr algn="ctr"/>
-            <a:r>
-              <a:rPr lang="en-US" sz="800" dirty="0"/>
-              <a:t>📚 </a:t>
-            </a:r>
-            <a:r>
-              <a:rPr lang="en-US" sz="800" b="1" u="sng" dirty="0"/>
-              <a:t>Angular 22</a:t>
-            </a:r>
-            <a:endParaRPr lang="en-US" sz="800" dirty="0"/>
-          </a:p>
-          <a:p>
-            <a:pPr algn="ctr"/>
-            <a:r>
-              <a:rPr lang="en-US" sz="800" dirty="0"/>
-              <a:t>📚 </a:t>
-            </a:r>
-            <a:r>
-              <a:rPr lang="en-US" sz="800" b="1" u="sng" dirty="0"/>
-              <a:t>ngrx/signals</a:t>
-            </a:r>
-          </a:p>
-          <a:p>
-            <a:pPr algn="ctr"/>
-            <a:r>
-              <a:rPr lang="en-US" sz="800" dirty="0"/>
-              <a:t>📚 </a:t>
-            </a:r>
-            <a:r>
-              <a:rPr lang="en-US" sz="800" b="1" u="sng" dirty="0"/>
-              <a:t>ng-apexcharts </a:t>
-            </a:r>
             <a:br>
               <a:rPr lang="en-US" sz="800" b="1" u="sng" dirty="0"/>
             </a:br>
@@ -8166,7 +8086,7 @@
             <a:pPr algn="ctr"/>
             <a:r>
               <a:rPr lang="en-US" sz="800" dirty="0"/>
-              <a:t>Interacts user with the web services </a:t>
+              <a:t>The HTML+JS pages a user interacts with to interface with the API</a:t>
             </a:r>
           </a:p>
         </p:txBody>
@@ -8176,7 +8096,7 @@
           <p:cNvPr id="132" name="Straight Arrow Connector 131">
             <a:extLst>
               <a:ext uri="{FF2B5EF4-FFF2-40B4-BE49-F238E27FC236}">
-                <a16:creationId xmlns:a16="http://schemas.microsoft.com/office/drawing/2014/main" id="{63A5CFC1-5969-1075-024E-14A656251337}"/>
+                <a16:creationId xmlns:a16="http://schemas.microsoft.com/office/drawing/2014/main" id="{85D2EE65-92C0-CE5A-2337-0D48B3185910}"/>
               </a:ext>
             </a:extLst>
           </p:cNvPr>
@@ -8188,7 +8108,7 @@
         </p:nvCxnSpPr>
         <p:spPr>
           <a:xfrm flipH="1">
-            <a:off x="1678180" y="1693947"/>
+            <a:off x="1405184" y="1994297"/>
             <a:ext cx="552826" cy="0"/>
           </a:xfrm>
           <a:prstGeom prst="straightConnector1">
@@ -8219,10 +8139,10 @@
       </p:cxnSp>
       <p:sp>
         <p:nvSpPr>
-          <p:cNvPr id="136" name="Flowchart: Off-page Connector 135">
-            <a:extLst>
-              <a:ext uri="{FF2B5EF4-FFF2-40B4-BE49-F238E27FC236}">
-                <a16:creationId xmlns:a16="http://schemas.microsoft.com/office/drawing/2014/main" id="{A1B0BCD8-DCD6-7861-F57A-66F9A0626BD6}"/>
+          <p:cNvPr id="143" name="Rectangle 142">
+            <a:extLst>
+              <a:ext uri="{FF2B5EF4-FFF2-40B4-BE49-F238E27FC236}">
+                <a16:creationId xmlns:a16="http://schemas.microsoft.com/office/drawing/2014/main" id="{5BD03DCB-AA87-E567-C5CE-8484550EF2AC}"/>
               </a:ext>
             </a:extLst>
           </p:cNvPr>
@@ -8230,8 +8150,88 @@
           <p:nvPr/>
         </p:nvSpPr>
         <p:spPr>
+          <a:xfrm>
+            <a:off x="6393310" y="1677116"/>
+            <a:ext cx="1110885" cy="1751234"/>
+          </a:xfrm>
+          <a:prstGeom prst="rect">
+            <a:avLst/>
+          </a:prstGeom>
+          <a:solidFill>
+            <a:srgbClr val="7030A0"/>
+          </a:solidFill>
+        </p:spPr>
+        <p:style>
+          <a:lnRef idx="2">
+            <a:schemeClr val="accent1">
+              <a:shade val="15000"/>
+            </a:schemeClr>
+          </a:lnRef>
+          <a:fillRef idx="1">
+            <a:schemeClr val="accent1"/>
+          </a:fillRef>
+          <a:effectRef idx="0">
+            <a:schemeClr val="accent1"/>
+          </a:effectRef>
+          <a:fontRef idx="minor">
+            <a:schemeClr val="lt1"/>
+          </a:fontRef>
+        </p:style>
+        <p:txBody>
+          <a:bodyPr lIns="0" tIns="0" rIns="0" bIns="0" rtlCol="0" anchor="ctr"/>
+          <a:lstStyle/>
+          <a:p>
+            <a:pPr algn="ctr"/>
+            <a:r>
+              <a:rPr lang="en-US" sz="1600" dirty="0"/>
+              <a:t>Query Pipeline</a:t>
+            </a:r>
+            <a:endParaRPr lang="en-US" sz="1400" dirty="0"/>
+          </a:p>
+          <a:p>
+            <a:pPr algn="ctr"/>
+            <a:endParaRPr lang="en-US" sz="800" dirty="0"/>
+          </a:p>
+          <a:p>
+            <a:pPr algn="ctr"/>
+            <a:r>
+              <a:rPr lang="en-US" sz="800" dirty="0"/>
+              <a:t>Takes a query string and produces an answer meant to be returned to the user</a:t>
+            </a:r>
+          </a:p>
+          <a:p>
+            <a:pPr algn="ctr"/>
+            <a:endParaRPr lang="en-US" sz="800" dirty="0"/>
+          </a:p>
+          <a:p>
+            <a:pPr algn="ctr"/>
+            <a:endParaRPr lang="en-US" sz="800" dirty="0"/>
+          </a:p>
+          <a:p>
+            <a:pPr algn="ctr"/>
+            <a:endParaRPr lang="en-US" sz="800" dirty="0"/>
+          </a:p>
+          <a:p>
+            <a:pPr algn="ctr"/>
+            <a:endParaRPr lang="en-US" sz="800" dirty="0"/>
+          </a:p>
+        </p:txBody>
+      </p:sp>
+      <p:sp>
+        <p:nvSpPr>
+          <p:cNvPr id="154" name="Flowchart: Off-page Connector 153">
+            <a:extLst>
+              <a:ext uri="{FF2B5EF4-FFF2-40B4-BE49-F238E27FC236}">
+                <a16:creationId xmlns:a16="http://schemas.microsoft.com/office/drawing/2014/main" id="{3DDA18EE-EBA5-71D4-6143-FFEF7FFBC3C1}"/>
+              </a:ext>
+            </a:extLst>
+          </p:cNvPr>
+          <p:cNvSpPr/>
+          <p:nvPr/>
+        </p:nvSpPr>
+        <p:spPr>
           <a:xfrm rot="16200000">
-            <a:off x="4045019" y="1369910"/>
+            <a:off x="6426289" y="1857144"/>
             <a:ext cx="186884" cy="210161"/>
           </a:xfrm>
           <a:prstGeom prst="flowChartOffpageConnector">
@@ -8280,151 +8280,10 @@
       </p:sp>
       <p:sp>
         <p:nvSpPr>
-          <p:cNvPr id="143" name="Rectangle 142">
-            <a:extLst>
-              <a:ext uri="{FF2B5EF4-FFF2-40B4-BE49-F238E27FC236}">
-                <a16:creationId xmlns:a16="http://schemas.microsoft.com/office/drawing/2014/main" id="{38DEB2BA-D85C-50E6-40BC-A6CD7A7ADEEE}"/>
-              </a:ext>
-            </a:extLst>
-          </p:cNvPr>
-          <p:cNvSpPr/>
-          <p:nvPr/>
-        </p:nvSpPr>
-        <p:spPr>
-          <a:xfrm>
-            <a:off x="6393311" y="1376765"/>
-            <a:ext cx="1110885" cy="2096743"/>
-          </a:xfrm>
-          <a:prstGeom prst="rect">
-            <a:avLst/>
-          </a:prstGeom>
-          <a:solidFill>
-            <a:srgbClr val="7030A0"/>
-          </a:solidFill>
-        </p:spPr>
-        <p:style>
-          <a:lnRef idx="2">
-            <a:schemeClr val="accent1">
-              <a:shade val="15000"/>
-            </a:schemeClr>
-          </a:lnRef>
-          <a:fillRef idx="1">
-            <a:schemeClr val="accent1"/>
-          </a:fillRef>
-          <a:effectRef idx="0">
-            <a:schemeClr val="accent1"/>
-          </a:effectRef>
-          <a:fontRef idx="minor">
-            <a:schemeClr val="lt1"/>
-          </a:fontRef>
-        </p:style>
-        <p:txBody>
-          <a:bodyPr lIns="0" tIns="0" rIns="0" bIns="0" rtlCol="0" anchor="ctr"/>
-          <a:lstStyle/>
-          <a:p>
-            <a:pPr algn="ctr"/>
-            <a:r>
-              <a:rPr lang="en-US" sz="1600" dirty="0"/>
-              <a:t>Query Pipeline</a:t>
-            </a:r>
-            <a:endParaRPr lang="en-US" sz="1400" dirty="0"/>
-          </a:p>
-          <a:p>
-            <a:pPr algn="ctr"/>
-            <a:endParaRPr lang="en-US" sz="800" dirty="0"/>
-          </a:p>
-          <a:p>
-            <a:pPr algn="ctr"/>
-            <a:r>
-              <a:rPr lang="en-US" sz="800" dirty="0"/>
-              <a:t>Takes a query string and produces an answer meant to be returned to the user</a:t>
-            </a:r>
-          </a:p>
-          <a:p>
-            <a:pPr algn="ctr"/>
-            <a:endParaRPr lang="en-US" sz="800" dirty="0"/>
-          </a:p>
-          <a:p>
-            <a:pPr algn="ctr"/>
-            <a:endParaRPr lang="en-US" sz="800" dirty="0"/>
-          </a:p>
-          <a:p>
-            <a:pPr algn="ctr"/>
-            <a:endParaRPr lang="en-US" sz="800" dirty="0"/>
-          </a:p>
-          <a:p>
-            <a:pPr algn="ctr"/>
-            <a:endParaRPr lang="en-US" sz="800" dirty="0"/>
-          </a:p>
-        </p:txBody>
-      </p:sp>
-      <p:sp>
-        <p:nvSpPr>
-          <p:cNvPr id="154" name="Flowchart: Off-page Connector 153">
-            <a:extLst>
-              <a:ext uri="{FF2B5EF4-FFF2-40B4-BE49-F238E27FC236}">
-                <a16:creationId xmlns:a16="http://schemas.microsoft.com/office/drawing/2014/main" id="{A3D4D619-1AF9-A9AD-A963-8280C6167FD0}"/>
-              </a:ext>
-            </a:extLst>
-          </p:cNvPr>
-          <p:cNvSpPr/>
-          <p:nvPr/>
-        </p:nvSpPr>
-        <p:spPr>
-          <a:xfrm rot="16200000">
-            <a:off x="6472356" y="1369911"/>
-            <a:ext cx="186884" cy="210161"/>
-          </a:xfrm>
-          <a:prstGeom prst="flowChartOffpageConnector">
-            <a:avLst/>
-          </a:prstGeom>
-          <a:solidFill>
-            <a:schemeClr val="accent4">
-              <a:lumMod val="60000"/>
-              <a:lumOff val="40000"/>
-            </a:schemeClr>
-          </a:solidFill>
-        </p:spPr>
-        <p:style>
-          <a:lnRef idx="2">
-            <a:schemeClr val="accent1">
-              <a:shade val="15000"/>
-            </a:schemeClr>
-          </a:lnRef>
-          <a:fillRef idx="1">
-            <a:schemeClr val="accent1"/>
-          </a:fillRef>
-          <a:effectRef idx="0">
-            <a:schemeClr val="accent1"/>
-          </a:effectRef>
-          <a:fontRef idx="minor">
-            <a:schemeClr val="lt1"/>
-          </a:fontRef>
-        </p:style>
-        <p:txBody>
-          <a:bodyPr vert="vert" rtlCol="0" anchor="ctr"/>
-          <a:lstStyle/>
-          <a:p>
-            <a:pPr algn="ctr"/>
-            <a:r>
-              <a:rPr lang="en-US" sz="1400" b="1" dirty="0">
-                <a:solidFill>
-                  <a:schemeClr val="accent4">
-                    <a:lumMod val="75000"/>
-                  </a:schemeClr>
-                </a:solidFill>
-              </a:rPr>
-              <a:t>3</a:t>
-            </a:r>
-          </a:p>
-        </p:txBody>
-      </p:sp>
-      <p:sp>
-        <p:nvSpPr>
           <p:cNvPr id="165" name="TextBox 164">
             <a:extLst>
               <a:ext uri="{FF2B5EF4-FFF2-40B4-BE49-F238E27FC236}">
-                <a16:creationId xmlns:a16="http://schemas.microsoft.com/office/drawing/2014/main" id="{505832D6-FBC7-265D-705F-64A8EB21D9EC}"/>
+                <a16:creationId xmlns:a16="http://schemas.microsoft.com/office/drawing/2014/main" id="{6B0950B3-78D4-69C2-2294-8BC7043B4DB1}"/>
               </a:ext>
             </a:extLst>
           </p:cNvPr>
@@ -8433,7 +8292,7 @@
         </p:nvSpPr>
         <p:spPr>
           <a:xfrm>
-            <a:off x="5644221" y="1724493"/>
+            <a:off x="5644221" y="2024843"/>
             <a:ext cx="816496" cy="161583"/>
           </a:xfrm>
           <a:prstGeom prst="rect">
@@ -8465,7 +8324,7 @@
           <p:cNvPr id="183" name="Rectangle 182">
             <a:extLst>
               <a:ext uri="{FF2B5EF4-FFF2-40B4-BE49-F238E27FC236}">
-                <a16:creationId xmlns:a16="http://schemas.microsoft.com/office/drawing/2014/main" id="{D43E0C22-7646-FF2D-BCA6-8C88A2D3837F}"/>
+                <a16:creationId xmlns:a16="http://schemas.microsoft.com/office/drawing/2014/main" id="{9BF8ECE2-6235-84CA-1DF5-BC7AF1D1FE51}"/>
               </a:ext>
             </a:extLst>
           </p:cNvPr>
@@ -8474,8 +8333,8 @@
         </p:nvSpPr>
         <p:spPr>
           <a:xfrm>
-            <a:off x="4392218" y="4070261"/>
-            <a:ext cx="998858" cy="1410974"/>
+            <a:off x="8171517" y="1367467"/>
+            <a:ext cx="998858" cy="1218498"/>
           </a:xfrm>
           <a:prstGeom prst="rect">
             <a:avLst/>
@@ -8595,7 +8454,7 @@
           <p:cNvPr id="30" name="TextBox 29">
             <a:extLst>
               <a:ext uri="{FF2B5EF4-FFF2-40B4-BE49-F238E27FC236}">
-                <a16:creationId xmlns:a16="http://schemas.microsoft.com/office/drawing/2014/main" id="{AFB64D13-631E-C589-C4ED-A89D01281540}"/>
+                <a16:creationId xmlns:a16="http://schemas.microsoft.com/office/drawing/2014/main" id="{888B736F-A957-5F64-656F-8D69256243E6}"/>
               </a:ext>
             </a:extLst>
           </p:cNvPr>
@@ -8604,7 +8463,7 @@
         </p:nvSpPr>
         <p:spPr>
           <a:xfrm>
-            <a:off x="5565437" y="2634336"/>
+            <a:off x="5565437" y="2934686"/>
             <a:ext cx="737772" cy="169277"/>
           </a:xfrm>
           <a:prstGeom prst="rect">
@@ -8638,7 +8497,7 @@
           <p:cNvPr id="72" name="Rectangle 71">
             <a:extLst>
               <a:ext uri="{FF2B5EF4-FFF2-40B4-BE49-F238E27FC236}">
-                <a16:creationId xmlns:a16="http://schemas.microsoft.com/office/drawing/2014/main" id="{5A941F4F-B015-3346-7BDB-4BC9B9B87C6A}"/>
+                <a16:creationId xmlns:a16="http://schemas.microsoft.com/office/drawing/2014/main" id="{9D483037-9860-406C-BE6D-CA21303232EA}"/>
               </a:ext>
             </a:extLst>
           </p:cNvPr>
@@ -8647,8 +8506,8 @@
         </p:nvSpPr>
         <p:spPr>
           <a:xfrm>
-            <a:off x="4285400" y="1376765"/>
-            <a:ext cx="1194727" cy="2100352"/>
+            <a:off x="4285400" y="1677115"/>
+            <a:ext cx="1194727" cy="1706832"/>
           </a:xfrm>
           <a:prstGeom prst="rect">
             <a:avLst/>
@@ -8680,7 +8539,7 @@
             <a:pPr algn="ctr"/>
             <a:r>
               <a:rPr lang="en-US" sz="1600" dirty="0"/>
-              <a:t>Web Server</a:t>
+              <a:t>API Server</a:t>
             </a:r>
             <a:endParaRPr lang="en-US" sz="1400" dirty="0"/>
           </a:p>
@@ -8780,7 +8639,7 @@
           <p:cNvPr id="146" name="Straight Arrow Connector 145">
             <a:extLst>
               <a:ext uri="{FF2B5EF4-FFF2-40B4-BE49-F238E27FC236}">
-                <a16:creationId xmlns:a16="http://schemas.microsoft.com/office/drawing/2014/main" id="{7B9890BF-AA75-9B52-CA47-20B28D8B417A}"/>
+                <a16:creationId xmlns:a16="http://schemas.microsoft.com/office/drawing/2014/main" id="{3A891E70-4A0D-ACF8-65DD-BB996E3244AD}"/>
               </a:ext>
             </a:extLst>
           </p:cNvPr>
@@ -8791,7 +8650,7 @@
         </p:nvCxnSpPr>
         <p:spPr>
           <a:xfrm>
-            <a:off x="5476394" y="1906884"/>
+            <a:off x="5476394" y="2207234"/>
             <a:ext cx="916917" cy="0"/>
           </a:xfrm>
           <a:prstGeom prst="straightConnector1">
@@ -8820,150 +8679,12 @@
           </a:fontRef>
         </p:style>
       </p:cxnSp>
-      <p:cxnSp>
-        <p:nvCxnSpPr>
-          <p:cNvPr id="185" name="Straight Arrow Connector 184">
-            <a:extLst>
-              <a:ext uri="{FF2B5EF4-FFF2-40B4-BE49-F238E27FC236}">
-                <a16:creationId xmlns:a16="http://schemas.microsoft.com/office/drawing/2014/main" id="{055BC9F6-8C0A-8440-8CB2-B3B3E5CAD35D}"/>
-              </a:ext>
-            </a:extLst>
-          </p:cNvPr>
-          <p:cNvCxnSpPr>
-            <a:cxnSpLocks/>
-            <a:stCxn id="72" idx="2"/>
-            <a:endCxn id="16" idx="0"/>
-          </p:cNvCxnSpPr>
-          <p:nvPr/>
-        </p:nvCxnSpPr>
-        <p:spPr>
-          <a:xfrm>
-            <a:off x="4882764" y="3477117"/>
-            <a:ext cx="7718" cy="545074"/>
-          </a:xfrm>
-          <a:prstGeom prst="straightConnector1">
-            <a:avLst/>
-          </a:prstGeom>
-          <a:ln w="12700">
-            <a:solidFill>
-              <a:schemeClr val="tx1"/>
-            </a:solidFill>
-            <a:prstDash val="dash"/>
-            <a:headEnd type="arrow"/>
-            <a:tailEnd type="arrow"/>
-          </a:ln>
-        </p:spPr>
-        <p:style>
-          <a:lnRef idx="1">
-            <a:schemeClr val="accent1"/>
-          </a:lnRef>
-          <a:fillRef idx="0">
-            <a:schemeClr val="accent1"/>
-          </a:fillRef>
-          <a:effectRef idx="0">
-            <a:schemeClr val="accent1"/>
-          </a:effectRef>
-          <a:fontRef idx="minor">
-            <a:schemeClr val="tx1"/>
-          </a:fontRef>
-        </p:style>
-      </p:cxnSp>
-      <p:cxnSp>
-        <p:nvCxnSpPr>
-          <p:cNvPr id="18" name="Straight Arrow Connector 17">
-            <a:extLst>
-              <a:ext uri="{FF2B5EF4-FFF2-40B4-BE49-F238E27FC236}">
-                <a16:creationId xmlns:a16="http://schemas.microsoft.com/office/drawing/2014/main" id="{289F1476-8289-F0DD-9B6E-4A04F3B111E0}"/>
-              </a:ext>
-            </a:extLst>
-          </p:cNvPr>
-          <p:cNvCxnSpPr>
-            <a:cxnSpLocks/>
-          </p:cNvCxnSpPr>
-          <p:nvPr/>
-        </p:nvCxnSpPr>
-        <p:spPr>
-          <a:xfrm flipH="1">
-            <a:off x="3259163" y="2835020"/>
-            <a:ext cx="1016852" cy="0"/>
-          </a:xfrm>
-          <a:prstGeom prst="straightConnector1">
-            <a:avLst/>
-          </a:prstGeom>
-          <a:ln w="12700">
-            <a:solidFill>
-              <a:schemeClr val="tx1"/>
-            </a:solidFill>
-            <a:headEnd type="arrow"/>
-            <a:tailEnd type="none"/>
-          </a:ln>
-        </p:spPr>
-        <p:style>
-          <a:lnRef idx="1">
-            <a:schemeClr val="accent1"/>
-          </a:lnRef>
-          <a:fillRef idx="0">
-            <a:schemeClr val="accent1"/>
-          </a:fillRef>
-          <a:effectRef idx="0">
-            <a:schemeClr val="accent1"/>
-          </a:effectRef>
-          <a:fontRef idx="minor">
-            <a:schemeClr val="tx1"/>
-          </a:fontRef>
-        </p:style>
-      </p:cxnSp>
-      <p:cxnSp>
-        <p:nvCxnSpPr>
-          <p:cNvPr id="64" name="Straight Arrow Connector 63">
-            <a:extLst>
-              <a:ext uri="{FF2B5EF4-FFF2-40B4-BE49-F238E27FC236}">
-                <a16:creationId xmlns:a16="http://schemas.microsoft.com/office/drawing/2014/main" id="{876C400E-DE7F-DE8B-23CD-DE4F9C59641B}"/>
-              </a:ext>
-            </a:extLst>
-          </p:cNvPr>
-          <p:cNvCxnSpPr>
-            <a:cxnSpLocks/>
-          </p:cNvCxnSpPr>
-          <p:nvPr/>
-        </p:nvCxnSpPr>
-        <p:spPr>
-          <a:xfrm>
-            <a:off x="3260789" y="1693947"/>
-            <a:ext cx="1015226" cy="0"/>
-          </a:xfrm>
-          <a:prstGeom prst="straightConnector1">
-            <a:avLst/>
-          </a:prstGeom>
-          <a:ln w="12700">
-            <a:solidFill>
-              <a:schemeClr val="tx1"/>
-            </a:solidFill>
-            <a:headEnd type="arrow"/>
-            <a:tailEnd type="none"/>
-          </a:ln>
-        </p:spPr>
-        <p:style>
-          <a:lnRef idx="1">
-            <a:schemeClr val="accent1"/>
-          </a:lnRef>
-          <a:fillRef idx="0">
-            <a:schemeClr val="accent1"/>
-          </a:fillRef>
-          <a:effectRef idx="0">
-            <a:schemeClr val="accent1"/>
-          </a:effectRef>
-          <a:fontRef idx="minor">
-            <a:schemeClr val="tx1"/>
-          </a:fontRef>
-        </p:style>
-      </p:cxnSp>
-      <p:sp>
-        <p:nvSpPr>
-          <p:cNvPr id="7" name="Rectangle 6">
-            <a:extLst>
-              <a:ext uri="{FF2B5EF4-FFF2-40B4-BE49-F238E27FC236}">
-                <a16:creationId xmlns:a16="http://schemas.microsoft.com/office/drawing/2014/main" id="{20F24B60-2905-0E09-E718-C84C2BFDB1B3}"/>
+      <p:sp>
+        <p:nvSpPr>
+          <p:cNvPr id="23" name="Rectangle 22">
+            <a:extLst>
+              <a:ext uri="{FF2B5EF4-FFF2-40B4-BE49-F238E27FC236}">
+                <a16:creationId xmlns:a16="http://schemas.microsoft.com/office/drawing/2014/main" id="{3B4BA202-17B6-5B5C-0859-508CF5F6256D}"/>
               </a:ext>
             </a:extLst>
           </p:cNvPr>
@@ -8972,15 +8693,16 @@
         </p:nvSpPr>
         <p:spPr>
           <a:xfrm>
-            <a:off x="3591753" y="1376765"/>
-            <a:ext cx="131182" cy="2096745"/>
+            <a:off x="8000202" y="2710813"/>
+            <a:ext cx="1053987" cy="424557"/>
           </a:xfrm>
           <a:prstGeom prst="rect">
             <a:avLst/>
           </a:prstGeom>
           <a:solidFill>
-            <a:schemeClr val="bg1">
-              <a:lumMod val="65000"/>
+            <a:schemeClr val="accent1">
+              <a:lumMod val="40000"/>
+              <a:lumOff val="60000"/>
             </a:schemeClr>
           </a:solidFill>
         </p:spPr>
@@ -9001,173 +8723,96 @@
           </a:fontRef>
         </p:style>
         <p:txBody>
-          <a:bodyPr lIns="0" tIns="0" rIns="0" bIns="0" rtlCol="0" anchor="ctr"/>
-          <a:lstStyle/>
-          <a:p>
-            <a:pPr algn="ctr"/>
-            <a:r>
-              <a:rPr lang="en-US" sz="1200" dirty="0"/>
-              <a:t>HTTP</a:t>
-            </a:r>
-            <a:endParaRPr lang="en-US" sz="500" dirty="0"/>
-          </a:p>
-        </p:txBody>
-      </p:sp>
-      <p:grpSp>
-        <p:nvGrpSpPr>
-          <p:cNvPr id="33" name="Group 32">
-            <a:extLst>
-              <a:ext uri="{FF2B5EF4-FFF2-40B4-BE49-F238E27FC236}">
-                <a16:creationId xmlns:a16="http://schemas.microsoft.com/office/drawing/2014/main" id="{BE1018F5-4A75-6D58-6DB4-E7F753803B71}"/>
-              </a:ext>
-            </a:extLst>
-          </p:cNvPr>
-          <p:cNvGrpSpPr/>
-          <p:nvPr/>
-        </p:nvGrpSpPr>
-        <p:grpSpPr>
-          <a:xfrm>
-            <a:off x="8000203" y="1376765"/>
-            <a:ext cx="780332" cy="424557"/>
-            <a:chOff x="8977718" y="4467817"/>
-            <a:chExt cx="780332" cy="424557"/>
-          </a:xfrm>
-        </p:grpSpPr>
-        <p:sp>
-          <p:nvSpPr>
-            <p:cNvPr id="23" name="Rectangle 22">
-              <a:extLst>
-                <a:ext uri="{FF2B5EF4-FFF2-40B4-BE49-F238E27FC236}">
-                  <a16:creationId xmlns:a16="http://schemas.microsoft.com/office/drawing/2014/main" id="{76555E47-F4F0-E310-C381-EBE0E8A67088}"/>
-                </a:ext>
-              </a:extLst>
-            </p:cNvPr>
-            <p:cNvSpPr/>
-            <p:nvPr/>
-          </p:nvSpPr>
-          <p:spPr>
-            <a:xfrm>
-              <a:off x="8977718" y="4467817"/>
-              <a:ext cx="780332" cy="424557"/>
-            </a:xfrm>
-            <a:prstGeom prst="rect">
-              <a:avLst/>
-            </a:prstGeom>
-            <a:solidFill>
-              <a:schemeClr val="accent1">
-                <a:lumMod val="40000"/>
-                <a:lumOff val="60000"/>
-              </a:schemeClr>
-            </a:solidFill>
-          </p:spPr>
-          <p:style>
-            <a:lnRef idx="2">
-              <a:schemeClr val="accent1">
-                <a:shade val="15000"/>
-              </a:schemeClr>
-            </a:lnRef>
-            <a:fillRef idx="1">
-              <a:schemeClr val="accent1"/>
-            </a:fillRef>
-            <a:effectRef idx="0">
-              <a:schemeClr val="accent1"/>
-            </a:effectRef>
-            <a:fontRef idx="minor">
-              <a:schemeClr val="lt1"/>
-            </a:fontRef>
-          </p:style>
-          <p:txBody>
-            <a:bodyPr lIns="0" tIns="45720" rIns="0" bIns="0" rtlCol="0" anchor="ctr"/>
-            <a:lstStyle/>
-            <a:p>
-              <a:r>
-                <a:rPr lang="en-US" sz="900" b="1" dirty="0"/>
-                <a:t>🐳</a:t>
-              </a:r>
-            </a:p>
-            <a:p>
-              <a:pPr algn="ctr"/>
-              <a:endParaRPr lang="en-US" sz="200" i="1" dirty="0"/>
-            </a:p>
-          </p:txBody>
-        </p:sp>
-        <p:sp>
-          <p:nvSpPr>
-            <p:cNvPr id="24" name="Rectangle 23">
-              <a:extLst>
-                <a:ext uri="{FF2B5EF4-FFF2-40B4-BE49-F238E27FC236}">
-                  <a16:creationId xmlns:a16="http://schemas.microsoft.com/office/drawing/2014/main" id="{BEF93897-39CC-878E-B9D7-F294A939278E}"/>
-                </a:ext>
-              </a:extLst>
-            </p:cNvPr>
-            <p:cNvSpPr/>
-            <p:nvPr/>
-          </p:nvSpPr>
-          <p:spPr>
-            <a:xfrm>
-              <a:off x="9154560" y="4493215"/>
-              <a:ext cx="579731" cy="372461"/>
-            </a:xfrm>
-            <a:prstGeom prst="rect">
-              <a:avLst/>
-            </a:prstGeom>
-            <a:solidFill>
-              <a:srgbClr val="F4B183"/>
-            </a:solidFill>
-          </p:spPr>
-          <p:style>
-            <a:lnRef idx="2">
-              <a:schemeClr val="accent1">
-                <a:shade val="15000"/>
-              </a:schemeClr>
-            </a:lnRef>
-            <a:fillRef idx="1">
-              <a:schemeClr val="accent1"/>
-            </a:fillRef>
-            <a:effectRef idx="0">
-              <a:schemeClr val="accent1"/>
-            </a:effectRef>
-            <a:fontRef idx="minor">
-              <a:schemeClr val="lt1"/>
-            </a:fontRef>
-          </p:style>
-          <p:txBody>
-            <a:bodyPr lIns="0" tIns="45720" rIns="0" bIns="0" rtlCol="0" anchor="t"/>
-            <a:lstStyle/>
-            <a:p>
-              <a:pPr algn="ctr"/>
-              <a:r>
-                <a:rPr lang="en-US" sz="1100" dirty="0"/>
-                <a:t>🛢️</a:t>
-              </a:r>
-              <a:r>
-                <a:rPr lang="en-US" sz="900" b="1" dirty="0"/>
-                <a:t> </a:t>
-              </a:r>
-              <a:r>
-                <a:rPr lang="en-US" sz="1200" b="1" dirty="0"/>
-                <a:t>DB</a:t>
-              </a:r>
-            </a:p>
-            <a:p>
-              <a:pPr marL="171450" indent="-91440">
-                <a:buFont typeface="Arial" panose="020B0604020202020204" pitchFamily="34" charset="0"/>
-                <a:buChar char="•"/>
-              </a:pPr>
-              <a:r>
-                <a:rPr lang="en-US" sz="900" dirty="0"/>
-                <a:t>xbrl</a:t>
-              </a:r>
-            </a:p>
-          </p:txBody>
-        </p:sp>
-      </p:grpSp>
+          <a:bodyPr lIns="0" tIns="45720" rIns="0" bIns="0" rtlCol="0" anchor="ctr"/>
+          <a:lstStyle/>
+          <a:p>
+            <a:r>
+              <a:rPr lang="en-US" sz="900" b="1" dirty="0"/>
+              <a:t>🐳</a:t>
+            </a:r>
+          </a:p>
+          <a:p>
+            <a:pPr algn="ctr"/>
+            <a:endParaRPr lang="en-US" sz="200" i="1" dirty="0"/>
+          </a:p>
+        </p:txBody>
+      </p:sp>
+      <p:sp>
+        <p:nvSpPr>
+          <p:cNvPr id="24" name="Rectangle 23">
+            <a:extLst>
+              <a:ext uri="{FF2B5EF4-FFF2-40B4-BE49-F238E27FC236}">
+                <a16:creationId xmlns:a16="http://schemas.microsoft.com/office/drawing/2014/main" id="{47BCC2B6-C74A-2DE2-83B5-4B306E2FF2DC}"/>
+              </a:ext>
+            </a:extLst>
+          </p:cNvPr>
+          <p:cNvSpPr/>
+          <p:nvPr/>
+        </p:nvSpPr>
+        <p:spPr>
+          <a:xfrm>
+            <a:off x="8171517" y="2736211"/>
+            <a:ext cx="850581" cy="372461"/>
+          </a:xfrm>
+          <a:prstGeom prst="rect">
+            <a:avLst/>
+          </a:prstGeom>
+          <a:solidFill>
+            <a:srgbClr val="F4B183"/>
+          </a:solidFill>
+        </p:spPr>
+        <p:style>
+          <a:lnRef idx="2">
+            <a:schemeClr val="accent1">
+              <a:shade val="15000"/>
+            </a:schemeClr>
+          </a:lnRef>
+          <a:fillRef idx="1">
+            <a:schemeClr val="accent1"/>
+          </a:fillRef>
+          <a:effectRef idx="0">
+            <a:schemeClr val="accent1"/>
+          </a:effectRef>
+          <a:fontRef idx="minor">
+            <a:schemeClr val="lt1"/>
+          </a:fontRef>
+        </p:style>
+        <p:txBody>
+          <a:bodyPr lIns="0" tIns="45720" rIns="0" bIns="0" rtlCol="0" anchor="t"/>
+          <a:lstStyle/>
+          <a:p>
+            <a:pPr algn="ctr"/>
+            <a:r>
+              <a:rPr lang="en-US" sz="1100" dirty="0"/>
+              <a:t>🛢️</a:t>
+            </a:r>
+            <a:r>
+              <a:rPr lang="en-US" sz="900" b="1" dirty="0"/>
+              <a:t> </a:t>
+            </a:r>
+            <a:r>
+              <a:rPr lang="en-US" sz="1200" b="1" dirty="0"/>
+              <a:t>DB</a:t>
+            </a:r>
+          </a:p>
+          <a:p>
+            <a:pPr marL="171450" indent="-91440">
+              <a:buFont typeface="Arial" panose="020B0604020202020204" pitchFamily="34" charset="0"/>
+              <a:buChar char="•"/>
+            </a:pPr>
+            <a:r>
+              <a:rPr lang="en-US" sz="900" dirty="0"/>
+              <a:t>xbrl</a:t>
+            </a:r>
+          </a:p>
+        </p:txBody>
+      </p:sp>
       <p:cxnSp>
         <p:nvCxnSpPr>
           <p:cNvPr id="38" name="Straight Arrow Connector 37">
             <a:extLst>
               <a:ext uri="{FF2B5EF4-FFF2-40B4-BE49-F238E27FC236}">
-                <a16:creationId xmlns:a16="http://schemas.microsoft.com/office/drawing/2014/main" id="{06A4713F-5E88-B7D3-0663-9307B4B51563}"/>
+                <a16:creationId xmlns:a16="http://schemas.microsoft.com/office/drawing/2014/main" id="{3ABA23A2-9E0A-EF85-AE84-C67620465958}"/>
               </a:ext>
             </a:extLst>
           </p:cNvPr>
@@ -9178,7 +8823,7 @@
         </p:nvCxnSpPr>
         <p:spPr>
           <a:xfrm flipH="1">
-            <a:off x="5483381" y="2835020"/>
+            <a:off x="5483381" y="3135370"/>
             <a:ext cx="909930" cy="0"/>
           </a:xfrm>
           <a:prstGeom prst="straightConnector1">
@@ -9212,7 +8857,7 @@
           <p:cNvPr id="56" name="Straight Arrow Connector 55">
             <a:extLst>
               <a:ext uri="{FF2B5EF4-FFF2-40B4-BE49-F238E27FC236}">
-                <a16:creationId xmlns:a16="http://schemas.microsoft.com/office/drawing/2014/main" id="{5AD8693A-2225-9F20-4278-50FD31AD2C77}"/>
+                <a16:creationId xmlns:a16="http://schemas.microsoft.com/office/drawing/2014/main" id="{5C4D6691-A751-DA49-0A56-0EE36C6105F2}"/>
               </a:ext>
             </a:extLst>
           </p:cNvPr>
@@ -9224,8 +8869,8 @@
         </p:nvCxnSpPr>
         <p:spPr>
           <a:xfrm>
-            <a:off x="7504196" y="1588393"/>
-            <a:ext cx="496007" cy="651"/>
+            <a:off x="7504196" y="2922441"/>
+            <a:ext cx="496006" cy="651"/>
           </a:xfrm>
           <a:prstGeom prst="straightConnector1">
             <a:avLst/>
@@ -9254,10 +8899,683 @@
           </a:fontRef>
         </p:style>
       </p:cxnSp>
+      <p:sp>
+        <p:nvSpPr>
+          <p:cNvPr id="74" name="Rectangle 73">
+            <a:extLst>
+              <a:ext uri="{FF2B5EF4-FFF2-40B4-BE49-F238E27FC236}">
+                <a16:creationId xmlns:a16="http://schemas.microsoft.com/office/drawing/2014/main" id="{1480122E-229C-B491-3E8E-590CD91098D8}"/>
+              </a:ext>
+            </a:extLst>
+          </p:cNvPr>
+          <p:cNvSpPr/>
+          <p:nvPr/>
+        </p:nvSpPr>
+        <p:spPr>
+          <a:xfrm>
+            <a:off x="4285400" y="4013034"/>
+            <a:ext cx="1194727" cy="1534841"/>
+          </a:xfrm>
+          <a:prstGeom prst="rect">
+            <a:avLst/>
+          </a:prstGeom>
+          <a:solidFill>
+            <a:schemeClr val="tx2">
+              <a:lumMod val="60000"/>
+              <a:lumOff val="40000"/>
+            </a:schemeClr>
+          </a:solidFill>
+        </p:spPr>
+        <p:style>
+          <a:lnRef idx="2">
+            <a:schemeClr val="accent1">
+              <a:shade val="15000"/>
+            </a:schemeClr>
+          </a:lnRef>
+          <a:fillRef idx="1">
+            <a:schemeClr val="accent1"/>
+          </a:fillRef>
+          <a:effectRef idx="0">
+            <a:schemeClr val="accent1"/>
+          </a:effectRef>
+          <a:fontRef idx="minor">
+            <a:schemeClr val="lt1"/>
+          </a:fontRef>
+        </p:style>
+        <p:txBody>
+          <a:bodyPr lIns="0" tIns="0" rIns="0" bIns="0" rtlCol="0" anchor="ctr"/>
+          <a:lstStyle/>
+          <a:p>
+            <a:pPr algn="ctr"/>
+            <a:r>
+              <a:rPr lang="en-US" sz="1600" dirty="0"/>
+              <a:t>Web Server</a:t>
+            </a:r>
+          </a:p>
+          <a:p>
+            <a:pPr algn="ctr"/>
+            <a:r>
+              <a:rPr lang="en-US" sz="600" dirty="0"/>
+              <a:t>(Caddy)</a:t>
+            </a:r>
+            <a:endParaRPr lang="en-US" sz="500" dirty="0"/>
+          </a:p>
+          <a:p>
+            <a:pPr algn="ctr"/>
+            <a:r>
+              <a:rPr lang="en-US" sz="1100" u="sng" dirty="0"/>
+              <a:t>web/</a:t>
+            </a:r>
+          </a:p>
+          <a:p>
+            <a:pPr algn="ctr"/>
+            <a:endParaRPr lang="en-US" sz="1100" u="sng" dirty="0"/>
+          </a:p>
+          <a:p>
+            <a:pPr algn="ctr"/>
+            <a:r>
+              <a:rPr lang="en-US" sz="800" dirty="0"/>
+              <a:t>📚 </a:t>
+            </a:r>
+            <a:r>
+              <a:rPr lang="en-US" sz="800" b="1" u="sng" dirty="0"/>
+              <a:t>Angular 22</a:t>
+            </a:r>
+            <a:endParaRPr lang="en-US" sz="800" dirty="0"/>
+          </a:p>
+          <a:p>
+            <a:pPr algn="ctr"/>
+            <a:r>
+              <a:rPr lang="en-US" sz="800" dirty="0"/>
+              <a:t>📚 </a:t>
+            </a:r>
+            <a:r>
+              <a:rPr lang="en-US" sz="800" b="1" u="sng" dirty="0"/>
+              <a:t>ngrx/signals</a:t>
+            </a:r>
+          </a:p>
+          <a:p>
+            <a:pPr algn="ctr"/>
+            <a:r>
+              <a:rPr lang="en-US" sz="800" dirty="0"/>
+              <a:t>📚 </a:t>
+            </a:r>
+            <a:r>
+              <a:rPr lang="en-US" sz="800" b="1" u="sng" dirty="0"/>
+              <a:t>ng-apexcharts</a:t>
+            </a:r>
+            <a:endParaRPr lang="en-US" sz="800" dirty="0"/>
+          </a:p>
+          <a:p>
+            <a:pPr algn="ctr"/>
+            <a:endParaRPr lang="en-US" sz="800" dirty="0"/>
+          </a:p>
+          <a:p>
+            <a:pPr algn="ctr"/>
+            <a:r>
+              <a:rPr lang="en-US" sz="800" dirty="0"/>
+              <a:t>Serves the Client </a:t>
+            </a:r>
+          </a:p>
+          <a:p>
+            <a:pPr algn="ctr"/>
+            <a:r>
+              <a:rPr lang="en-US" sz="800" dirty="0"/>
+              <a:t>HTML+JS pages</a:t>
+            </a:r>
+          </a:p>
+        </p:txBody>
+      </p:sp>
+      <p:cxnSp>
+        <p:nvCxnSpPr>
+          <p:cNvPr id="75" name="Straight Arrow Connector 74">
+            <a:extLst>
+              <a:ext uri="{FF2B5EF4-FFF2-40B4-BE49-F238E27FC236}">
+                <a16:creationId xmlns:a16="http://schemas.microsoft.com/office/drawing/2014/main" id="{5FE23C77-9F11-958A-0905-9E33B1CF083B}"/>
+              </a:ext>
+            </a:extLst>
+          </p:cNvPr>
+          <p:cNvCxnSpPr>
+            <a:cxnSpLocks/>
+            <a:stCxn id="74" idx="1"/>
+          </p:cNvCxnSpPr>
+          <p:nvPr/>
+        </p:nvCxnSpPr>
+        <p:spPr>
+          <a:xfrm flipH="1">
+            <a:off x="3010464" y="4780455"/>
+            <a:ext cx="1274936" cy="0"/>
+          </a:xfrm>
+          <a:prstGeom prst="straightConnector1">
+            <a:avLst/>
+          </a:prstGeom>
+          <a:ln w="12700">
+            <a:solidFill>
+              <a:schemeClr val="tx1"/>
+            </a:solidFill>
+            <a:headEnd type="arrow"/>
+            <a:tailEnd type="arrow"/>
+          </a:ln>
+        </p:spPr>
+        <p:style>
+          <a:lnRef idx="1">
+            <a:schemeClr val="accent1"/>
+          </a:lnRef>
+          <a:fillRef idx="0">
+            <a:schemeClr val="accent1"/>
+          </a:fillRef>
+          <a:effectRef idx="0">
+            <a:schemeClr val="accent1"/>
+          </a:effectRef>
+          <a:fontRef idx="minor">
+            <a:schemeClr val="tx1"/>
+          </a:fontRef>
+        </p:style>
+      </p:cxnSp>
+      <p:cxnSp>
+        <p:nvCxnSpPr>
+          <p:cNvPr id="83" name="Connector: Elbow 82">
+            <a:extLst>
+              <a:ext uri="{FF2B5EF4-FFF2-40B4-BE49-F238E27FC236}">
+                <a16:creationId xmlns:a16="http://schemas.microsoft.com/office/drawing/2014/main" id="{BD89F9C4-E0A3-4696-2C7F-04DF17EAC057}"/>
+              </a:ext>
+            </a:extLst>
+          </p:cNvPr>
+          <p:cNvCxnSpPr>
+            <a:cxnSpLocks/>
+            <a:stCxn id="72" idx="0"/>
+            <a:endCxn id="16" idx="0"/>
+          </p:cNvCxnSpPr>
+          <p:nvPr/>
+        </p:nvCxnSpPr>
+        <p:spPr>
+          <a:xfrm rot="5400000" flipH="1" flipV="1">
+            <a:off x="6563539" y="-361378"/>
+            <a:ext cx="357719" cy="3719269"/>
+          </a:xfrm>
+          <a:prstGeom prst="bentConnector3">
+            <a:avLst>
+              <a:gd name="adj1" fmla="val 163905"/>
+            </a:avLst>
+          </a:prstGeom>
+          <a:ln w="12700">
+            <a:solidFill>
+              <a:schemeClr val="tx1"/>
+            </a:solidFill>
+            <a:prstDash val="dash"/>
+            <a:headEnd type="arrow"/>
+            <a:tailEnd type="arrow"/>
+          </a:ln>
+        </p:spPr>
+        <p:style>
+          <a:lnRef idx="1">
+            <a:schemeClr val="accent1"/>
+          </a:lnRef>
+          <a:fillRef idx="0">
+            <a:schemeClr val="accent1"/>
+          </a:fillRef>
+          <a:effectRef idx="0">
+            <a:schemeClr val="accent1"/>
+          </a:effectRef>
+          <a:fontRef idx="minor">
+            <a:schemeClr val="tx1"/>
+          </a:fontRef>
+        </p:style>
+      </p:cxnSp>
+      <p:sp>
+        <p:nvSpPr>
+          <p:cNvPr id="4" name="TextBox 3">
+            <a:extLst>
+              <a:ext uri="{FF2B5EF4-FFF2-40B4-BE49-F238E27FC236}">
+                <a16:creationId xmlns:a16="http://schemas.microsoft.com/office/drawing/2014/main" id="{CBC2861F-785C-642F-E5A6-CD4C94ACA223}"/>
+              </a:ext>
+            </a:extLst>
+          </p:cNvPr>
+          <p:cNvSpPr txBox="1"/>
+          <p:nvPr/>
+        </p:nvSpPr>
+        <p:spPr>
+          <a:xfrm>
+            <a:off x="3266505" y="4804373"/>
+            <a:ext cx="816833" cy="169277"/>
+          </a:xfrm>
+          <a:prstGeom prst="rect">
+            <a:avLst/>
+          </a:prstGeom>
+          <a:noFill/>
+        </p:spPr>
+        <p:txBody>
+          <a:bodyPr wrap="square" lIns="0" tIns="0" rIns="0" bIns="0" rtlCol="0">
+            <a:spAutoFit/>
+          </a:bodyPr>
+          <a:lstStyle>
+            <a:defPPr>
+              <a:defRPr lang="en-US"/>
+            </a:defPPr>
+            <a:lvl1pPr algn="r">
+              <a:defRPr sz="1100" i="1"/>
+            </a:lvl1pPr>
+          </a:lstStyle>
+          <a:p>
+            <a:pPr algn="ctr"/>
+            <a:r>
+              <a:rPr lang="en-US" dirty="0"/>
+              <a:t>JSON + events</a:t>
+            </a:r>
+          </a:p>
+        </p:txBody>
+      </p:sp>
+      <p:sp>
+        <p:nvSpPr>
+          <p:cNvPr id="9" name="TextBox 8">
+            <a:extLst>
+              <a:ext uri="{FF2B5EF4-FFF2-40B4-BE49-F238E27FC236}">
+                <a16:creationId xmlns:a16="http://schemas.microsoft.com/office/drawing/2014/main" id="{A8018FAA-AEBE-E7A7-CB24-80C4201B4236}"/>
+              </a:ext>
+            </a:extLst>
+          </p:cNvPr>
+          <p:cNvSpPr txBox="1"/>
+          <p:nvPr/>
+        </p:nvSpPr>
+        <p:spPr>
+          <a:xfrm>
+            <a:off x="3318085" y="4968158"/>
+            <a:ext cx="670228" cy="169277"/>
+          </a:xfrm>
+          <a:prstGeom prst="rect">
+            <a:avLst/>
+          </a:prstGeom>
+          <a:noFill/>
+        </p:spPr>
+        <p:txBody>
+          <a:bodyPr wrap="square" lIns="0" tIns="0" rIns="0" bIns="0" rtlCol="0">
+            <a:spAutoFit/>
+          </a:bodyPr>
+          <a:lstStyle>
+            <a:defPPr>
+              <a:defRPr lang="en-US"/>
+            </a:defPPr>
+            <a:lvl1pPr algn="r">
+              <a:defRPr sz="1100" i="1"/>
+            </a:lvl1pPr>
+          </a:lstStyle>
+          <a:p>
+            <a:pPr algn="ctr"/>
+            <a:r>
+              <a:rPr lang="en-US" dirty="0"/>
+              <a:t>HTML + JS</a:t>
+            </a:r>
+          </a:p>
+        </p:txBody>
+      </p:sp>
+      <p:sp>
+        <p:nvSpPr>
+          <p:cNvPr id="10" name="TextBox 9">
+            <a:extLst>
+              <a:ext uri="{FF2B5EF4-FFF2-40B4-BE49-F238E27FC236}">
+                <a16:creationId xmlns:a16="http://schemas.microsoft.com/office/drawing/2014/main" id="{C13DA346-7CB0-96D7-8EC5-FD9E1EA22013}"/>
+              </a:ext>
+            </a:extLst>
+          </p:cNvPr>
+          <p:cNvSpPr txBox="1"/>
+          <p:nvPr/>
+        </p:nvSpPr>
+        <p:spPr>
+          <a:xfrm>
+            <a:off x="3213585" y="4576007"/>
+            <a:ext cx="816833" cy="153888"/>
+          </a:xfrm>
+          <a:prstGeom prst="rect">
+            <a:avLst/>
+          </a:prstGeom>
+          <a:noFill/>
+        </p:spPr>
+        <p:txBody>
+          <a:bodyPr wrap="square" lIns="0" tIns="0" rIns="0" bIns="0" rtlCol="0">
+            <a:spAutoFit/>
+          </a:bodyPr>
+          <a:lstStyle>
+            <a:defPPr>
+              <a:defRPr lang="en-US"/>
+            </a:defPPr>
+            <a:lvl1pPr algn="r">
+              <a:defRPr sz="1100" i="1"/>
+            </a:lvl1pPr>
+          </a:lstStyle>
+          <a:p>
+            <a:pPr algn="ctr"/>
+            <a:r>
+              <a:rPr lang="en-US" sz="1000" i="0" dirty="0"/>
+              <a:t>HTTP Requests</a:t>
+            </a:r>
+          </a:p>
+        </p:txBody>
+      </p:sp>
+      <p:sp>
+        <p:nvSpPr>
+          <p:cNvPr id="12" name="TextBox 11">
+            <a:extLst>
+              <a:ext uri="{FF2B5EF4-FFF2-40B4-BE49-F238E27FC236}">
+                <a16:creationId xmlns:a16="http://schemas.microsoft.com/office/drawing/2014/main" id="{052EA57F-A625-2207-FF4A-A8C1D6F8B879}"/>
+              </a:ext>
+            </a:extLst>
+          </p:cNvPr>
+          <p:cNvSpPr txBox="1"/>
+          <p:nvPr/>
+        </p:nvSpPr>
+        <p:spPr>
+          <a:xfrm>
+            <a:off x="4791970" y="3645572"/>
+            <a:ext cx="670228" cy="169277"/>
+          </a:xfrm>
+          <a:prstGeom prst="rect">
+            <a:avLst/>
+          </a:prstGeom>
+          <a:noFill/>
+        </p:spPr>
+        <p:txBody>
+          <a:bodyPr wrap="square" lIns="0" tIns="0" rIns="0" bIns="0" rtlCol="0">
+            <a:spAutoFit/>
+          </a:bodyPr>
+          <a:lstStyle>
+            <a:defPPr>
+              <a:defRPr lang="en-US"/>
+            </a:defPPr>
+            <a:lvl1pPr algn="r">
+              <a:defRPr sz="1100" i="1"/>
+            </a:lvl1pPr>
+          </a:lstStyle>
+          <a:p>
+            <a:pPr algn="ctr"/>
+            <a:r>
+              <a:rPr lang="en-US" dirty="0"/>
+              <a:t>/api/*</a:t>
+            </a:r>
+          </a:p>
+        </p:txBody>
+      </p:sp>
+      <p:cxnSp>
+        <p:nvCxnSpPr>
+          <p:cNvPr id="15" name="Straight Arrow Connector 14">
+            <a:extLst>
+              <a:ext uri="{FF2B5EF4-FFF2-40B4-BE49-F238E27FC236}">
+                <a16:creationId xmlns:a16="http://schemas.microsoft.com/office/drawing/2014/main" id="{F7CB8C70-34A9-BA52-6569-8902A81C5D57}"/>
+              </a:ext>
+            </a:extLst>
+          </p:cNvPr>
+          <p:cNvCxnSpPr>
+            <a:cxnSpLocks/>
+            <a:stCxn id="74" idx="0"/>
+            <a:endCxn id="72" idx="2"/>
+          </p:cNvCxnSpPr>
+          <p:nvPr/>
+        </p:nvCxnSpPr>
+        <p:spPr>
+          <a:xfrm flipV="1">
+            <a:off x="4882764" y="3383947"/>
+            <a:ext cx="0" cy="629087"/>
+          </a:xfrm>
+          <a:prstGeom prst="straightConnector1">
+            <a:avLst/>
+          </a:prstGeom>
+          <a:ln w="12700">
+            <a:solidFill>
+              <a:schemeClr val="tx1"/>
+            </a:solidFill>
+            <a:headEnd type="arrow"/>
+            <a:tailEnd type="arrow"/>
+          </a:ln>
+        </p:spPr>
+        <p:style>
+          <a:lnRef idx="1">
+            <a:schemeClr val="accent1"/>
+          </a:lnRef>
+          <a:fillRef idx="0">
+            <a:schemeClr val="accent1"/>
+          </a:fillRef>
+          <a:effectRef idx="0">
+            <a:schemeClr val="accent1"/>
+          </a:effectRef>
+          <a:fontRef idx="minor">
+            <a:schemeClr val="tx1"/>
+          </a:fontRef>
+        </p:style>
+      </p:cxnSp>
+      <p:cxnSp>
+        <p:nvCxnSpPr>
+          <p:cNvPr id="92" name="Connector: Elbow 91">
+            <a:extLst>
+              <a:ext uri="{FF2B5EF4-FFF2-40B4-BE49-F238E27FC236}">
+                <a16:creationId xmlns:a16="http://schemas.microsoft.com/office/drawing/2014/main" id="{A005EC75-6ED2-9062-08C5-B31A711C156A}"/>
+              </a:ext>
+            </a:extLst>
+          </p:cNvPr>
+          <p:cNvCxnSpPr>
+            <a:cxnSpLocks/>
+            <a:stCxn id="50" idx="1"/>
+            <a:endCxn id="143" idx="2"/>
+          </p:cNvCxnSpPr>
+          <p:nvPr/>
+        </p:nvCxnSpPr>
+        <p:spPr>
+          <a:xfrm rot="10800000">
+            <a:off x="6948754" y="3428351"/>
+            <a:ext cx="1051243" cy="904923"/>
+          </a:xfrm>
+          <a:prstGeom prst="bentConnector2">
+            <a:avLst/>
+          </a:prstGeom>
+          <a:ln w="12700">
+            <a:solidFill>
+              <a:schemeClr val="tx1"/>
+            </a:solidFill>
+            <a:prstDash val="dash"/>
+            <a:headEnd type="arrow"/>
+            <a:tailEnd type="arrow"/>
+          </a:ln>
+        </p:spPr>
+        <p:style>
+          <a:lnRef idx="1">
+            <a:schemeClr val="accent1"/>
+          </a:lnRef>
+          <a:fillRef idx="0">
+            <a:schemeClr val="accent1"/>
+          </a:fillRef>
+          <a:effectRef idx="0">
+            <a:schemeClr val="accent1"/>
+          </a:effectRef>
+          <a:fontRef idx="minor">
+            <a:schemeClr val="tx1"/>
+          </a:fontRef>
+        </p:style>
+      </p:cxnSp>
+      <p:sp>
+        <p:nvSpPr>
+          <p:cNvPr id="118" name="Flowchart: Off-page Connector 117">
+            <a:extLst>
+              <a:ext uri="{FF2B5EF4-FFF2-40B4-BE49-F238E27FC236}">
+                <a16:creationId xmlns:a16="http://schemas.microsoft.com/office/drawing/2014/main" id="{F263E383-04D9-4274-55DF-1B367571C0F0}"/>
+              </a:ext>
+            </a:extLst>
+          </p:cNvPr>
+          <p:cNvSpPr/>
+          <p:nvPr/>
+        </p:nvSpPr>
+        <p:spPr>
+          <a:xfrm rot="16200000">
+            <a:off x="4150911" y="4072697"/>
+            <a:ext cx="186884" cy="240280"/>
+          </a:xfrm>
+          <a:prstGeom prst="flowChartOffpageConnector">
+            <a:avLst/>
+          </a:prstGeom>
+          <a:solidFill>
+            <a:schemeClr val="accent4">
+              <a:lumMod val="60000"/>
+              <a:lumOff val="40000"/>
+            </a:schemeClr>
+          </a:solidFill>
+        </p:spPr>
+        <p:style>
+          <a:lnRef idx="2">
+            <a:schemeClr val="accent1">
+              <a:shade val="15000"/>
+            </a:schemeClr>
+          </a:lnRef>
+          <a:fillRef idx="1">
+            <a:schemeClr val="accent1"/>
+          </a:fillRef>
+          <a:effectRef idx="0">
+            <a:schemeClr val="accent1"/>
+          </a:effectRef>
+          <a:fontRef idx="minor">
+            <a:schemeClr val="lt1"/>
+          </a:fontRef>
+        </p:style>
+        <p:txBody>
+          <a:bodyPr vert="vert" rtlCol="0" anchor="ctr"/>
+          <a:lstStyle/>
+          <a:p>
+            <a:pPr algn="ctr"/>
+            <a:r>
+              <a:rPr lang="en-US" sz="1400" b="1" dirty="0">
+                <a:solidFill>
+                  <a:schemeClr val="accent4">
+                    <a:lumMod val="75000"/>
+                  </a:schemeClr>
+                </a:solidFill>
+              </a:rPr>
+              <a:t>2</a:t>
+            </a:r>
+          </a:p>
+        </p:txBody>
+      </p:sp>
+      <p:sp>
+        <p:nvSpPr>
+          <p:cNvPr id="28" name="Flowchart: Off-page Connector 27">
+            <a:extLst>
+              <a:ext uri="{FF2B5EF4-FFF2-40B4-BE49-F238E27FC236}">
+                <a16:creationId xmlns:a16="http://schemas.microsoft.com/office/drawing/2014/main" id="{3C23E572-F47B-64A0-F8DD-7D260DF9E656}"/>
+              </a:ext>
+            </a:extLst>
+          </p:cNvPr>
+          <p:cNvSpPr/>
+          <p:nvPr/>
+        </p:nvSpPr>
+        <p:spPr>
+          <a:xfrm rot="16200000">
+            <a:off x="5353566" y="2923047"/>
+            <a:ext cx="186884" cy="210161"/>
+          </a:xfrm>
+          <a:prstGeom prst="flowChartOffpageConnector">
+            <a:avLst/>
+          </a:prstGeom>
+          <a:solidFill>
+            <a:schemeClr val="accent4">
+              <a:lumMod val="60000"/>
+              <a:lumOff val="40000"/>
+            </a:schemeClr>
+          </a:solidFill>
+        </p:spPr>
+        <p:style>
+          <a:lnRef idx="2">
+            <a:schemeClr val="accent1">
+              <a:shade val="15000"/>
+            </a:schemeClr>
+          </a:lnRef>
+          <a:fillRef idx="1">
+            <a:schemeClr val="accent1"/>
+          </a:fillRef>
+          <a:effectRef idx="0">
+            <a:schemeClr val="accent1"/>
+          </a:effectRef>
+          <a:fontRef idx="minor">
+            <a:schemeClr val="lt1"/>
+          </a:fontRef>
+        </p:style>
+        <p:txBody>
+          <a:bodyPr vert="vert" rtlCol="0" anchor="ctr"/>
+          <a:lstStyle/>
+          <a:p>
+            <a:pPr algn="ctr"/>
+            <a:r>
+              <a:rPr lang="en-US" sz="1400" b="1" dirty="0">
+                <a:solidFill>
+                  <a:schemeClr val="accent4">
+                    <a:lumMod val="75000"/>
+                  </a:schemeClr>
+                </a:solidFill>
+              </a:rPr>
+              <a:t>3</a:t>
+            </a:r>
+          </a:p>
+        </p:txBody>
+      </p:sp>
+      <p:sp>
+        <p:nvSpPr>
+          <p:cNvPr id="136" name="Flowchart: Off-page Connector 135">
+            <a:extLst>
+              <a:ext uri="{FF2B5EF4-FFF2-40B4-BE49-F238E27FC236}">
+                <a16:creationId xmlns:a16="http://schemas.microsoft.com/office/drawing/2014/main" id="{E13A9921-036D-16B5-52F3-0B666968F8B0}"/>
+              </a:ext>
+            </a:extLst>
+          </p:cNvPr>
+          <p:cNvSpPr/>
+          <p:nvPr/>
+        </p:nvSpPr>
+        <p:spPr>
+          <a:xfrm rot="16200000">
+            <a:off x="5399276" y="1982657"/>
+            <a:ext cx="186884" cy="210161"/>
+          </a:xfrm>
+          <a:prstGeom prst="flowChartOffpageConnector">
+            <a:avLst/>
+          </a:prstGeom>
+          <a:solidFill>
+            <a:schemeClr val="accent4">
+              <a:lumMod val="60000"/>
+              <a:lumOff val="40000"/>
+            </a:schemeClr>
+          </a:solidFill>
+        </p:spPr>
+        <p:style>
+          <a:lnRef idx="2">
+            <a:schemeClr val="accent1">
+              <a:shade val="15000"/>
+            </a:schemeClr>
+          </a:lnRef>
+          <a:fillRef idx="1">
+            <a:schemeClr val="accent1"/>
+          </a:fillRef>
+          <a:effectRef idx="0">
+            <a:schemeClr val="accent1"/>
+          </a:effectRef>
+          <a:fontRef idx="minor">
+            <a:schemeClr val="lt1"/>
+          </a:fontRef>
+        </p:style>
+        <p:txBody>
+          <a:bodyPr vert="vert" rtlCol="0" anchor="ctr"/>
+          <a:lstStyle/>
+          <a:p>
+            <a:pPr algn="ctr"/>
+            <a:r>
+              <a:rPr lang="en-US" sz="1400" b="1" dirty="0">
+                <a:solidFill>
+                  <a:schemeClr val="accent4">
+                    <a:lumMod val="75000"/>
+                  </a:schemeClr>
+                </a:solidFill>
+              </a:rPr>
+              <a:t>5</a:t>
+            </a:r>
+          </a:p>
+        </p:txBody>
+      </p:sp>
     </p:spTree>
     <p:extLst>
       <p:ext uri="{BB962C8B-B14F-4D97-AF65-F5344CB8AC3E}">
-        <p14:creationId xmlns:p14="http://schemas.microsoft.com/office/powerpoint/2010/main" val="3238737500"/>
+        <p14:creationId xmlns:p14="http://schemas.microsoft.com/office/powerpoint/2010/main" val="87944047"/>
       </p:ext>
     </p:extLst>
   </p:cSld>
@@ -11028,6 +11346,1669 @@
     <p:extLst>
       <p:ext uri="{BB962C8B-B14F-4D97-AF65-F5344CB8AC3E}">
         <p14:creationId xmlns:p14="http://schemas.microsoft.com/office/powerpoint/2010/main" val="2019995292"/>
+      </p:ext>
+    </p:extLst>
+  </p:cSld>
+  <p:clrMapOvr>
+    <a:masterClrMapping/>
+  </p:clrMapOvr>
+</p:sld>
+</file>
+
+<file path=ppt/slides/slide4.xml><?xml version="1.0" encoding="utf-8"?>
+<p:sld xmlns:a="http://schemas.openxmlformats.org/drawingml/2006/main" xmlns:r="http://schemas.openxmlformats.org/officeDocument/2006/relationships" xmlns:p="http://schemas.openxmlformats.org/presentationml/2006/main">
+  <p:cSld>
+    <p:spTree>
+      <p:nvGrpSpPr>
+        <p:cNvPr id="1" name="">
+          <a:extLst>
+            <a:ext uri="{FF2B5EF4-FFF2-40B4-BE49-F238E27FC236}">
+              <a16:creationId xmlns:a16="http://schemas.microsoft.com/office/drawing/2014/main" id="{C7CE0D83-8119-E82B-CA99-B9342FEC22DD}"/>
+            </a:ext>
+          </a:extLst>
+        </p:cNvPr>
+        <p:cNvGrpSpPr/>
+        <p:nvPr/>
+      </p:nvGrpSpPr>
+      <p:grpSpPr>
+        <a:xfrm>
+          <a:off x="0" y="0"/>
+          <a:ext cx="0" cy="0"/>
+          <a:chOff x="0" y="0"/>
+          <a:chExt cx="0" cy="0"/>
+        </a:xfrm>
+      </p:grpSpPr>
+      <p:sp>
+        <p:nvSpPr>
+          <p:cNvPr id="201" name="Rectangle: Rounded Corners 200">
+            <a:extLst>
+              <a:ext uri="{FF2B5EF4-FFF2-40B4-BE49-F238E27FC236}">
+                <a16:creationId xmlns:a16="http://schemas.microsoft.com/office/drawing/2014/main" id="{E73DDC3C-908A-4491-D677-669A6CAE5244}"/>
+              </a:ext>
+            </a:extLst>
+          </p:cNvPr>
+          <p:cNvSpPr/>
+          <p:nvPr/>
+        </p:nvSpPr>
+        <p:spPr>
+          <a:xfrm>
+            <a:off x="4098114" y="3744368"/>
+            <a:ext cx="4932420" cy="2109127"/>
+          </a:xfrm>
+          <a:prstGeom prst="roundRect">
+            <a:avLst>
+              <a:gd name="adj" fmla="val 5996"/>
+            </a:avLst>
+          </a:prstGeom>
+          <a:noFill/>
+          <a:ln>
+            <a:prstDash val="sysDash"/>
+          </a:ln>
+        </p:spPr>
+        <p:style>
+          <a:lnRef idx="2">
+            <a:schemeClr val="accent1">
+              <a:shade val="15000"/>
+            </a:schemeClr>
+          </a:lnRef>
+          <a:fillRef idx="1">
+            <a:schemeClr val="accent1"/>
+          </a:fillRef>
+          <a:effectRef idx="0">
+            <a:schemeClr val="accent1"/>
+          </a:effectRef>
+          <a:fontRef idx="minor">
+            <a:schemeClr val="lt1"/>
+          </a:fontRef>
+        </p:style>
+        <p:txBody>
+          <a:bodyPr lIns="0" tIns="0" rIns="0" bIns="0" rtlCol="0" anchor="t"/>
+          <a:lstStyle/>
+          <a:p>
+            <a:pPr algn="ctr"/>
+            <a:r>
+              <a:rPr lang="en-US" sz="1200" dirty="0">
+                <a:solidFill>
+                  <a:schemeClr val="tx1"/>
+                </a:solidFill>
+              </a:rPr>
+              <a:t>Build Time</a:t>
+            </a:r>
+          </a:p>
+        </p:txBody>
+      </p:sp>
+      <p:sp>
+        <p:nvSpPr>
+          <p:cNvPr id="57" name="Rectangle 56">
+            <a:extLst>
+              <a:ext uri="{FF2B5EF4-FFF2-40B4-BE49-F238E27FC236}">
+                <a16:creationId xmlns:a16="http://schemas.microsoft.com/office/drawing/2014/main" id="{C062ABCF-6465-DFB0-05C3-695005C43686}"/>
+              </a:ext>
+            </a:extLst>
+          </p:cNvPr>
+          <p:cNvSpPr/>
+          <p:nvPr/>
+        </p:nvSpPr>
+        <p:spPr>
+          <a:xfrm>
+            <a:off x="4897822" y="4081568"/>
+            <a:ext cx="1635112" cy="1484422"/>
+          </a:xfrm>
+          <a:prstGeom prst="rect">
+            <a:avLst/>
+          </a:prstGeom>
+          <a:solidFill>
+            <a:schemeClr val="accent4">
+              <a:lumMod val="75000"/>
+            </a:schemeClr>
+          </a:solidFill>
+        </p:spPr>
+        <p:style>
+          <a:lnRef idx="2">
+            <a:schemeClr val="accent1">
+              <a:shade val="15000"/>
+            </a:schemeClr>
+          </a:lnRef>
+          <a:fillRef idx="1">
+            <a:schemeClr val="accent1"/>
+          </a:fillRef>
+          <a:effectRef idx="0">
+            <a:schemeClr val="accent1"/>
+          </a:effectRef>
+          <a:fontRef idx="minor">
+            <a:schemeClr val="lt1"/>
+          </a:fontRef>
+        </p:style>
+        <p:txBody>
+          <a:bodyPr lIns="0" tIns="0" rIns="0" bIns="0" rtlCol="0" anchor="t"/>
+          <a:lstStyle/>
+          <a:p>
+            <a:pPr algn="ctr"/>
+            <a:r>
+              <a:rPr lang="en-US" dirty="0"/>
+              <a:t>Angular CLI</a:t>
+            </a:r>
+          </a:p>
+        </p:txBody>
+      </p:sp>
+      <p:sp>
+        <p:nvSpPr>
+          <p:cNvPr id="75" name="Rectangle 74">
+            <a:extLst>
+              <a:ext uri="{FF2B5EF4-FFF2-40B4-BE49-F238E27FC236}">
+                <a16:creationId xmlns:a16="http://schemas.microsoft.com/office/drawing/2014/main" id="{17252D85-CAAC-DB4A-0095-44C0AAEDA212}"/>
+              </a:ext>
+            </a:extLst>
+          </p:cNvPr>
+          <p:cNvSpPr/>
+          <p:nvPr/>
+        </p:nvSpPr>
+        <p:spPr>
+          <a:xfrm>
+            <a:off x="5187161" y="4459735"/>
+            <a:ext cx="1121308" cy="948726"/>
+          </a:xfrm>
+          <a:prstGeom prst="rect">
+            <a:avLst/>
+          </a:prstGeom>
+          <a:solidFill>
+            <a:schemeClr val="accent4">
+              <a:lumMod val="75000"/>
+            </a:schemeClr>
+          </a:solidFill>
+          <a:ln>
+            <a:solidFill>
+              <a:schemeClr val="tx1"/>
+            </a:solidFill>
+          </a:ln>
+        </p:spPr>
+        <p:style>
+          <a:lnRef idx="2">
+            <a:schemeClr val="accent1">
+              <a:shade val="15000"/>
+            </a:schemeClr>
+          </a:lnRef>
+          <a:fillRef idx="1">
+            <a:schemeClr val="accent1"/>
+          </a:fillRef>
+          <a:effectRef idx="0">
+            <a:schemeClr val="accent1"/>
+          </a:effectRef>
+          <a:fontRef idx="minor">
+            <a:schemeClr val="lt1"/>
+          </a:fontRef>
+        </p:style>
+        <p:txBody>
+          <a:bodyPr lIns="0" tIns="0" rIns="0" bIns="0" rtlCol="0" anchor="t"/>
+          <a:lstStyle/>
+          <a:p>
+            <a:pPr algn="ctr"/>
+            <a:endParaRPr lang="en-US" sz="300" dirty="0"/>
+          </a:p>
+          <a:p>
+            <a:pPr algn="ctr"/>
+            <a:r>
+              <a:rPr lang="en-US" sz="1100" dirty="0"/>
+              <a:t>Angular </a:t>
+            </a:r>
+          </a:p>
+          <a:p>
+            <a:pPr algn="ctr"/>
+            <a:r>
+              <a:rPr lang="en-US" sz="1100" dirty="0"/>
+              <a:t>Compiler</a:t>
+            </a:r>
+          </a:p>
+        </p:txBody>
+      </p:sp>
+      <p:sp>
+        <p:nvSpPr>
+          <p:cNvPr id="8" name="Title 1024">
+            <a:extLst>
+              <a:ext uri="{FF2B5EF4-FFF2-40B4-BE49-F238E27FC236}">
+                <a16:creationId xmlns:a16="http://schemas.microsoft.com/office/drawing/2014/main" id="{5E4304EA-1867-FA67-AD3A-E6BCE48DD203}"/>
+              </a:ext>
+            </a:extLst>
+          </p:cNvPr>
+          <p:cNvSpPr txBox="1">
+            <a:spLocks/>
+          </p:cNvSpPr>
+          <p:nvPr/>
+        </p:nvSpPr>
+        <p:spPr>
+          <a:xfrm>
+            <a:off x="115734" y="64032"/>
+            <a:ext cx="11304254" cy="476956"/>
+          </a:xfrm>
+          <a:prstGeom prst="rect">
+            <a:avLst/>
+          </a:prstGeom>
+        </p:spPr>
+        <p:txBody>
+          <a:bodyPr vert="horz" lIns="91440" tIns="45720" rIns="91440" bIns="45720" rtlCol="0" anchor="t">
+            <a:noAutofit/>
+          </a:bodyPr>
+          <a:lstStyle>
+            <a:lvl1pPr algn="ctr" defTabSz="914400" rtl="0" eaLnBrk="1" latinLnBrk="0" hangingPunct="1">
+              <a:lnSpc>
+                <a:spcPct val="90000"/>
+              </a:lnSpc>
+              <a:spcBef>
+                <a:spcPct val="0"/>
+              </a:spcBef>
+              <a:buNone/>
+              <a:defRPr sz="6000" kern="1200">
+                <a:solidFill>
+                  <a:schemeClr val="tx1"/>
+                </a:solidFill>
+                <a:latin typeface="+mj-lt"/>
+                <a:ea typeface="+mj-ea"/>
+                <a:cs typeface="+mj-cs"/>
+              </a:defRPr>
+            </a:lvl1pPr>
+          </a:lstStyle>
+          <a:p>
+            <a:pPr algn="l"/>
+            <a:r>
+              <a:rPr lang="en-US" sz="4000" dirty="0"/>
+              <a:t>Web Server Setup + Overview (Production)</a:t>
+            </a:r>
+          </a:p>
+        </p:txBody>
+      </p:sp>
+      <p:sp>
+        <p:nvSpPr>
+          <p:cNvPr id="18" name="Rectangle 17">
+            <a:extLst>
+              <a:ext uri="{FF2B5EF4-FFF2-40B4-BE49-F238E27FC236}">
+                <a16:creationId xmlns:a16="http://schemas.microsoft.com/office/drawing/2014/main" id="{CE75BE4D-1EF4-F1F6-7D2E-04E70C2E6CFF}"/>
+              </a:ext>
+            </a:extLst>
+          </p:cNvPr>
+          <p:cNvSpPr/>
+          <p:nvPr/>
+        </p:nvSpPr>
+        <p:spPr>
+          <a:xfrm>
+            <a:off x="495393" y="2059720"/>
+            <a:ext cx="1022504" cy="2648452"/>
+          </a:xfrm>
+          <a:prstGeom prst="rect">
+            <a:avLst/>
+          </a:prstGeom>
+          <a:solidFill>
+            <a:schemeClr val="accent6">
+              <a:lumMod val="75000"/>
+            </a:schemeClr>
+          </a:solidFill>
+        </p:spPr>
+        <p:style>
+          <a:lnRef idx="2">
+            <a:schemeClr val="accent1">
+              <a:shade val="15000"/>
+            </a:schemeClr>
+          </a:lnRef>
+          <a:fillRef idx="1">
+            <a:schemeClr val="accent1"/>
+          </a:fillRef>
+          <a:effectRef idx="0">
+            <a:schemeClr val="accent1"/>
+          </a:effectRef>
+          <a:fontRef idx="minor">
+            <a:schemeClr val="lt1"/>
+          </a:fontRef>
+        </p:style>
+        <p:txBody>
+          <a:bodyPr lIns="0" tIns="0" rIns="0" bIns="0" rtlCol="0" anchor="ctr"/>
+          <a:lstStyle/>
+          <a:p>
+            <a:pPr algn="ctr"/>
+            <a:r>
+              <a:rPr lang="en-US" sz="1600" dirty="0"/>
+              <a:t>Client</a:t>
+            </a:r>
+            <a:endParaRPr lang="en-US" sz="1400" dirty="0"/>
+          </a:p>
+        </p:txBody>
+      </p:sp>
+      <p:sp>
+        <p:nvSpPr>
+          <p:cNvPr id="26" name="Rectangle 25">
+            <a:extLst>
+              <a:ext uri="{FF2B5EF4-FFF2-40B4-BE49-F238E27FC236}">
+                <a16:creationId xmlns:a16="http://schemas.microsoft.com/office/drawing/2014/main" id="{7A494E3D-5A7F-6C83-1EB3-A0B1FCE2EBFD}"/>
+              </a:ext>
+            </a:extLst>
+          </p:cNvPr>
+          <p:cNvSpPr/>
+          <p:nvPr/>
+        </p:nvSpPr>
+        <p:spPr>
+          <a:xfrm>
+            <a:off x="4897822" y="1139593"/>
+            <a:ext cx="2133600" cy="1911912"/>
+          </a:xfrm>
+          <a:prstGeom prst="rect">
+            <a:avLst/>
+          </a:prstGeom>
+          <a:solidFill>
+            <a:srgbClr val="B17ED8"/>
+          </a:solidFill>
+        </p:spPr>
+        <p:style>
+          <a:lnRef idx="2">
+            <a:schemeClr val="accent1">
+              <a:shade val="15000"/>
+            </a:schemeClr>
+          </a:lnRef>
+          <a:fillRef idx="1">
+            <a:schemeClr val="accent1"/>
+          </a:fillRef>
+          <a:effectRef idx="0">
+            <a:schemeClr val="accent1"/>
+          </a:effectRef>
+          <a:fontRef idx="minor">
+            <a:schemeClr val="lt1"/>
+          </a:fontRef>
+        </p:style>
+        <p:txBody>
+          <a:bodyPr lIns="0" tIns="0" rIns="0" bIns="0" rtlCol="0" anchor="t"/>
+          <a:lstStyle/>
+          <a:p>
+            <a:pPr algn="ctr"/>
+            <a:r>
+              <a:rPr lang="en-US" sz="1600" dirty="0"/>
+              <a:t>API Server</a:t>
+            </a:r>
+          </a:p>
+          <a:p>
+            <a:pPr algn="ctr"/>
+            <a:r>
+              <a:rPr lang="en-US" sz="1400" dirty="0"/>
+              <a:t>(uvicorn + FastAPI)</a:t>
+            </a:r>
+          </a:p>
+          <a:p>
+            <a:pPr algn="ctr"/>
+            <a:endParaRPr lang="en-US" sz="1400" dirty="0"/>
+          </a:p>
+          <a:p>
+            <a:pPr algn="ctr"/>
+            <a:r>
+              <a:rPr lang="en-US" sz="900" dirty="0"/>
+              <a:t>uvicorn = sets up the server</a:t>
+            </a:r>
+          </a:p>
+          <a:p>
+            <a:pPr algn="ctr"/>
+            <a:r>
+              <a:rPr lang="en-US" sz="900" dirty="0"/>
+              <a:t>FastAPI = maps API requests to Python code</a:t>
+            </a:r>
+            <a:endParaRPr lang="en-US" sz="1100" dirty="0"/>
+          </a:p>
+        </p:txBody>
+      </p:sp>
+      <p:sp>
+        <p:nvSpPr>
+          <p:cNvPr id="36" name="Rectangle 35">
+            <a:extLst>
+              <a:ext uri="{FF2B5EF4-FFF2-40B4-BE49-F238E27FC236}">
+                <a16:creationId xmlns:a16="http://schemas.microsoft.com/office/drawing/2014/main" id="{E6224A39-3D33-19B6-80A8-E20ACAE07553}"/>
+              </a:ext>
+            </a:extLst>
+          </p:cNvPr>
+          <p:cNvSpPr/>
+          <p:nvPr/>
+        </p:nvSpPr>
+        <p:spPr>
+          <a:xfrm>
+            <a:off x="2687447" y="2754444"/>
+            <a:ext cx="1194727" cy="1349112"/>
+          </a:xfrm>
+          <a:prstGeom prst="rect">
+            <a:avLst/>
+          </a:prstGeom>
+          <a:solidFill>
+            <a:schemeClr val="tx2">
+              <a:lumMod val="60000"/>
+              <a:lumOff val="40000"/>
+            </a:schemeClr>
+          </a:solidFill>
+        </p:spPr>
+        <p:style>
+          <a:lnRef idx="2">
+            <a:schemeClr val="accent1">
+              <a:shade val="15000"/>
+            </a:schemeClr>
+          </a:lnRef>
+          <a:fillRef idx="1">
+            <a:schemeClr val="accent1"/>
+          </a:fillRef>
+          <a:effectRef idx="0">
+            <a:schemeClr val="accent1"/>
+          </a:effectRef>
+          <a:fontRef idx="minor">
+            <a:schemeClr val="lt1"/>
+          </a:fontRef>
+        </p:style>
+        <p:txBody>
+          <a:bodyPr lIns="0" tIns="0" rIns="0" bIns="0" rtlCol="0" anchor="ctr"/>
+          <a:lstStyle/>
+          <a:p>
+            <a:pPr algn="ctr"/>
+            <a:r>
+              <a:rPr lang="en-US" sz="1600" dirty="0"/>
+              <a:t>Web Server</a:t>
+            </a:r>
+          </a:p>
+          <a:p>
+            <a:pPr algn="ctr"/>
+            <a:r>
+              <a:rPr lang="en-US" sz="1400" dirty="0"/>
+              <a:t>(Caddy)</a:t>
+            </a:r>
+          </a:p>
+        </p:txBody>
+      </p:sp>
+      <p:cxnSp>
+        <p:nvCxnSpPr>
+          <p:cNvPr id="37" name="Straight Arrow Connector 36">
+            <a:extLst>
+              <a:ext uri="{FF2B5EF4-FFF2-40B4-BE49-F238E27FC236}">
+                <a16:creationId xmlns:a16="http://schemas.microsoft.com/office/drawing/2014/main" id="{1A9DBC32-9357-2C90-6437-601190DF46DF}"/>
+              </a:ext>
+            </a:extLst>
+          </p:cNvPr>
+          <p:cNvCxnSpPr>
+            <a:cxnSpLocks/>
+          </p:cNvCxnSpPr>
+          <p:nvPr/>
+        </p:nvCxnSpPr>
+        <p:spPr>
+          <a:xfrm flipH="1">
+            <a:off x="6308469" y="4599057"/>
+            <a:ext cx="1241270" cy="0"/>
+          </a:xfrm>
+          <a:prstGeom prst="straightConnector1">
+            <a:avLst/>
+          </a:prstGeom>
+          <a:ln w="12700">
+            <a:solidFill>
+              <a:schemeClr val="tx1"/>
+            </a:solidFill>
+            <a:headEnd type="none"/>
+            <a:tailEnd type="arrow"/>
+          </a:ln>
+        </p:spPr>
+        <p:style>
+          <a:lnRef idx="1">
+            <a:schemeClr val="accent1"/>
+          </a:lnRef>
+          <a:fillRef idx="0">
+            <a:schemeClr val="accent1"/>
+          </a:fillRef>
+          <a:effectRef idx="0">
+            <a:schemeClr val="accent1"/>
+          </a:effectRef>
+          <a:fontRef idx="minor">
+            <a:schemeClr val="tx1"/>
+          </a:fontRef>
+        </p:style>
+      </p:cxnSp>
+      <p:sp>
+        <p:nvSpPr>
+          <p:cNvPr id="204" name="TextBox 203">
+            <a:extLst>
+              <a:ext uri="{FF2B5EF4-FFF2-40B4-BE49-F238E27FC236}">
+                <a16:creationId xmlns:a16="http://schemas.microsoft.com/office/drawing/2014/main" id="{5B1A7DC2-A50F-BD1F-E3FD-FD8DCCB0B9AF}"/>
+              </a:ext>
+            </a:extLst>
+          </p:cNvPr>
+          <p:cNvSpPr txBox="1"/>
+          <p:nvPr/>
+        </p:nvSpPr>
+        <p:spPr>
+          <a:xfrm>
+            <a:off x="6590998" y="4260502"/>
+            <a:ext cx="805597" cy="338554"/>
+          </a:xfrm>
+          <a:prstGeom prst="rect">
+            <a:avLst/>
+          </a:prstGeom>
+          <a:noFill/>
+        </p:spPr>
+        <p:txBody>
+          <a:bodyPr wrap="square" lIns="0" tIns="0" rIns="0" bIns="0" rtlCol="0">
+            <a:spAutoFit/>
+          </a:bodyPr>
+          <a:lstStyle>
+            <a:defPPr>
+              <a:defRPr lang="en-US"/>
+            </a:defPPr>
+            <a:lvl1pPr algn="r">
+              <a:defRPr sz="1100" i="1"/>
+            </a:lvl1pPr>
+          </a:lstStyle>
+          <a:p>
+            <a:pPr algn="ctr"/>
+            <a:r>
+              <a:rPr lang="en-US" dirty="0"/>
+              <a:t>Angular Templates</a:t>
+            </a:r>
+          </a:p>
+        </p:txBody>
+      </p:sp>
+      <p:sp>
+        <p:nvSpPr>
+          <p:cNvPr id="41" name="TextBox 40">
+            <a:extLst>
+              <a:ext uri="{FF2B5EF4-FFF2-40B4-BE49-F238E27FC236}">
+                <a16:creationId xmlns:a16="http://schemas.microsoft.com/office/drawing/2014/main" id="{D8350608-DDD1-A87C-0F8E-5AE20180D5EC}"/>
+              </a:ext>
+            </a:extLst>
+          </p:cNvPr>
+          <p:cNvSpPr txBox="1"/>
+          <p:nvPr/>
+        </p:nvSpPr>
+        <p:spPr>
+          <a:xfrm>
+            <a:off x="1694255" y="3205571"/>
+            <a:ext cx="816833" cy="169277"/>
+          </a:xfrm>
+          <a:prstGeom prst="rect">
+            <a:avLst/>
+          </a:prstGeom>
+          <a:noFill/>
+        </p:spPr>
+        <p:txBody>
+          <a:bodyPr wrap="square" lIns="0" tIns="0" rIns="0" bIns="0" rtlCol="0">
+            <a:spAutoFit/>
+          </a:bodyPr>
+          <a:lstStyle>
+            <a:defPPr>
+              <a:defRPr lang="en-US"/>
+            </a:defPPr>
+            <a:lvl1pPr algn="r">
+              <a:defRPr sz="1100" i="1"/>
+            </a:lvl1pPr>
+          </a:lstStyle>
+          <a:p>
+            <a:pPr algn="ctr"/>
+            <a:r>
+              <a:rPr lang="en-US" dirty="0"/>
+              <a:t>JSON + events</a:t>
+            </a:r>
+          </a:p>
+        </p:txBody>
+      </p:sp>
+      <p:sp>
+        <p:nvSpPr>
+          <p:cNvPr id="42" name="Rectangle 41">
+            <a:extLst>
+              <a:ext uri="{FF2B5EF4-FFF2-40B4-BE49-F238E27FC236}">
+                <a16:creationId xmlns:a16="http://schemas.microsoft.com/office/drawing/2014/main" id="{1E0EC690-9A6C-3574-0E58-340057310248}"/>
+              </a:ext>
+            </a:extLst>
+          </p:cNvPr>
+          <p:cNvSpPr/>
+          <p:nvPr/>
+        </p:nvSpPr>
+        <p:spPr>
+          <a:xfrm>
+            <a:off x="7549738" y="4081569"/>
+            <a:ext cx="1241269" cy="1484422"/>
+          </a:xfrm>
+          <a:prstGeom prst="rect">
+            <a:avLst/>
+          </a:prstGeom>
+          <a:solidFill>
+            <a:srgbClr val="FFC021"/>
+          </a:solidFill>
+        </p:spPr>
+        <p:style>
+          <a:lnRef idx="2">
+            <a:schemeClr val="accent1">
+              <a:shade val="15000"/>
+            </a:schemeClr>
+          </a:lnRef>
+          <a:fillRef idx="1">
+            <a:schemeClr val="accent1"/>
+          </a:fillRef>
+          <a:effectRef idx="0">
+            <a:schemeClr val="accent1"/>
+          </a:effectRef>
+          <a:fontRef idx="minor">
+            <a:schemeClr val="lt1"/>
+          </a:fontRef>
+        </p:style>
+        <p:txBody>
+          <a:bodyPr lIns="0" tIns="0" rIns="0" bIns="0" rtlCol="0" anchor="ctr"/>
+          <a:lstStyle/>
+          <a:p>
+            <a:pPr algn="ctr"/>
+            <a:r>
+              <a:rPr lang="en-US" dirty="0"/>
+              <a:t>Web Code</a:t>
+            </a:r>
+          </a:p>
+          <a:p>
+            <a:pPr algn="ctr"/>
+            <a:r>
+              <a:rPr lang="en-US" sz="1000" dirty="0"/>
+              <a:t>📚 </a:t>
+            </a:r>
+            <a:r>
+              <a:rPr lang="en-US" sz="1000" b="1" u="sng" dirty="0"/>
+              <a:t>Angular</a:t>
+            </a:r>
+          </a:p>
+          <a:p>
+            <a:pPr algn="ctr"/>
+            <a:r>
+              <a:rPr lang="en-US" sz="1000" dirty="0"/>
+              <a:t>📚 </a:t>
+            </a:r>
+            <a:r>
+              <a:rPr lang="en-US" sz="1000" b="1" u="sng" dirty="0"/>
+              <a:t>various libs </a:t>
+            </a:r>
+          </a:p>
+          <a:p>
+            <a:pPr algn="ctr"/>
+            <a:r>
+              <a:rPr lang="en-US" sz="900" b="1" i="1" u="sng" dirty="0"/>
+              <a:t>(e.g. charts, webstores, etc…)</a:t>
+            </a:r>
+            <a:endParaRPr lang="en-US" sz="1400" i="1" u="sng" dirty="0"/>
+          </a:p>
+        </p:txBody>
+      </p:sp>
+      <p:cxnSp>
+        <p:nvCxnSpPr>
+          <p:cNvPr id="48" name="Straight Arrow Connector 47">
+            <a:extLst>
+              <a:ext uri="{FF2B5EF4-FFF2-40B4-BE49-F238E27FC236}">
+                <a16:creationId xmlns:a16="http://schemas.microsoft.com/office/drawing/2014/main" id="{79E87979-DC65-D8F0-F4A6-EF70FCC13A63}"/>
+              </a:ext>
+            </a:extLst>
+          </p:cNvPr>
+          <p:cNvCxnSpPr>
+            <a:cxnSpLocks/>
+          </p:cNvCxnSpPr>
+          <p:nvPr/>
+        </p:nvCxnSpPr>
+        <p:spPr>
+          <a:xfrm flipH="1">
+            <a:off x="1517897" y="3429000"/>
+            <a:ext cx="1169550" cy="0"/>
+          </a:xfrm>
+          <a:prstGeom prst="straightConnector1">
+            <a:avLst/>
+          </a:prstGeom>
+          <a:ln w="12700">
+            <a:solidFill>
+              <a:schemeClr val="tx1"/>
+            </a:solidFill>
+            <a:headEnd type="none"/>
+            <a:tailEnd type="arrow"/>
+          </a:ln>
+        </p:spPr>
+        <p:style>
+          <a:lnRef idx="1">
+            <a:schemeClr val="accent1"/>
+          </a:lnRef>
+          <a:fillRef idx="0">
+            <a:schemeClr val="accent1"/>
+          </a:fillRef>
+          <a:effectRef idx="0">
+            <a:schemeClr val="accent1"/>
+          </a:effectRef>
+          <a:fontRef idx="minor">
+            <a:schemeClr val="tx1"/>
+          </a:fontRef>
+        </p:style>
+      </p:cxnSp>
+      <p:sp>
+        <p:nvSpPr>
+          <p:cNvPr id="49" name="TextBox 48">
+            <a:extLst>
+              <a:ext uri="{FF2B5EF4-FFF2-40B4-BE49-F238E27FC236}">
+                <a16:creationId xmlns:a16="http://schemas.microsoft.com/office/drawing/2014/main" id="{2C89E25A-1F61-9793-EBCA-2737AC655A09}"/>
+              </a:ext>
+            </a:extLst>
+          </p:cNvPr>
+          <p:cNvSpPr txBox="1"/>
+          <p:nvPr/>
+        </p:nvSpPr>
+        <p:spPr>
+          <a:xfrm>
+            <a:off x="1767558" y="3489971"/>
+            <a:ext cx="670228" cy="169277"/>
+          </a:xfrm>
+          <a:prstGeom prst="rect">
+            <a:avLst/>
+          </a:prstGeom>
+          <a:noFill/>
+        </p:spPr>
+        <p:txBody>
+          <a:bodyPr wrap="square" lIns="0" tIns="0" rIns="0" bIns="0" rtlCol="0">
+            <a:spAutoFit/>
+          </a:bodyPr>
+          <a:lstStyle>
+            <a:defPPr>
+              <a:defRPr lang="en-US"/>
+            </a:defPPr>
+            <a:lvl1pPr algn="r">
+              <a:defRPr sz="1100" i="1"/>
+            </a:lvl1pPr>
+          </a:lstStyle>
+          <a:p>
+            <a:pPr algn="ctr"/>
+            <a:r>
+              <a:rPr lang="en-US" dirty="0"/>
+              <a:t>HTML + JS</a:t>
+            </a:r>
+          </a:p>
+        </p:txBody>
+      </p:sp>
+      <p:cxnSp>
+        <p:nvCxnSpPr>
+          <p:cNvPr id="61" name="Straight Arrow Connector 60">
+            <a:extLst>
+              <a:ext uri="{FF2B5EF4-FFF2-40B4-BE49-F238E27FC236}">
+                <a16:creationId xmlns:a16="http://schemas.microsoft.com/office/drawing/2014/main" id="{7105EF8B-8CE0-6520-7456-E5F41597766C}"/>
+              </a:ext>
+            </a:extLst>
+          </p:cNvPr>
+          <p:cNvCxnSpPr>
+            <a:cxnSpLocks/>
+          </p:cNvCxnSpPr>
+          <p:nvPr/>
+        </p:nvCxnSpPr>
+        <p:spPr>
+          <a:xfrm flipH="1">
+            <a:off x="6308469" y="5070829"/>
+            <a:ext cx="1241270" cy="0"/>
+          </a:xfrm>
+          <a:prstGeom prst="straightConnector1">
+            <a:avLst/>
+          </a:prstGeom>
+          <a:ln w="12700">
+            <a:solidFill>
+              <a:schemeClr val="tx1"/>
+            </a:solidFill>
+            <a:headEnd type="none"/>
+            <a:tailEnd type="arrow"/>
+          </a:ln>
+        </p:spPr>
+        <p:style>
+          <a:lnRef idx="1">
+            <a:schemeClr val="accent1"/>
+          </a:lnRef>
+          <a:fillRef idx="0">
+            <a:schemeClr val="accent1"/>
+          </a:fillRef>
+          <a:effectRef idx="0">
+            <a:schemeClr val="accent1"/>
+          </a:effectRef>
+          <a:fontRef idx="minor">
+            <a:schemeClr val="tx1"/>
+          </a:fontRef>
+        </p:style>
+      </p:cxnSp>
+      <p:sp>
+        <p:nvSpPr>
+          <p:cNvPr id="62" name="TextBox 61">
+            <a:extLst>
+              <a:ext uri="{FF2B5EF4-FFF2-40B4-BE49-F238E27FC236}">
+                <a16:creationId xmlns:a16="http://schemas.microsoft.com/office/drawing/2014/main" id="{C3407928-0390-2E9B-FC8E-1DDD3447C28F}"/>
+              </a:ext>
+            </a:extLst>
+          </p:cNvPr>
+          <p:cNvSpPr txBox="1"/>
+          <p:nvPr/>
+        </p:nvSpPr>
+        <p:spPr>
+          <a:xfrm>
+            <a:off x="6590998" y="4889982"/>
+            <a:ext cx="805597" cy="169277"/>
+          </a:xfrm>
+          <a:prstGeom prst="rect">
+            <a:avLst/>
+          </a:prstGeom>
+          <a:noFill/>
+        </p:spPr>
+        <p:txBody>
+          <a:bodyPr wrap="square" lIns="0" tIns="0" rIns="0" bIns="0" rtlCol="0">
+            <a:spAutoFit/>
+          </a:bodyPr>
+          <a:lstStyle>
+            <a:defPPr>
+              <a:defRPr lang="en-US"/>
+            </a:defPPr>
+            <a:lvl1pPr algn="r">
+              <a:defRPr sz="1100" i="1"/>
+            </a:lvl1pPr>
+          </a:lstStyle>
+          <a:p>
+            <a:pPr algn="ctr"/>
+            <a:r>
+              <a:rPr lang="en-US" dirty="0"/>
+              <a:t>TS</a:t>
+            </a:r>
+          </a:p>
+        </p:txBody>
+      </p:sp>
+      <p:sp>
+        <p:nvSpPr>
+          <p:cNvPr id="63" name="Rectangle 62">
+            <a:extLst>
+              <a:ext uri="{FF2B5EF4-FFF2-40B4-BE49-F238E27FC236}">
+                <a16:creationId xmlns:a16="http://schemas.microsoft.com/office/drawing/2014/main" id="{D47973AE-F83C-A3D9-4FC3-742EBFBB6B10}"/>
+              </a:ext>
+            </a:extLst>
+          </p:cNvPr>
+          <p:cNvSpPr/>
+          <p:nvPr/>
+        </p:nvSpPr>
+        <p:spPr>
+          <a:xfrm>
+            <a:off x="5340304" y="4924693"/>
+            <a:ext cx="815022" cy="292272"/>
+          </a:xfrm>
+          <a:prstGeom prst="rect">
+            <a:avLst/>
+          </a:prstGeom>
+          <a:solidFill>
+            <a:schemeClr val="accent4">
+              <a:lumMod val="75000"/>
+            </a:schemeClr>
+          </a:solidFill>
+          <a:ln>
+            <a:solidFill>
+              <a:schemeClr val="tx1"/>
+            </a:solidFill>
+          </a:ln>
+        </p:spPr>
+        <p:style>
+          <a:lnRef idx="2">
+            <a:schemeClr val="accent1">
+              <a:shade val="15000"/>
+            </a:schemeClr>
+          </a:lnRef>
+          <a:fillRef idx="1">
+            <a:schemeClr val="accent1"/>
+          </a:fillRef>
+          <a:effectRef idx="0">
+            <a:schemeClr val="accent1"/>
+          </a:effectRef>
+          <a:fontRef idx="minor">
+            <a:schemeClr val="lt1"/>
+          </a:fontRef>
+        </p:style>
+        <p:txBody>
+          <a:bodyPr lIns="0" tIns="0" rIns="0" bIns="0" rtlCol="0" anchor="ctr"/>
+          <a:lstStyle/>
+          <a:p>
+            <a:pPr algn="ctr"/>
+            <a:r>
+              <a:rPr lang="en-US" sz="1400" dirty="0"/>
+              <a:t>tsc</a:t>
+            </a:r>
+          </a:p>
+        </p:txBody>
+      </p:sp>
+      <p:sp>
+        <p:nvSpPr>
+          <p:cNvPr id="114" name="TextBox 113">
+            <a:extLst>
+              <a:ext uri="{FF2B5EF4-FFF2-40B4-BE49-F238E27FC236}">
+                <a16:creationId xmlns:a16="http://schemas.microsoft.com/office/drawing/2014/main" id="{6F0C7F54-AA32-53B3-A1F2-DF62DB4B8DAC}"/>
+              </a:ext>
+            </a:extLst>
+          </p:cNvPr>
+          <p:cNvSpPr txBox="1"/>
+          <p:nvPr/>
+        </p:nvSpPr>
+        <p:spPr>
+          <a:xfrm>
+            <a:off x="6590998" y="5239184"/>
+            <a:ext cx="805597" cy="169277"/>
+          </a:xfrm>
+          <a:prstGeom prst="rect">
+            <a:avLst/>
+          </a:prstGeom>
+          <a:noFill/>
+        </p:spPr>
+        <p:txBody>
+          <a:bodyPr wrap="square" lIns="0" tIns="0" rIns="0" bIns="0" rtlCol="0">
+            <a:spAutoFit/>
+          </a:bodyPr>
+          <a:lstStyle>
+            <a:defPPr>
+              <a:defRPr lang="en-US"/>
+            </a:defPPr>
+            <a:lvl1pPr algn="r">
+              <a:defRPr sz="1100" i="1"/>
+            </a:lvl1pPr>
+          </a:lstStyle>
+          <a:p>
+            <a:pPr algn="ctr"/>
+            <a:r>
+              <a:rPr lang="en-US" dirty="0"/>
+              <a:t>HTML</a:t>
+            </a:r>
+          </a:p>
+        </p:txBody>
+      </p:sp>
+      <p:sp>
+        <p:nvSpPr>
+          <p:cNvPr id="124" name="TextBox 123">
+            <a:extLst>
+              <a:ext uri="{FF2B5EF4-FFF2-40B4-BE49-F238E27FC236}">
+                <a16:creationId xmlns:a16="http://schemas.microsoft.com/office/drawing/2014/main" id="{29BB77FE-F358-DEAB-CD1E-8D1C5E183E81}"/>
+              </a:ext>
+            </a:extLst>
+          </p:cNvPr>
+          <p:cNvSpPr txBox="1"/>
+          <p:nvPr/>
+        </p:nvSpPr>
+        <p:spPr>
+          <a:xfrm>
+            <a:off x="4850267" y="5588208"/>
+            <a:ext cx="1795096" cy="161583"/>
+          </a:xfrm>
+          <a:prstGeom prst="rect">
+            <a:avLst/>
+          </a:prstGeom>
+          <a:noFill/>
+        </p:spPr>
+        <p:txBody>
+          <a:bodyPr wrap="square" lIns="0" tIns="0" rIns="0" bIns="0" rtlCol="0">
+            <a:spAutoFit/>
+          </a:bodyPr>
+          <a:lstStyle>
+            <a:defPPr>
+              <a:defRPr lang="en-US"/>
+            </a:defPPr>
+            <a:lvl1pPr algn="r">
+              <a:defRPr sz="1100" i="1"/>
+            </a:lvl1pPr>
+          </a:lstStyle>
+          <a:p>
+            <a:pPr algn="ctr"/>
+            <a:r>
+              <a:rPr lang="en-US" sz="1050" b="1" i="0" dirty="0"/>
+              <a:t>Node.js </a:t>
+            </a:r>
+            <a:r>
+              <a:rPr lang="en-US" sz="1050" i="0" dirty="0"/>
+              <a:t>Runtime</a:t>
+            </a:r>
+          </a:p>
+        </p:txBody>
+      </p:sp>
+      <p:sp>
+        <p:nvSpPr>
+          <p:cNvPr id="125" name="TextBox 124">
+            <a:extLst>
+              <a:ext uri="{FF2B5EF4-FFF2-40B4-BE49-F238E27FC236}">
+                <a16:creationId xmlns:a16="http://schemas.microsoft.com/office/drawing/2014/main" id="{BE2D3868-9DA1-4C51-098E-021EF69E3C76}"/>
+              </a:ext>
+            </a:extLst>
+          </p:cNvPr>
+          <p:cNvSpPr txBox="1"/>
+          <p:nvPr/>
+        </p:nvSpPr>
+        <p:spPr>
+          <a:xfrm>
+            <a:off x="5067074" y="3063075"/>
+            <a:ext cx="1795096" cy="161583"/>
+          </a:xfrm>
+          <a:prstGeom prst="rect">
+            <a:avLst/>
+          </a:prstGeom>
+          <a:noFill/>
+        </p:spPr>
+        <p:txBody>
+          <a:bodyPr wrap="square" lIns="0" tIns="0" rIns="0" bIns="0" rtlCol="0">
+            <a:spAutoFit/>
+          </a:bodyPr>
+          <a:lstStyle>
+            <a:defPPr>
+              <a:defRPr lang="en-US"/>
+            </a:defPPr>
+            <a:lvl1pPr algn="r">
+              <a:defRPr sz="1100" i="1"/>
+            </a:lvl1pPr>
+          </a:lstStyle>
+          <a:p>
+            <a:pPr algn="ctr"/>
+            <a:r>
+              <a:rPr lang="en-US" sz="1050" b="1" i="0" dirty="0"/>
+              <a:t>Python </a:t>
+            </a:r>
+            <a:r>
+              <a:rPr lang="en-US" sz="1050" i="0" dirty="0"/>
+              <a:t>Runtime</a:t>
+            </a:r>
+          </a:p>
+        </p:txBody>
+      </p:sp>
+      <p:sp>
+        <p:nvSpPr>
+          <p:cNvPr id="139" name="TextBox 138">
+            <a:extLst>
+              <a:ext uri="{FF2B5EF4-FFF2-40B4-BE49-F238E27FC236}">
+                <a16:creationId xmlns:a16="http://schemas.microsoft.com/office/drawing/2014/main" id="{1616A251-7504-2F8B-57F2-E0C651EBD173}"/>
+              </a:ext>
+            </a:extLst>
+          </p:cNvPr>
+          <p:cNvSpPr txBox="1"/>
+          <p:nvPr/>
+        </p:nvSpPr>
+        <p:spPr>
+          <a:xfrm>
+            <a:off x="2667424" y="4118949"/>
+            <a:ext cx="1214750" cy="161583"/>
+          </a:xfrm>
+          <a:prstGeom prst="rect">
+            <a:avLst/>
+          </a:prstGeom>
+          <a:noFill/>
+        </p:spPr>
+        <p:txBody>
+          <a:bodyPr wrap="square" lIns="0" tIns="0" rIns="0" bIns="0" rtlCol="0">
+            <a:spAutoFit/>
+          </a:bodyPr>
+          <a:lstStyle>
+            <a:defPPr>
+              <a:defRPr lang="en-US"/>
+            </a:defPPr>
+            <a:lvl1pPr algn="r">
+              <a:defRPr sz="1100" i="1"/>
+            </a:lvl1pPr>
+          </a:lstStyle>
+          <a:p>
+            <a:pPr algn="ctr"/>
+            <a:r>
+              <a:rPr lang="en-US" sz="1050" b="1" i="0" dirty="0"/>
+              <a:t>Go </a:t>
+            </a:r>
+            <a:r>
+              <a:rPr lang="en-US" sz="1050" i="0" dirty="0"/>
+              <a:t>Runtime</a:t>
+            </a:r>
+          </a:p>
+        </p:txBody>
+      </p:sp>
+      <p:sp>
+        <p:nvSpPr>
+          <p:cNvPr id="162" name="TextBox 161">
+            <a:extLst>
+              <a:ext uri="{FF2B5EF4-FFF2-40B4-BE49-F238E27FC236}">
+                <a16:creationId xmlns:a16="http://schemas.microsoft.com/office/drawing/2014/main" id="{46B9F577-D81F-780D-D351-5E3D1F94E885}"/>
+              </a:ext>
+            </a:extLst>
+          </p:cNvPr>
+          <p:cNvSpPr txBox="1"/>
+          <p:nvPr/>
+        </p:nvSpPr>
+        <p:spPr>
+          <a:xfrm>
+            <a:off x="399270" y="4724501"/>
+            <a:ext cx="1214750" cy="161583"/>
+          </a:xfrm>
+          <a:prstGeom prst="rect">
+            <a:avLst/>
+          </a:prstGeom>
+          <a:noFill/>
+        </p:spPr>
+        <p:txBody>
+          <a:bodyPr wrap="square" lIns="0" tIns="0" rIns="0" bIns="0" rtlCol="0">
+            <a:spAutoFit/>
+          </a:bodyPr>
+          <a:lstStyle>
+            <a:defPPr>
+              <a:defRPr lang="en-US"/>
+            </a:defPPr>
+            <a:lvl1pPr algn="r">
+              <a:defRPr sz="1100" i="1"/>
+            </a:lvl1pPr>
+          </a:lstStyle>
+          <a:p>
+            <a:pPr algn="ctr"/>
+            <a:r>
+              <a:rPr lang="en-US" sz="1050" b="1" i="0" dirty="0"/>
+              <a:t>Browser</a:t>
+            </a:r>
+            <a:r>
+              <a:rPr lang="en-US" sz="1050" i="0" dirty="0"/>
+              <a:t> Runtime</a:t>
+            </a:r>
+          </a:p>
+        </p:txBody>
+      </p:sp>
+      <p:cxnSp>
+        <p:nvCxnSpPr>
+          <p:cNvPr id="168" name="Straight Arrow Connector 167">
+            <a:extLst>
+              <a:ext uri="{FF2B5EF4-FFF2-40B4-BE49-F238E27FC236}">
+                <a16:creationId xmlns:a16="http://schemas.microsoft.com/office/drawing/2014/main" id="{84DFB570-0728-E7F6-53E4-B903A546F000}"/>
+              </a:ext>
+            </a:extLst>
+          </p:cNvPr>
+          <p:cNvCxnSpPr>
+            <a:cxnSpLocks/>
+          </p:cNvCxnSpPr>
+          <p:nvPr/>
+        </p:nvCxnSpPr>
+        <p:spPr>
+          <a:xfrm flipH="1">
+            <a:off x="6527431" y="5430679"/>
+            <a:ext cx="1003635" cy="0"/>
+          </a:xfrm>
+          <a:prstGeom prst="straightConnector1">
+            <a:avLst/>
+          </a:prstGeom>
+          <a:ln w="12700">
+            <a:solidFill>
+              <a:schemeClr val="tx1"/>
+            </a:solidFill>
+            <a:headEnd type="none"/>
+            <a:tailEnd type="arrow"/>
+          </a:ln>
+        </p:spPr>
+        <p:style>
+          <a:lnRef idx="1">
+            <a:schemeClr val="accent1"/>
+          </a:lnRef>
+          <a:fillRef idx="0">
+            <a:schemeClr val="accent1"/>
+          </a:fillRef>
+          <a:effectRef idx="0">
+            <a:schemeClr val="accent1"/>
+          </a:effectRef>
+          <a:fontRef idx="minor">
+            <a:schemeClr val="tx1"/>
+          </a:fontRef>
+        </p:style>
+      </p:cxnSp>
+      <p:sp>
+        <p:nvSpPr>
+          <p:cNvPr id="180" name="Rectangle 179">
+            <a:extLst>
+              <a:ext uri="{FF2B5EF4-FFF2-40B4-BE49-F238E27FC236}">
+                <a16:creationId xmlns:a16="http://schemas.microsoft.com/office/drawing/2014/main" id="{16C97DD2-5066-9719-DB27-72927C397F4A}"/>
+              </a:ext>
+            </a:extLst>
+          </p:cNvPr>
+          <p:cNvSpPr/>
+          <p:nvPr/>
+        </p:nvSpPr>
+        <p:spPr>
+          <a:xfrm>
+            <a:off x="5110292" y="2207908"/>
+            <a:ext cx="592914" cy="693499"/>
+          </a:xfrm>
+          <a:prstGeom prst="rect">
+            <a:avLst/>
+          </a:prstGeom>
+          <a:solidFill>
+            <a:srgbClr val="7030A0"/>
+          </a:solidFill>
+        </p:spPr>
+        <p:style>
+          <a:lnRef idx="2">
+            <a:schemeClr val="accent1">
+              <a:shade val="15000"/>
+            </a:schemeClr>
+          </a:lnRef>
+          <a:fillRef idx="1">
+            <a:schemeClr val="accent1"/>
+          </a:fillRef>
+          <a:effectRef idx="0">
+            <a:schemeClr val="accent1"/>
+          </a:effectRef>
+          <a:fontRef idx="minor">
+            <a:schemeClr val="lt1"/>
+          </a:fontRef>
+        </p:style>
+        <p:txBody>
+          <a:bodyPr lIns="0" tIns="0" rIns="0" bIns="0" rtlCol="0" anchor="ctr"/>
+          <a:lstStyle/>
+          <a:p>
+            <a:pPr algn="ctr"/>
+            <a:r>
+              <a:rPr lang="en-US" sz="1200" dirty="0"/>
+              <a:t>Job </a:t>
+            </a:r>
+          </a:p>
+          <a:p>
+            <a:pPr algn="ctr"/>
+            <a:r>
+              <a:rPr lang="en-US" sz="1200" dirty="0"/>
+              <a:t>Runner</a:t>
+            </a:r>
+            <a:endParaRPr lang="en-US" sz="1100" dirty="0"/>
+          </a:p>
+        </p:txBody>
+      </p:sp>
+      <p:sp>
+        <p:nvSpPr>
+          <p:cNvPr id="181" name="Rectangle 180">
+            <a:extLst>
+              <a:ext uri="{FF2B5EF4-FFF2-40B4-BE49-F238E27FC236}">
+                <a16:creationId xmlns:a16="http://schemas.microsoft.com/office/drawing/2014/main" id="{8B7C8766-2D31-46B4-2449-B34C3F54CE34}"/>
+              </a:ext>
+            </a:extLst>
+          </p:cNvPr>
+          <p:cNvSpPr/>
+          <p:nvPr/>
+        </p:nvSpPr>
+        <p:spPr>
+          <a:xfrm>
+            <a:off x="6030254" y="2207908"/>
+            <a:ext cx="834306" cy="693499"/>
+          </a:xfrm>
+          <a:prstGeom prst="rect">
+            <a:avLst/>
+          </a:prstGeom>
+          <a:solidFill>
+            <a:srgbClr val="7030A0"/>
+          </a:solidFill>
+        </p:spPr>
+        <p:style>
+          <a:lnRef idx="2">
+            <a:schemeClr val="accent1">
+              <a:shade val="15000"/>
+            </a:schemeClr>
+          </a:lnRef>
+          <a:fillRef idx="1">
+            <a:schemeClr val="accent1"/>
+          </a:fillRef>
+          <a:effectRef idx="0">
+            <a:schemeClr val="accent1"/>
+          </a:effectRef>
+          <a:fontRef idx="minor">
+            <a:schemeClr val="lt1"/>
+          </a:fontRef>
+        </p:style>
+        <p:txBody>
+          <a:bodyPr lIns="0" tIns="0" rIns="0" bIns="0" rtlCol="0" anchor="ctr"/>
+          <a:lstStyle/>
+          <a:p>
+            <a:pPr algn="ctr"/>
+            <a:r>
+              <a:rPr lang="en-US" sz="1200" dirty="0"/>
+              <a:t>Query </a:t>
+            </a:r>
+          </a:p>
+          <a:p>
+            <a:pPr algn="ctr"/>
+            <a:r>
+              <a:rPr lang="en-US" sz="1200" dirty="0"/>
+              <a:t>Pipeline</a:t>
+            </a:r>
+            <a:endParaRPr lang="en-US" sz="1100" dirty="0"/>
+          </a:p>
+        </p:txBody>
+      </p:sp>
+      <p:cxnSp>
+        <p:nvCxnSpPr>
+          <p:cNvPr id="182" name="Straight Arrow Connector 181">
+            <a:extLst>
+              <a:ext uri="{FF2B5EF4-FFF2-40B4-BE49-F238E27FC236}">
+                <a16:creationId xmlns:a16="http://schemas.microsoft.com/office/drawing/2014/main" id="{20C0564A-DF24-9727-7344-62CABE709AF1}"/>
+              </a:ext>
+            </a:extLst>
+          </p:cNvPr>
+          <p:cNvCxnSpPr>
+            <a:cxnSpLocks/>
+            <a:stCxn id="181" idx="1"/>
+            <a:endCxn id="180" idx="3"/>
+          </p:cNvCxnSpPr>
+          <p:nvPr/>
+        </p:nvCxnSpPr>
+        <p:spPr>
+          <a:xfrm flipH="1">
+            <a:off x="5703206" y="2554658"/>
+            <a:ext cx="327048" cy="0"/>
+          </a:xfrm>
+          <a:prstGeom prst="straightConnector1">
+            <a:avLst/>
+          </a:prstGeom>
+          <a:ln w="12700">
+            <a:solidFill>
+              <a:schemeClr val="tx1"/>
+            </a:solidFill>
+            <a:headEnd type="arrow"/>
+            <a:tailEnd type="arrow"/>
+          </a:ln>
+        </p:spPr>
+        <p:style>
+          <a:lnRef idx="1">
+            <a:schemeClr val="accent1"/>
+          </a:lnRef>
+          <a:fillRef idx="0">
+            <a:schemeClr val="accent1"/>
+          </a:fillRef>
+          <a:effectRef idx="0">
+            <a:schemeClr val="accent1"/>
+          </a:effectRef>
+          <a:fontRef idx="minor">
+            <a:schemeClr val="tx1"/>
+          </a:fontRef>
+        </p:style>
+      </p:cxnSp>
+      <p:cxnSp>
+        <p:nvCxnSpPr>
+          <p:cNvPr id="191" name="Connector: Elbow 190">
+            <a:extLst>
+              <a:ext uri="{FF2B5EF4-FFF2-40B4-BE49-F238E27FC236}">
+                <a16:creationId xmlns:a16="http://schemas.microsoft.com/office/drawing/2014/main" id="{3F7DE3FA-3E17-6D71-888C-61149959A1DE}"/>
+              </a:ext>
+            </a:extLst>
+          </p:cNvPr>
+          <p:cNvCxnSpPr>
+            <a:stCxn id="36" idx="3"/>
+            <a:endCxn id="26" idx="1"/>
+          </p:cNvCxnSpPr>
+          <p:nvPr/>
+        </p:nvCxnSpPr>
+        <p:spPr>
+          <a:xfrm flipV="1">
+            <a:off x="3882174" y="2095549"/>
+            <a:ext cx="1015648" cy="1333451"/>
+          </a:xfrm>
+          <a:prstGeom prst="bentConnector3">
+            <a:avLst>
+              <a:gd name="adj1" fmla="val 64458"/>
+            </a:avLst>
+          </a:prstGeom>
+          <a:ln w="12700">
+            <a:solidFill>
+              <a:schemeClr val="tx1"/>
+            </a:solidFill>
+            <a:headEnd type="arrow"/>
+            <a:tailEnd type="arrow"/>
+          </a:ln>
+        </p:spPr>
+        <p:style>
+          <a:lnRef idx="1">
+            <a:schemeClr val="accent1"/>
+          </a:lnRef>
+          <a:fillRef idx="0">
+            <a:schemeClr val="accent1"/>
+          </a:fillRef>
+          <a:effectRef idx="0">
+            <a:schemeClr val="accent1"/>
+          </a:effectRef>
+          <a:fontRef idx="minor">
+            <a:schemeClr val="tx1"/>
+          </a:fontRef>
+        </p:style>
+      </p:cxnSp>
+      <p:sp>
+        <p:nvSpPr>
+          <p:cNvPr id="192" name="TextBox 191">
+            <a:extLst>
+              <a:ext uri="{FF2B5EF4-FFF2-40B4-BE49-F238E27FC236}">
+                <a16:creationId xmlns:a16="http://schemas.microsoft.com/office/drawing/2014/main" id="{66CB1DB6-A46F-32AA-63C5-7AC68DE24DB0}"/>
+              </a:ext>
+            </a:extLst>
+          </p:cNvPr>
+          <p:cNvSpPr txBox="1"/>
+          <p:nvPr/>
+        </p:nvSpPr>
+        <p:spPr>
+          <a:xfrm>
+            <a:off x="3943632" y="3205571"/>
+            <a:ext cx="670228" cy="169277"/>
+          </a:xfrm>
+          <a:prstGeom prst="rect">
+            <a:avLst/>
+          </a:prstGeom>
+          <a:noFill/>
+        </p:spPr>
+        <p:txBody>
+          <a:bodyPr wrap="square" lIns="0" tIns="0" rIns="0" bIns="0" rtlCol="0">
+            <a:spAutoFit/>
+          </a:bodyPr>
+          <a:lstStyle>
+            <a:defPPr>
+              <a:defRPr lang="en-US"/>
+            </a:defPPr>
+            <a:lvl1pPr algn="r">
+              <a:defRPr sz="1100" i="1"/>
+            </a:lvl1pPr>
+          </a:lstStyle>
+          <a:p>
+            <a:pPr algn="ctr"/>
+            <a:r>
+              <a:rPr lang="en-US" dirty="0"/>
+              <a:t>/api/*</a:t>
+            </a:r>
+          </a:p>
+        </p:txBody>
+      </p:sp>
+      <p:sp>
+        <p:nvSpPr>
+          <p:cNvPr id="194" name="TextBox 193">
+            <a:extLst>
+              <a:ext uri="{FF2B5EF4-FFF2-40B4-BE49-F238E27FC236}">
+                <a16:creationId xmlns:a16="http://schemas.microsoft.com/office/drawing/2014/main" id="{A1283FDE-C319-A20A-66F9-5AE78967A256}"/>
+              </a:ext>
+            </a:extLst>
+          </p:cNvPr>
+          <p:cNvSpPr txBox="1"/>
+          <p:nvPr/>
+        </p:nvSpPr>
+        <p:spPr>
+          <a:xfrm>
+            <a:off x="4227593" y="4623533"/>
+            <a:ext cx="670228" cy="169277"/>
+          </a:xfrm>
+          <a:prstGeom prst="rect">
+            <a:avLst/>
+          </a:prstGeom>
+          <a:noFill/>
+        </p:spPr>
+        <p:txBody>
+          <a:bodyPr wrap="square" lIns="0" tIns="0" rIns="0" bIns="0" rtlCol="0">
+            <a:spAutoFit/>
+          </a:bodyPr>
+          <a:lstStyle>
+            <a:defPPr>
+              <a:defRPr lang="en-US"/>
+            </a:defPPr>
+            <a:lvl1pPr algn="r">
+              <a:defRPr sz="1100" i="1"/>
+            </a:lvl1pPr>
+          </a:lstStyle>
+          <a:p>
+            <a:pPr algn="ctr"/>
+            <a:r>
+              <a:rPr lang="en-US" dirty="0"/>
+              <a:t>HTML + JS</a:t>
+            </a:r>
+          </a:p>
+        </p:txBody>
+      </p:sp>
+      <p:cxnSp>
+        <p:nvCxnSpPr>
+          <p:cNvPr id="195" name="Connector: Elbow 194">
+            <a:extLst>
+              <a:ext uri="{FF2B5EF4-FFF2-40B4-BE49-F238E27FC236}">
+                <a16:creationId xmlns:a16="http://schemas.microsoft.com/office/drawing/2014/main" id="{4174DE66-9A99-EAAD-04F9-7CDF09B37AF9}"/>
+              </a:ext>
+            </a:extLst>
+          </p:cNvPr>
+          <p:cNvCxnSpPr>
+            <a:cxnSpLocks/>
+            <a:stCxn id="57" idx="1"/>
+          </p:cNvCxnSpPr>
+          <p:nvPr/>
+        </p:nvCxnSpPr>
+        <p:spPr>
+          <a:xfrm rot="10800000">
+            <a:off x="3889896" y="3882619"/>
+            <a:ext cx="1007926" cy="941161"/>
+          </a:xfrm>
+          <a:prstGeom prst="bentConnector3">
+            <a:avLst>
+              <a:gd name="adj1" fmla="val 67217"/>
+            </a:avLst>
+          </a:prstGeom>
+          <a:ln w="12700">
+            <a:solidFill>
+              <a:schemeClr val="tx1"/>
+            </a:solidFill>
+            <a:headEnd type="none"/>
+            <a:tailEnd type="arrow"/>
+          </a:ln>
+        </p:spPr>
+        <p:style>
+          <a:lnRef idx="1">
+            <a:schemeClr val="accent1"/>
+          </a:lnRef>
+          <a:fillRef idx="0">
+            <a:schemeClr val="accent1"/>
+          </a:fillRef>
+          <a:effectRef idx="0">
+            <a:schemeClr val="accent1"/>
+          </a:effectRef>
+          <a:fontRef idx="minor">
+            <a:schemeClr val="tx1"/>
+          </a:fontRef>
+        </p:style>
+      </p:cxnSp>
+    </p:spTree>
+    <p:extLst>
+      <p:ext uri="{BB962C8B-B14F-4D97-AF65-F5344CB8AC3E}">
+        <p14:creationId xmlns:p14="http://schemas.microsoft.com/office/powerpoint/2010/main" val="3252050584"/>
+      </p:ext>
+    </p:extLst>
+  </p:cSld>
+  <p:clrMapOvr>
+    <a:masterClrMapping/>
+  </p:clrMapOvr>
+</p:sld>
+</file>
+
+<file path=ppt/slides/slide5.xml><?xml version="1.0" encoding="utf-8"?>
+<p:sld xmlns:a="http://schemas.openxmlformats.org/drawingml/2006/main" xmlns:r="http://schemas.openxmlformats.org/officeDocument/2006/relationships" xmlns:p="http://schemas.openxmlformats.org/presentationml/2006/main">
+  <p:cSld>
+    <p:spTree>
+      <p:nvGrpSpPr>
+        <p:cNvPr id="1" name="">
+          <a:extLst>
+            <a:ext uri="{FF2B5EF4-FFF2-40B4-BE49-F238E27FC236}">
+              <a16:creationId xmlns:a16="http://schemas.microsoft.com/office/drawing/2014/main" id="{0461C334-E282-6245-304B-5E831FC89E80}"/>
+            </a:ext>
+          </a:extLst>
+        </p:cNvPr>
+        <p:cNvGrpSpPr/>
+        <p:nvPr/>
+      </p:nvGrpSpPr>
+      <p:grpSpPr>
+        <a:xfrm>
+          <a:off x="0" y="0"/>
+          <a:ext cx="0" cy="0"/>
+          <a:chOff x="0" y="0"/>
+          <a:chExt cx="0" cy="0"/>
+        </a:xfrm>
+      </p:grpSpPr>
+      <p:sp>
+        <p:nvSpPr>
+          <p:cNvPr id="8" name="Title 1024">
+            <a:extLst>
+              <a:ext uri="{FF2B5EF4-FFF2-40B4-BE49-F238E27FC236}">
+                <a16:creationId xmlns:a16="http://schemas.microsoft.com/office/drawing/2014/main" id="{86579F43-2FFF-68F3-7AD4-CC820DA75A28}"/>
+              </a:ext>
+            </a:extLst>
+          </p:cNvPr>
+          <p:cNvSpPr txBox="1">
+            <a:spLocks/>
+          </p:cNvSpPr>
+          <p:nvPr/>
+        </p:nvSpPr>
+        <p:spPr>
+          <a:xfrm>
+            <a:off x="115734" y="64032"/>
+            <a:ext cx="11304254" cy="476956"/>
+          </a:xfrm>
+          <a:prstGeom prst="rect">
+            <a:avLst/>
+          </a:prstGeom>
+        </p:spPr>
+        <p:txBody>
+          <a:bodyPr vert="horz" lIns="91440" tIns="45720" rIns="91440" bIns="45720" rtlCol="0" anchor="t">
+            <a:noAutofit/>
+          </a:bodyPr>
+          <a:lstStyle>
+            <a:lvl1pPr algn="ctr" defTabSz="914400" rtl="0" eaLnBrk="1" latinLnBrk="0" hangingPunct="1">
+              <a:lnSpc>
+                <a:spcPct val="90000"/>
+              </a:lnSpc>
+              <a:spcBef>
+                <a:spcPct val="0"/>
+              </a:spcBef>
+              <a:buNone/>
+              <a:defRPr sz="6000" kern="1200">
+                <a:solidFill>
+                  <a:schemeClr val="tx1"/>
+                </a:solidFill>
+                <a:latin typeface="+mj-lt"/>
+                <a:ea typeface="+mj-ea"/>
+                <a:cs typeface="+mj-cs"/>
+              </a:defRPr>
+            </a:lvl1pPr>
+          </a:lstStyle>
+          <a:p>
+            <a:pPr algn="l"/>
+            <a:r>
+              <a:rPr lang="en-US" sz="4000" dirty="0"/>
+              <a:t>Web Server Setup + Overview (Development)</a:t>
+            </a:r>
+          </a:p>
+        </p:txBody>
+      </p:sp>
+      <p:pic>
+        <p:nvPicPr>
+          <p:cNvPr id="3" name="Picture 2">
+            <a:extLst>
+              <a:ext uri="{FF2B5EF4-FFF2-40B4-BE49-F238E27FC236}">
+                <a16:creationId xmlns:a16="http://schemas.microsoft.com/office/drawing/2014/main" id="{28E8EDB6-D5B6-9853-B0C8-6B2D6B6118CC}"/>
+              </a:ext>
+            </a:extLst>
+          </p:cNvPr>
+          <p:cNvPicPr>
+            <a:picLocks noChangeAspect="1"/>
+          </p:cNvPicPr>
+          <p:nvPr/>
+        </p:nvPicPr>
+        <p:blipFill>
+          <a:blip r:embed="rId2"/>
+          <a:stretch>
+            <a:fillRect/>
+          </a:stretch>
+        </p:blipFill>
+        <p:spPr>
+          <a:xfrm>
+            <a:off x="2715390" y="826942"/>
+            <a:ext cx="6761220" cy="5600849"/>
+          </a:xfrm>
+          <a:prstGeom prst="rect">
+            <a:avLst/>
+          </a:prstGeom>
+        </p:spPr>
+      </p:pic>
+    </p:spTree>
+    <p:extLst>
+      <p:ext uri="{BB962C8B-B14F-4D97-AF65-F5344CB8AC3E}">
+        <p14:creationId xmlns:p14="http://schemas.microsoft.com/office/powerpoint/2010/main" val="3006188234"/>
       </p:ext>
     </p:extLst>
   </p:cSld>

</xml_diff>